<commit_message>
Codex: Readerplanbeleg und kanonischen Foliensatzstatus aktualisieren
</commit_message>
<xml_diff>
--- a/Presentations/SQL_Server_2025_KI.pptx
+++ b/Presentations/SQL_Server_2025_KI.pptx
@@ -2,46 +2,46 @@
 <file path=ppt/presentation.xml><?xml version="1.0" encoding="utf-8"?>
 <p:presentation xmlns:p="http://schemas.openxmlformats.org/presentationml/2006/main">
   <p:sldMasterIdLst>
-    <p:sldMasterId xmlns:r="http://schemas.openxmlformats.org/officeDocument/2006/relationships" id="2147483648" r:id="R033a4343e5ac4958"/>
+    <p:sldMasterId xmlns:r="http://schemas.openxmlformats.org/officeDocument/2006/relationships" id="2147483648" r:id="R7d116e301e2949a1"/>
   </p:sldMasterIdLst>
   <p:notesMasterIdLst>
-    <p:notesMasterId xmlns:r="http://schemas.openxmlformats.org/officeDocument/2006/relationships" r:id="Rce4844989bda4a0b"/>
+    <p:notesMasterId xmlns:r="http://schemas.openxmlformats.org/officeDocument/2006/relationships" r:id="R4d67bd3a02f342f6"/>
   </p:notesMasterIdLst>
   <p:sldIdLst>
-    <p:sldId xmlns:r="http://schemas.openxmlformats.org/officeDocument/2006/relationships" id="256" r:id="Rd67585d822c34806"/>
-    <p:sldId xmlns:r="http://schemas.openxmlformats.org/officeDocument/2006/relationships" id="257" r:id="Rb204832b50604324"/>
-    <p:sldId xmlns:r="http://schemas.openxmlformats.org/officeDocument/2006/relationships" id="258" r:id="R49643fc0795a49c1"/>
-    <p:sldId xmlns:r="http://schemas.openxmlformats.org/officeDocument/2006/relationships" id="259" r:id="Rfd273602af764790"/>
-    <p:sldId xmlns:r="http://schemas.openxmlformats.org/officeDocument/2006/relationships" id="260" r:id="Ree803eadfaf74147"/>
-    <p:sldId xmlns:r="http://schemas.openxmlformats.org/officeDocument/2006/relationships" id="261" r:id="Rae1f8ccf2f0d4a41"/>
-    <p:sldId xmlns:r="http://schemas.openxmlformats.org/officeDocument/2006/relationships" id="262" r:id="R0d341f56798d4b8c"/>
-    <p:sldId xmlns:r="http://schemas.openxmlformats.org/officeDocument/2006/relationships" id="263" r:id="Rd6064057ebae4e2f"/>
-    <p:sldId xmlns:r="http://schemas.openxmlformats.org/officeDocument/2006/relationships" id="264" r:id="R587b5df30edc422d"/>
-    <p:sldId xmlns:r="http://schemas.openxmlformats.org/officeDocument/2006/relationships" id="265" r:id="R5d7a8c5ab7ce4812"/>
-    <p:sldId xmlns:r="http://schemas.openxmlformats.org/officeDocument/2006/relationships" id="266" r:id="R7db1777a21fe45a9"/>
-    <p:sldId xmlns:r="http://schemas.openxmlformats.org/officeDocument/2006/relationships" id="267" r:id="Rd4d0929dffef478b"/>
-    <p:sldId xmlns:r="http://schemas.openxmlformats.org/officeDocument/2006/relationships" id="268" r:id="Rc1622702e41249d8"/>
-    <p:sldId xmlns:r="http://schemas.openxmlformats.org/officeDocument/2006/relationships" id="269" r:id="Rea303797f9db4d6f"/>
-    <p:sldId xmlns:r="http://schemas.openxmlformats.org/officeDocument/2006/relationships" id="270" r:id="Rdc600b8bda2348c2"/>
-    <p:sldId xmlns:r="http://schemas.openxmlformats.org/officeDocument/2006/relationships" id="271" r:id="Rc4c49fbb021c47a1"/>
-    <p:sldId xmlns:r="http://schemas.openxmlformats.org/officeDocument/2006/relationships" id="272" r:id="R60869fa5660446d8"/>
-    <p:sldId xmlns:r="http://schemas.openxmlformats.org/officeDocument/2006/relationships" id="273" r:id="R7dd0650e9c5c4559"/>
-    <p:sldId xmlns:r="http://schemas.openxmlformats.org/officeDocument/2006/relationships" id="274" r:id="Rc0e12dc20b8a4cb3"/>
-    <p:sldId xmlns:r="http://schemas.openxmlformats.org/officeDocument/2006/relationships" id="275" r:id="Rfb73ffbd03014891"/>
-    <p:sldId xmlns:r="http://schemas.openxmlformats.org/officeDocument/2006/relationships" id="276" r:id="R94940e3101cf4c21"/>
-    <p:sldId xmlns:r="http://schemas.openxmlformats.org/officeDocument/2006/relationships" id="277" r:id="R373e8f5ebe134f17"/>
-    <p:sldId xmlns:r="http://schemas.openxmlformats.org/officeDocument/2006/relationships" id="278" r:id="R4d378abdaf884df7"/>
-    <p:sldId xmlns:r="http://schemas.openxmlformats.org/officeDocument/2006/relationships" id="279" r:id="R9e440774902c41a3"/>
-    <p:sldId xmlns:r="http://schemas.openxmlformats.org/officeDocument/2006/relationships" id="280" r:id="R680221de8b164f59"/>
-    <p:sldId xmlns:r="http://schemas.openxmlformats.org/officeDocument/2006/relationships" id="281" r:id="R010769dc33e6453b"/>
-    <p:sldId xmlns:r="http://schemas.openxmlformats.org/officeDocument/2006/relationships" id="282" r:id="R306805e89dc646c1"/>
-    <p:sldId xmlns:r="http://schemas.openxmlformats.org/officeDocument/2006/relationships" id="283" r:id="Re8009166d4f2417f"/>
-    <p:sldId xmlns:r="http://schemas.openxmlformats.org/officeDocument/2006/relationships" id="284" r:id="R3a229d3efd9147b8"/>
-    <p:sldId xmlns:r="http://schemas.openxmlformats.org/officeDocument/2006/relationships" id="285" r:id="R244ce90cf83a451b"/>
-    <p:sldId xmlns:r="http://schemas.openxmlformats.org/officeDocument/2006/relationships" id="286" r:id="R93b7be85620f4e31"/>
-    <p:sldId xmlns:r="http://schemas.openxmlformats.org/officeDocument/2006/relationships" id="287" r:id="Ra2eaaea2d6104da6"/>
-    <p:sldId xmlns:r="http://schemas.openxmlformats.org/officeDocument/2006/relationships" id="288" r:id="R3d65cc47a46c4e73"/>
-    <p:sldId xmlns:r="http://schemas.openxmlformats.org/officeDocument/2006/relationships" id="289" r:id="R75dfebdeb79c48ce"/>
+    <p:sldId xmlns:r="http://schemas.openxmlformats.org/officeDocument/2006/relationships" id="256" r:id="R4ccb37dfc6414719"/>
+    <p:sldId xmlns:r="http://schemas.openxmlformats.org/officeDocument/2006/relationships" id="257" r:id="Rb1451e28d72b4656"/>
+    <p:sldId xmlns:r="http://schemas.openxmlformats.org/officeDocument/2006/relationships" id="258" r:id="R3722047bd6e940d4"/>
+    <p:sldId xmlns:r="http://schemas.openxmlformats.org/officeDocument/2006/relationships" id="259" r:id="Racca7db4825644ca"/>
+    <p:sldId xmlns:r="http://schemas.openxmlformats.org/officeDocument/2006/relationships" id="260" r:id="R95078e4761344eee"/>
+    <p:sldId xmlns:r="http://schemas.openxmlformats.org/officeDocument/2006/relationships" id="261" r:id="Rf668c00768834fb5"/>
+    <p:sldId xmlns:r="http://schemas.openxmlformats.org/officeDocument/2006/relationships" id="262" r:id="Rfbaf35564d424a36"/>
+    <p:sldId xmlns:r="http://schemas.openxmlformats.org/officeDocument/2006/relationships" id="263" r:id="Rd2a50c39059e46f1"/>
+    <p:sldId xmlns:r="http://schemas.openxmlformats.org/officeDocument/2006/relationships" id="264" r:id="R323f7056a2c2406e"/>
+    <p:sldId xmlns:r="http://schemas.openxmlformats.org/officeDocument/2006/relationships" id="265" r:id="R3ddfb2fe63384746"/>
+    <p:sldId xmlns:r="http://schemas.openxmlformats.org/officeDocument/2006/relationships" id="266" r:id="Rd21d865d796c4074"/>
+    <p:sldId xmlns:r="http://schemas.openxmlformats.org/officeDocument/2006/relationships" id="267" r:id="R97cc7c789f354acf"/>
+    <p:sldId xmlns:r="http://schemas.openxmlformats.org/officeDocument/2006/relationships" id="268" r:id="R5e94ab79873f4732"/>
+    <p:sldId xmlns:r="http://schemas.openxmlformats.org/officeDocument/2006/relationships" id="269" r:id="Rbac1d02ed0434b18"/>
+    <p:sldId xmlns:r="http://schemas.openxmlformats.org/officeDocument/2006/relationships" id="270" r:id="Rafb7cbe17877419e"/>
+    <p:sldId xmlns:r="http://schemas.openxmlformats.org/officeDocument/2006/relationships" id="271" r:id="Rd71964b520c3498b"/>
+    <p:sldId xmlns:r="http://schemas.openxmlformats.org/officeDocument/2006/relationships" id="272" r:id="R9ecf270a8e204edb"/>
+    <p:sldId xmlns:r="http://schemas.openxmlformats.org/officeDocument/2006/relationships" id="273" r:id="R1638b4a95ea34a26"/>
+    <p:sldId xmlns:r="http://schemas.openxmlformats.org/officeDocument/2006/relationships" id="274" r:id="Reefca831a1ab4da4"/>
+    <p:sldId xmlns:r="http://schemas.openxmlformats.org/officeDocument/2006/relationships" id="275" r:id="R78a4bc6132604797"/>
+    <p:sldId xmlns:r="http://schemas.openxmlformats.org/officeDocument/2006/relationships" id="276" r:id="Rb95d2a3f42874151"/>
+    <p:sldId xmlns:r="http://schemas.openxmlformats.org/officeDocument/2006/relationships" id="277" r:id="Ra2d010dc00ac4c1d"/>
+    <p:sldId xmlns:r="http://schemas.openxmlformats.org/officeDocument/2006/relationships" id="278" r:id="R77a8f63223a74d06"/>
+    <p:sldId xmlns:r="http://schemas.openxmlformats.org/officeDocument/2006/relationships" id="279" r:id="Rc9eb146ef0f9484e"/>
+    <p:sldId xmlns:r="http://schemas.openxmlformats.org/officeDocument/2006/relationships" id="280" r:id="Rcac97fa1bf184b72"/>
+    <p:sldId xmlns:r="http://schemas.openxmlformats.org/officeDocument/2006/relationships" id="281" r:id="R39d0a92b2fcb4243"/>
+    <p:sldId xmlns:r="http://schemas.openxmlformats.org/officeDocument/2006/relationships" id="282" r:id="Rf0abc69e7add43ca"/>
+    <p:sldId xmlns:r="http://schemas.openxmlformats.org/officeDocument/2006/relationships" id="283" r:id="Rf877663eea8243be"/>
+    <p:sldId xmlns:r="http://schemas.openxmlformats.org/officeDocument/2006/relationships" id="284" r:id="R04246ab66b684f59"/>
+    <p:sldId xmlns:r="http://schemas.openxmlformats.org/officeDocument/2006/relationships" id="285" r:id="R0d4b991cd2154771"/>
+    <p:sldId xmlns:r="http://schemas.openxmlformats.org/officeDocument/2006/relationships" id="286" r:id="Rb36b2be0842c40e9"/>
+    <p:sldId xmlns:r="http://schemas.openxmlformats.org/officeDocument/2006/relationships" id="287" r:id="Rfd6d765b45054e02"/>
+    <p:sldId xmlns:r="http://schemas.openxmlformats.org/officeDocument/2006/relationships" id="288" r:id="Rc9998d6b73c844c7"/>
+    <p:sldId xmlns:r="http://schemas.openxmlformats.org/officeDocument/2006/relationships" id="289" r:id="Rf751df90e11e4992"/>
   </p:sldIdLst>
   <p:sldSz cx="12192000" cy="6858000"/>
   <p:notesSz cx="6858000" cy="9144000"/>
@@ -4415,7 +4415,7 @@
           <a:lstStyle xmlns:a="http://schemas.openxmlformats.org/drawingml/2006/main"/>
           <a:p xmlns:a="http://schemas.openxmlformats.org/drawingml/2006/main">
             <a:r>
-              <a:t>Besprechen Sie den Vorschlag zuerst ohne einen neuen SQL-Lauf. Die vorhandenen Teilbelege betreffen einen kleinen synthetischen1000-Row-Fall. Einzelne Readernutzung ist kein Actual-Reader-Plan. Repräsentative Ownerpläne übertragen sich nicht automatisch auf den Readerkontext. Der INSERT-Versuch enthält OUTPUT, Roworacles, BEGIN/ROLLBACK und Abwesenheitskontrollen, daher ist seine Batchdauer keine reine INSERT- oder Commitzeit. SYSrequestWrites0 beweist keine Log-I/O-Abwesenheit. Vollständige Build-/DML-/Worker-/Speicherkosten und Nettonutzen bleiben zu qualifizieren. Eine noch nicht integrierte Readerplan-Diagnose liefert dem Deck keinen PASS. Der Transferauftrag fordert den nächsten Versuch, der den behaupteten Lesegewinn widerlegen könnte.</a:t>
+              <a:t>Besprechen Sie den Vorschlag zuerst ohne einen neuen SQL-Lauf. Die vorhandenen Teilbelege betreffen einen kleinen synthetischen 1000-Row-Fall. Zwei private vollständige Original-Readerplanprofile bestätigen inzwischen je den Wechsel Clustered Index Seek auf dem vorhandenen PK, Index Seek auf dem eigenen Candidate und wieder Clustered Index Seek nach dem Abbau. Je Actualplan sind Ergebnisroot 10, Source 10, eine Ausführung und die ursprünglichen Runtimeparameter 101/110 an die echte Readerausführung gebunden. Die zusätzliche Instrumentierung bleibt von bisherigen Performancefenstern getrennt. Diese begrenzte Beobachtung bestätigt keinen Indexnettonutzen. Der INSERT-Versuch enthält OUTPUT, Roworacles, BEGIN/ROLLBACK und Abwesenheitskontrollen, daher ist seine Batchdauer keine reine INSERT- oder Commitzeit. SYSrequestWrites 0 beweist keine Log-I/O-Abwesenheit. Vollständige Runtime-/TP-PERF-, Build-/DML-/Worker-/Speicherkosten und Nettonutzen bleiben zu qualifizieren. Quellenstand dieser neuen Readerplanaussage: main 4bfb1914623c3c49fcc287ee8079013a0fad6ddb, 2026-10-12. Der Transferauftrag fordert den nächsten Versuch, der den behaupteten Lesegewinn widerlegen könnte.</a:t>
             </a:r>
           </a:p>
           <a:p xmlns:a="http://schemas.openxmlformats.org/drawingml/2006/main">
@@ -4496,6 +4496,16 @@
           <a:p xmlns:a="http://schemas.openxmlformats.org/drawingml/2006/main">
             <a:r>
               <a:t>Projektquelle: Documentation/Project_Planning/SQL_SERVER_2025_AI_DGN010_INSERT_REVIEW.md</a:t>
+            </a:r>
+          </a:p>
+          <a:p xmlns:a="http://schemas.openxmlformats.org/drawingml/2006/main">
+            <a:r>
+              <a:t/>
+            </a:r>
+          </a:p>
+          <a:p xmlns:a="http://schemas.openxmlformats.org/drawingml/2006/main">
+            <a:r>
+              <a:t>Projektquelle: Documentation/Project_Planning/SQL_SERVER_2025_AI_DGN010_READER_CLOCK_REVIEW.md</a:t>
             </a:r>
           </a:p>
           <a:p xmlns:a="http://schemas.openxmlformats.org/drawingml/2006/main">
@@ -5992,7 +6002,7 @@
           <p:cNvPr id="3" name="Title">
             <a:extLst xmlns:a="http://schemas.openxmlformats.org/drawingml/2006/main">
               <a:ext uri="{FF2B5EF4-FFF2-40B4-BE49-F238E27FC236}">
-                <a16:creationId xmlns:a16="http://schemas.microsoft.com/office/drawing/2014/main" id="{435EEA4A-6F87-45A7-8E39-DDB15F627483}"/>
+                <a16:creationId xmlns:a16="http://schemas.microsoft.com/office/drawing/2014/main" id="{8E5AE035-4201-4454-A392-D63BCDA7F50B}"/>
               </a:ext>
             </a:extLst>
           </p:cNvPr>
@@ -6149,7 +6159,7 @@
           <p:cNvPr id="2" name="Subtitle">
             <a:extLst xmlns:a="http://schemas.openxmlformats.org/drawingml/2006/main">
               <a:ext uri="{FF2B5EF4-FFF2-40B4-BE49-F238E27FC236}">
-                <a16:creationId xmlns:a16="http://schemas.microsoft.com/office/drawing/2014/main" id="{0C745854-EE48-4D1D-9194-6496286D1224}"/>
+                <a16:creationId xmlns:a16="http://schemas.microsoft.com/office/drawing/2014/main" id="{8C2A5314-2FBB-4C68-8884-1F56D11B00F7}"/>
               </a:ext>
             </a:extLst>
           </p:cNvPr>
@@ -6323,7 +6333,7 @@
           <p:cNvPr id="2" name="Section title">
             <a:extLst xmlns:a="http://schemas.openxmlformats.org/drawingml/2006/main">
               <a:ext uri="{FF2B5EF4-FFF2-40B4-BE49-F238E27FC236}">
-                <a16:creationId xmlns:a16="http://schemas.microsoft.com/office/drawing/2014/main" id="{99AFAB33-CAA6-4DAF-8FBD-72FF5AE40A7D}"/>
+                <a16:creationId xmlns:a16="http://schemas.microsoft.com/office/drawing/2014/main" id="{2E59181D-825F-4B42-9EB4-8E07109D7B5A}"/>
               </a:ext>
             </a:extLst>
           </p:cNvPr>
@@ -6497,7 +6507,7 @@
           <p:cNvPr id="3" name="Title">
             <a:extLst xmlns:a="http://schemas.openxmlformats.org/drawingml/2006/main">
               <a:ext uri="{FF2B5EF4-FFF2-40B4-BE49-F238E27FC236}">
-                <a16:creationId xmlns:a16="http://schemas.microsoft.com/office/drawing/2014/main" id="{C404B8D5-611B-4771-A20D-CF15C8805B30}"/>
+                <a16:creationId xmlns:a16="http://schemas.microsoft.com/office/drawing/2014/main" id="{1300F7AB-DEBF-4255-8CA7-E9635ACDA9CE}"/>
               </a:ext>
             </a:extLst>
           </p:cNvPr>
@@ -6654,7 +6664,7 @@
           <p:cNvPr id="2" name="Body">
             <a:extLst xmlns:a="http://schemas.openxmlformats.org/drawingml/2006/main">
               <a:ext uri="{FF2B5EF4-FFF2-40B4-BE49-F238E27FC236}">
-                <a16:creationId xmlns:a16="http://schemas.microsoft.com/office/drawing/2014/main" id="{FE3EF41E-A503-4F6B-907D-F215150D523D}"/>
+                <a16:creationId xmlns:a16="http://schemas.microsoft.com/office/drawing/2014/main" id="{4D4E6D34-B226-4421-8CC4-09029ABEA0F0}"/>
               </a:ext>
             </a:extLst>
           </p:cNvPr>
@@ -6828,7 +6838,7 @@
           <p:cNvPr id="4" name="Title">
             <a:extLst xmlns:a="http://schemas.openxmlformats.org/drawingml/2006/main">
               <a:ext uri="{FF2B5EF4-FFF2-40B4-BE49-F238E27FC236}">
-                <a16:creationId xmlns:a16="http://schemas.microsoft.com/office/drawing/2014/main" id="{D958A62C-C573-461F-BE22-A040D2CB3243}"/>
+                <a16:creationId xmlns:a16="http://schemas.microsoft.com/office/drawing/2014/main" id="{147A1C4C-B560-4289-8C14-F400FEC15003}"/>
               </a:ext>
             </a:extLst>
           </p:cNvPr>
@@ -6985,7 +6995,7 @@
           <p:cNvPr id="2" name="Left column">
             <a:extLst xmlns:a="http://schemas.openxmlformats.org/drawingml/2006/main">
               <a:ext uri="{FF2B5EF4-FFF2-40B4-BE49-F238E27FC236}">
-                <a16:creationId xmlns:a16="http://schemas.microsoft.com/office/drawing/2014/main" id="{F2CE8DD8-1F2F-4C73-A429-045B6BCA1DB7}"/>
+                <a16:creationId xmlns:a16="http://schemas.microsoft.com/office/drawing/2014/main" id="{CC06429E-1EE9-4215-826D-BF9FB7B9186A}"/>
               </a:ext>
             </a:extLst>
           </p:cNvPr>
@@ -7142,7 +7152,7 @@
           <p:cNvPr id="3" name="Right column">
             <a:extLst xmlns:a="http://schemas.openxmlformats.org/drawingml/2006/main">
               <a:ext uri="{FF2B5EF4-FFF2-40B4-BE49-F238E27FC236}">
-                <a16:creationId xmlns:a16="http://schemas.microsoft.com/office/drawing/2014/main" id="{376DD0F4-814F-4A86-9D4F-2E22076594D0}"/>
+                <a16:creationId xmlns:a16="http://schemas.microsoft.com/office/drawing/2014/main" id="{D2F076B8-6321-41A2-AE70-663508F21187}"/>
               </a:ext>
             </a:extLst>
           </p:cNvPr>
@@ -7316,7 +7326,7 @@
           <p:cNvPr id="3" name="Title">
             <a:extLst xmlns:a="http://schemas.openxmlformats.org/drawingml/2006/main">
               <a:ext uri="{FF2B5EF4-FFF2-40B4-BE49-F238E27FC236}">
-                <a16:creationId xmlns:a16="http://schemas.microsoft.com/office/drawing/2014/main" id="{B1D21178-2084-4F09-807E-7E5A298DEEAF}"/>
+                <a16:creationId xmlns:a16="http://schemas.microsoft.com/office/drawing/2014/main" id="{644AC5C0-935B-4751-9CF8-3DC68BFC7BF3}"/>
               </a:ext>
             </a:extLst>
           </p:cNvPr>
@@ -7473,7 +7483,7 @@
           <p:cNvPr id="2" name="Left column">
             <a:extLst xmlns:a="http://schemas.openxmlformats.org/drawingml/2006/main">
               <a:ext uri="{FF2B5EF4-FFF2-40B4-BE49-F238E27FC236}">
-                <a16:creationId xmlns:a16="http://schemas.microsoft.com/office/drawing/2014/main" id="{49B70776-2BEE-4B0A-BB61-A2CDCC4EAA20}"/>
+                <a16:creationId xmlns:a16="http://schemas.microsoft.com/office/drawing/2014/main" id="{034CE504-1E88-47B6-A0FC-905731ABC9CF}"/>
               </a:ext>
             </a:extLst>
           </p:cNvPr>
@@ -7668,12 +7678,12 @@
   </p:cSld>
   <p:clrMap bg1="lt1" tx1="dk1" bg2="lt2" tx2="dk2" accent1="accent1" accent2="accent2" accent3="accent3" accent4="accent4" accent5="accent5" accent6="accent6" hlink="hlink" folHlink="folHlink"/>
   <p:sldLayoutIdLst>
-    <p:sldLayoutId xmlns:r="http://schemas.openxmlformats.org/officeDocument/2006/relationships" id="2147483649" r:id="Rf7edf7b009634cff"/>
-    <p:sldLayoutId xmlns:r="http://schemas.openxmlformats.org/officeDocument/2006/relationships" id="2147483650" r:id="R6cad8206e80c48a2"/>
-    <p:sldLayoutId xmlns:r="http://schemas.openxmlformats.org/officeDocument/2006/relationships" id="2147483651" r:id="R8e0e1d982d444abf"/>
-    <p:sldLayoutId xmlns:r="http://schemas.openxmlformats.org/officeDocument/2006/relationships" id="2147483652" r:id="R178bd502a43b4396"/>
-    <p:sldLayoutId xmlns:r="http://schemas.openxmlformats.org/officeDocument/2006/relationships" id="2147483653" r:id="Rd1819224aa0c46f0"/>
-    <p:sldLayoutId xmlns:r="http://schemas.openxmlformats.org/officeDocument/2006/relationships" id="2147483654" r:id="R02d92f7551774ce1"/>
+    <p:sldLayoutId xmlns:r="http://schemas.openxmlformats.org/officeDocument/2006/relationships" id="2147483649" r:id="Rb33f65535099467f"/>
+    <p:sldLayoutId xmlns:r="http://schemas.openxmlformats.org/officeDocument/2006/relationships" id="2147483650" r:id="Rf0e5c3dcb27540fa"/>
+    <p:sldLayoutId xmlns:r="http://schemas.openxmlformats.org/officeDocument/2006/relationships" id="2147483651" r:id="Ra0db818df0784a7a"/>
+    <p:sldLayoutId xmlns:r="http://schemas.openxmlformats.org/officeDocument/2006/relationships" id="2147483652" r:id="Rb697737295f3413f"/>
+    <p:sldLayoutId xmlns:r="http://schemas.openxmlformats.org/officeDocument/2006/relationships" id="2147483653" r:id="R79459adc954d4fbb"/>
+    <p:sldLayoutId xmlns:r="http://schemas.openxmlformats.org/officeDocument/2006/relationships" id="2147483654" r:id="R850d89253dfc44cb"/>
   </p:sldLayoutIdLst>
   <p:txStyles>
     <p:titleStyle>
@@ -8224,7 +8234,7 @@
           <p:cNvPr id="4" name="text-0">
             <a:extLst xmlns:a="http://schemas.openxmlformats.org/drawingml/2006/main">
               <a:ext uri="{FF2B5EF4-FFF2-40B4-BE49-F238E27FC236}">
-                <a16:creationId xmlns:a16="http://schemas.microsoft.com/office/drawing/2014/main" id="{E30D98DF-92BF-448F-8FF2-5AEBC872F85C}"/>
+                <a16:creationId xmlns:a16="http://schemas.microsoft.com/office/drawing/2014/main" id="{DF459D8A-33E3-4805-947A-A3F6670304B9}"/>
               </a:ext>
             </a:extLst>
           </p:cNvPr>
@@ -8313,7 +8323,7 @@
           <p:cNvPr id="2" name="text-1">
             <a:extLst xmlns:a="http://schemas.openxmlformats.org/drawingml/2006/main">
               <a:ext uri="{FF2B5EF4-FFF2-40B4-BE49-F238E27FC236}">
-                <a16:creationId xmlns:a16="http://schemas.microsoft.com/office/drawing/2014/main" id="{94E8C8EF-24DA-4FF6-B67F-3FD3B33DF3E1}"/>
+                <a16:creationId xmlns:a16="http://schemas.microsoft.com/office/drawing/2014/main" id="{6EC1AFC6-AD81-46BE-BAD4-3F08F6A52B82}"/>
               </a:ext>
             </a:extLst>
           </p:cNvPr>
@@ -8379,7 +8389,7 @@
           <p:cNvPr id="3" name="text-2">
             <a:extLst xmlns:a="http://schemas.openxmlformats.org/drawingml/2006/main">
               <a:ext uri="{FF2B5EF4-FFF2-40B4-BE49-F238E27FC236}">
-                <a16:creationId xmlns:a16="http://schemas.microsoft.com/office/drawing/2014/main" id="{D603A914-3F25-4FFC-AC4A-9290EB8ACC36}"/>
+                <a16:creationId xmlns:a16="http://schemas.microsoft.com/office/drawing/2014/main" id="{277F7DB0-BB35-4986-A87D-705AF34131C3}"/>
               </a:ext>
             </a:extLst>
           </p:cNvPr>
@@ -8443,7 +8453,7 @@
     </p:spTree>
     <p:extLst>
       <p:ext uri="{BB962C8B-B14F-4D97-AF65-F5344CB8AC3E}">
-        <p14:creationId xmlns:p14="http://schemas.microsoft.com/office/powerpoint/2010/main" val="1491751944"/>
+        <p14:creationId xmlns:p14="http://schemas.microsoft.com/office/powerpoint/2010/main" val="1884918879"/>
       </p:ext>
     </p:extLst>
   </p:cSld>
@@ -8474,7 +8484,7 @@
           <p:cNvPr id="9" name="text-0">
             <a:extLst xmlns:a="http://schemas.openxmlformats.org/drawingml/2006/main">
               <a:ext uri="{FF2B5EF4-FFF2-40B4-BE49-F238E27FC236}">
-                <a16:creationId xmlns:a16="http://schemas.microsoft.com/office/drawing/2014/main" id="{73F05244-65B6-4225-A1E7-20FA4FC3CC44}"/>
+                <a16:creationId xmlns:a16="http://schemas.microsoft.com/office/drawing/2014/main" id="{0D184321-FDDA-4743-9279-FF9DB70CAC00}"/>
               </a:ext>
             </a:extLst>
           </p:cNvPr>
@@ -8540,7 +8550,7 @@
           <p:cNvPr id="2" name="text-1">
             <a:extLst xmlns:a="http://schemas.openxmlformats.org/drawingml/2006/main">
               <a:ext uri="{FF2B5EF4-FFF2-40B4-BE49-F238E27FC236}">
-                <a16:creationId xmlns:a16="http://schemas.microsoft.com/office/drawing/2014/main" id="{1E62148A-4A03-4E79-8F8E-DB35ACE6E35C}"/>
+                <a16:creationId xmlns:a16="http://schemas.microsoft.com/office/drawing/2014/main" id="{C2E3450A-AA4B-482A-9228-C8ECA2F2D5F3}"/>
               </a:ext>
             </a:extLst>
           </p:cNvPr>
@@ -8675,7 +8685,7 @@
           <p:cNvPr id="3" name="text-2">
             <a:extLst xmlns:a="http://schemas.openxmlformats.org/drawingml/2006/main">
               <a:ext uri="{FF2B5EF4-FFF2-40B4-BE49-F238E27FC236}">
-                <a16:creationId xmlns:a16="http://schemas.microsoft.com/office/drawing/2014/main" id="{B804ABF8-8167-4A94-BDFC-8BB26E4873B8}"/>
+                <a16:creationId xmlns:a16="http://schemas.microsoft.com/office/drawing/2014/main" id="{47AFC7F4-E8BD-4673-9F82-F7ACB09350BD}"/>
               </a:ext>
             </a:extLst>
           </p:cNvPr>
@@ -8741,7 +8751,7 @@
           <p:cNvPr id="4" name="text-3">
             <a:extLst xmlns:a="http://schemas.openxmlformats.org/drawingml/2006/main">
               <a:ext uri="{FF2B5EF4-FFF2-40B4-BE49-F238E27FC236}">
-                <a16:creationId xmlns:a16="http://schemas.microsoft.com/office/drawing/2014/main" id="{89FC7616-E5C7-41C9-B4F7-5F7CDD27F13A}"/>
+                <a16:creationId xmlns:a16="http://schemas.microsoft.com/office/drawing/2014/main" id="{FFC53265-1F48-4B1F-AA91-BEF6B214BD5D}"/>
               </a:ext>
             </a:extLst>
           </p:cNvPr>
@@ -8807,7 +8817,7 @@
           <p:cNvPr id="5" name="text-4">
             <a:extLst xmlns:a="http://schemas.openxmlformats.org/drawingml/2006/main">
               <a:ext uri="{FF2B5EF4-FFF2-40B4-BE49-F238E27FC236}">
-                <a16:creationId xmlns:a16="http://schemas.microsoft.com/office/drawing/2014/main" id="{85AD9E89-AF01-4228-8A85-F1C5F2C7218A}"/>
+                <a16:creationId xmlns:a16="http://schemas.microsoft.com/office/drawing/2014/main" id="{7FE0EA2B-04CA-47E1-AAF1-077AAF64D846}"/>
               </a:ext>
             </a:extLst>
           </p:cNvPr>
@@ -8873,7 +8883,7 @@
           <p:cNvPr id="6" name="text-5">
             <a:extLst xmlns:a="http://schemas.openxmlformats.org/drawingml/2006/main">
               <a:ext uri="{FF2B5EF4-FFF2-40B4-BE49-F238E27FC236}">
-                <a16:creationId xmlns:a16="http://schemas.microsoft.com/office/drawing/2014/main" id="{0563A0AA-E859-4AF4-BDAD-4B90024602A3}"/>
+                <a16:creationId xmlns:a16="http://schemas.microsoft.com/office/drawing/2014/main" id="{777D763C-0433-4950-86F5-8B6DDEDA244C}"/>
               </a:ext>
             </a:extLst>
           </p:cNvPr>
@@ -8939,7 +8949,7 @@
           <p:cNvPr id="7" name="text-6">
             <a:extLst xmlns:a="http://schemas.openxmlformats.org/drawingml/2006/main">
               <a:ext uri="{FF2B5EF4-FFF2-40B4-BE49-F238E27FC236}">
-                <a16:creationId xmlns:a16="http://schemas.microsoft.com/office/drawing/2014/main" id="{C6BCB3D3-2C0D-4E0A-9ACA-09CF6C51167C}"/>
+                <a16:creationId xmlns:a16="http://schemas.microsoft.com/office/drawing/2014/main" id="{4C7C9C4C-AF95-46BD-8991-CDA2B35C0382}"/>
               </a:ext>
             </a:extLst>
           </p:cNvPr>
@@ -9005,7 +9015,7 @@
           <p:cNvPr id="8" name="text-7">
             <a:extLst xmlns:a="http://schemas.openxmlformats.org/drawingml/2006/main">
               <a:ext uri="{FF2B5EF4-FFF2-40B4-BE49-F238E27FC236}">
-                <a16:creationId xmlns:a16="http://schemas.microsoft.com/office/drawing/2014/main" id="{81B9D149-FA35-4216-8896-6F581372228F}"/>
+                <a16:creationId xmlns:a16="http://schemas.microsoft.com/office/drawing/2014/main" id="{01D84ECC-9A6E-437F-948E-87D46AD01A14}"/>
               </a:ext>
             </a:extLst>
           </p:cNvPr>
@@ -9069,7 +9079,7 @@
     </p:spTree>
     <p:extLst>
       <p:ext uri="{BB962C8B-B14F-4D97-AF65-F5344CB8AC3E}">
-        <p14:creationId xmlns:p14="http://schemas.microsoft.com/office/powerpoint/2010/main" val="1823878151"/>
+        <p14:creationId xmlns:p14="http://schemas.microsoft.com/office/powerpoint/2010/main" val="1847281255"/>
       </p:ext>
     </p:extLst>
   </p:cSld>
@@ -9100,7 +9110,7 @@
           <p:cNvPr id="9" name="text-0">
             <a:extLst xmlns:a="http://schemas.openxmlformats.org/drawingml/2006/main">
               <a:ext uri="{FF2B5EF4-FFF2-40B4-BE49-F238E27FC236}">
-                <a16:creationId xmlns:a16="http://schemas.microsoft.com/office/drawing/2014/main" id="{21B52D52-A0F4-4855-91DB-A2997A1F5184}"/>
+                <a16:creationId xmlns:a16="http://schemas.microsoft.com/office/drawing/2014/main" id="{BAF76B6B-9D6A-4E46-B177-1CF2CBB38813}"/>
               </a:ext>
             </a:extLst>
           </p:cNvPr>
@@ -9166,7 +9176,7 @@
           <p:cNvPr id="2" name="text-1">
             <a:extLst xmlns:a="http://schemas.openxmlformats.org/drawingml/2006/main">
               <a:ext uri="{FF2B5EF4-FFF2-40B4-BE49-F238E27FC236}">
-                <a16:creationId xmlns:a16="http://schemas.microsoft.com/office/drawing/2014/main" id="{FCCA5FD2-330D-430F-B62A-9F5D96E4DFD7}"/>
+                <a16:creationId xmlns:a16="http://schemas.microsoft.com/office/drawing/2014/main" id="{2A79E4BB-EA4E-423E-AA27-FCCC4D3CC64E}"/>
               </a:ext>
             </a:extLst>
           </p:cNvPr>
@@ -9232,7 +9242,7 @@
           <p:cNvPr id="3" name="text-2">
             <a:extLst xmlns:a="http://schemas.openxmlformats.org/drawingml/2006/main">
               <a:ext uri="{FF2B5EF4-FFF2-40B4-BE49-F238E27FC236}">
-                <a16:creationId xmlns:a16="http://schemas.microsoft.com/office/drawing/2014/main" id="{42AAA02F-59A3-425D-9EEB-213CD44384A3}"/>
+                <a16:creationId xmlns:a16="http://schemas.microsoft.com/office/drawing/2014/main" id="{45082AE7-0D1F-4FF5-A5FD-429AA0BF2E89}"/>
               </a:ext>
             </a:extLst>
           </p:cNvPr>
@@ -9298,7 +9308,7 @@
           <p:cNvPr id="4" name="text-3">
             <a:extLst xmlns:a="http://schemas.openxmlformats.org/drawingml/2006/main">
               <a:ext uri="{FF2B5EF4-FFF2-40B4-BE49-F238E27FC236}">
-                <a16:creationId xmlns:a16="http://schemas.microsoft.com/office/drawing/2014/main" id="{EF589CAF-4659-416E-B755-547F78AC3650}"/>
+                <a16:creationId xmlns:a16="http://schemas.microsoft.com/office/drawing/2014/main" id="{12CA0D16-7ED8-4E05-AAA0-0CA3D525478B}"/>
               </a:ext>
             </a:extLst>
           </p:cNvPr>
@@ -9364,7 +9374,7 @@
           <p:cNvPr id="5" name="text-4">
             <a:extLst xmlns:a="http://schemas.openxmlformats.org/drawingml/2006/main">
               <a:ext uri="{FF2B5EF4-FFF2-40B4-BE49-F238E27FC236}">
-                <a16:creationId xmlns:a16="http://schemas.microsoft.com/office/drawing/2014/main" id="{527C65CD-4F1D-4AAC-B58E-A1AD7565DDAB}"/>
+                <a16:creationId xmlns:a16="http://schemas.microsoft.com/office/drawing/2014/main" id="{BE2673D6-6042-46F8-8822-171476CF0E8D}"/>
               </a:ext>
             </a:extLst>
           </p:cNvPr>
@@ -9430,7 +9440,7 @@
           <p:cNvPr id="6" name="text-5">
             <a:extLst xmlns:a="http://schemas.openxmlformats.org/drawingml/2006/main">
               <a:ext uri="{FF2B5EF4-FFF2-40B4-BE49-F238E27FC236}">
-                <a16:creationId xmlns:a16="http://schemas.microsoft.com/office/drawing/2014/main" id="{46D249D2-180F-4189-B3ED-5D77346540A4}"/>
+                <a16:creationId xmlns:a16="http://schemas.microsoft.com/office/drawing/2014/main" id="{D8B63F61-4844-41BA-9168-3D70C4441DBC}"/>
               </a:ext>
             </a:extLst>
           </p:cNvPr>
@@ -9496,7 +9506,7 @@
           <p:cNvPr id="7" name="text-6">
             <a:extLst xmlns:a="http://schemas.openxmlformats.org/drawingml/2006/main">
               <a:ext uri="{FF2B5EF4-FFF2-40B4-BE49-F238E27FC236}">
-                <a16:creationId xmlns:a16="http://schemas.microsoft.com/office/drawing/2014/main" id="{41CFB131-2981-45B3-936A-37CE9DBFD4B0}"/>
+                <a16:creationId xmlns:a16="http://schemas.microsoft.com/office/drawing/2014/main" id="{5CB617A2-1630-4EE1-B726-728FB618B0F1}"/>
               </a:ext>
             </a:extLst>
           </p:cNvPr>
@@ -9562,7 +9572,7 @@
           <p:cNvPr id="8" name="text-7">
             <a:extLst xmlns:a="http://schemas.openxmlformats.org/drawingml/2006/main">
               <a:ext uri="{FF2B5EF4-FFF2-40B4-BE49-F238E27FC236}">
-                <a16:creationId xmlns:a16="http://schemas.microsoft.com/office/drawing/2014/main" id="{0A2E4AFA-7CAB-469B-8891-313FE279BB0E}"/>
+                <a16:creationId xmlns:a16="http://schemas.microsoft.com/office/drawing/2014/main" id="{CD150ED4-8E7D-4AD8-B7F1-D1C3DD9273A3}"/>
               </a:ext>
             </a:extLst>
           </p:cNvPr>
@@ -9626,7 +9636,7 @@
     </p:spTree>
     <p:extLst>
       <p:ext uri="{BB962C8B-B14F-4D97-AF65-F5344CB8AC3E}">
-        <p14:creationId xmlns:p14="http://schemas.microsoft.com/office/powerpoint/2010/main" val="1951855294"/>
+        <p14:creationId xmlns:p14="http://schemas.microsoft.com/office/powerpoint/2010/main" val="2006953075"/>
       </p:ext>
     </p:extLst>
   </p:cSld>
@@ -9657,7 +9667,7 @@
           <p:cNvPr id="10" name="text-0">
             <a:extLst xmlns:a="http://schemas.openxmlformats.org/drawingml/2006/main">
               <a:ext uri="{FF2B5EF4-FFF2-40B4-BE49-F238E27FC236}">
-                <a16:creationId xmlns:a16="http://schemas.microsoft.com/office/drawing/2014/main" id="{4B18F2D0-434A-4CC7-8BDE-DC9E3A8E849E}"/>
+                <a16:creationId xmlns:a16="http://schemas.microsoft.com/office/drawing/2014/main" id="{BCE28744-BC3E-462D-8648-279C3480F16F}"/>
               </a:ext>
             </a:extLst>
           </p:cNvPr>
@@ -9723,7 +9733,7 @@
           <p:cNvPr id="2" name="text-1">
             <a:extLst xmlns:a="http://schemas.openxmlformats.org/drawingml/2006/main">
               <a:ext uri="{FF2B5EF4-FFF2-40B4-BE49-F238E27FC236}">
-                <a16:creationId xmlns:a16="http://schemas.microsoft.com/office/drawing/2014/main" id="{64826640-3DCC-4456-B244-295ECD342643}"/>
+                <a16:creationId xmlns:a16="http://schemas.microsoft.com/office/drawing/2014/main" id="{8A5509CF-F966-4377-9B47-1998F24AABC7}"/>
               </a:ext>
             </a:extLst>
           </p:cNvPr>
@@ -9789,7 +9799,7 @@
           <p:cNvPr id="3" name="text-2">
             <a:extLst xmlns:a="http://schemas.openxmlformats.org/drawingml/2006/main">
               <a:ext uri="{FF2B5EF4-FFF2-40B4-BE49-F238E27FC236}">
-                <a16:creationId xmlns:a16="http://schemas.microsoft.com/office/drawing/2014/main" id="{BA19B3A8-A56B-41A2-B7F7-64D1DBC348C8}"/>
+                <a16:creationId xmlns:a16="http://schemas.microsoft.com/office/drawing/2014/main" id="{7B4800F6-F413-4C4C-BEBA-C19F1F53B0FD}"/>
               </a:ext>
             </a:extLst>
           </p:cNvPr>
@@ -9855,7 +9865,7 @@
           <p:cNvPr id="4" name="text-3">
             <a:extLst xmlns:a="http://schemas.openxmlformats.org/drawingml/2006/main">
               <a:ext uri="{FF2B5EF4-FFF2-40B4-BE49-F238E27FC236}">
-                <a16:creationId xmlns:a16="http://schemas.microsoft.com/office/drawing/2014/main" id="{966775E8-E421-41A5-A56C-F72C59753E6B}"/>
+                <a16:creationId xmlns:a16="http://schemas.microsoft.com/office/drawing/2014/main" id="{B4933C99-141A-4913-9820-8E7A639EF984}"/>
               </a:ext>
             </a:extLst>
           </p:cNvPr>
@@ -9921,7 +9931,7 @@
           <p:cNvPr id="5" name="text-4">
             <a:extLst xmlns:a="http://schemas.openxmlformats.org/drawingml/2006/main">
               <a:ext uri="{FF2B5EF4-FFF2-40B4-BE49-F238E27FC236}">
-                <a16:creationId xmlns:a16="http://schemas.microsoft.com/office/drawing/2014/main" id="{FDB101FE-6F32-4C8E-A4EC-4DD0C83327DB}"/>
+                <a16:creationId xmlns:a16="http://schemas.microsoft.com/office/drawing/2014/main" id="{FB5F3033-6CC1-4928-B290-121CC65AB924}"/>
               </a:ext>
             </a:extLst>
           </p:cNvPr>
@@ -9987,7 +9997,7 @@
           <p:cNvPr id="6" name="text-5">
             <a:extLst xmlns:a="http://schemas.openxmlformats.org/drawingml/2006/main">
               <a:ext uri="{FF2B5EF4-FFF2-40B4-BE49-F238E27FC236}">
-                <a16:creationId xmlns:a16="http://schemas.microsoft.com/office/drawing/2014/main" id="{7D23F05D-E6EB-424E-9E61-F02192AE29E7}"/>
+                <a16:creationId xmlns:a16="http://schemas.microsoft.com/office/drawing/2014/main" id="{B489D29B-9EB7-451C-A5A2-93B304831AD2}"/>
               </a:ext>
             </a:extLst>
           </p:cNvPr>
@@ -10053,7 +10063,7 @@
           <p:cNvPr id="7" name="text-6">
             <a:extLst xmlns:a="http://schemas.openxmlformats.org/drawingml/2006/main">
               <a:ext uri="{FF2B5EF4-FFF2-40B4-BE49-F238E27FC236}">
-                <a16:creationId xmlns:a16="http://schemas.microsoft.com/office/drawing/2014/main" id="{E6ADE6C4-451B-49CC-BD26-5123A14CB8BC}"/>
+                <a16:creationId xmlns:a16="http://schemas.microsoft.com/office/drawing/2014/main" id="{65B863FF-CB2E-40D2-9062-8DD39C7914FD}"/>
               </a:ext>
             </a:extLst>
           </p:cNvPr>
@@ -10119,7 +10129,7 @@
           <p:cNvPr id="8" name="text-7">
             <a:extLst xmlns:a="http://schemas.openxmlformats.org/drawingml/2006/main">
               <a:ext uri="{FF2B5EF4-FFF2-40B4-BE49-F238E27FC236}">
-                <a16:creationId xmlns:a16="http://schemas.microsoft.com/office/drawing/2014/main" id="{E558B5DF-5D0F-4ED7-881D-EBC0DDE80945}"/>
+                <a16:creationId xmlns:a16="http://schemas.microsoft.com/office/drawing/2014/main" id="{BFB39E9D-3480-4FD3-937D-DF4010224808}"/>
               </a:ext>
             </a:extLst>
           </p:cNvPr>
@@ -10185,7 +10195,7 @@
           <p:cNvPr id="9" name="text-8">
             <a:extLst xmlns:a="http://schemas.openxmlformats.org/drawingml/2006/main">
               <a:ext uri="{FF2B5EF4-FFF2-40B4-BE49-F238E27FC236}">
-                <a16:creationId xmlns:a16="http://schemas.microsoft.com/office/drawing/2014/main" id="{88E00DFD-3889-4AFE-ABEE-378C378AD308}"/>
+                <a16:creationId xmlns:a16="http://schemas.microsoft.com/office/drawing/2014/main" id="{D09E2532-AF66-4E64-AA35-BB894E5CDA63}"/>
               </a:ext>
             </a:extLst>
           </p:cNvPr>
@@ -10249,7 +10259,7 @@
     </p:spTree>
     <p:extLst>
       <p:ext uri="{BB962C8B-B14F-4D97-AF65-F5344CB8AC3E}">
-        <p14:creationId xmlns:p14="http://schemas.microsoft.com/office/powerpoint/2010/main" val="691858019"/>
+        <p14:creationId xmlns:p14="http://schemas.microsoft.com/office/powerpoint/2010/main" val="1672454899"/>
       </p:ext>
     </p:extLst>
   </p:cSld>
@@ -10280,7 +10290,7 @@
           <p:cNvPr id="4" name="text-0">
             <a:extLst xmlns:a="http://schemas.openxmlformats.org/drawingml/2006/main">
               <a:ext uri="{FF2B5EF4-FFF2-40B4-BE49-F238E27FC236}">
-                <a16:creationId xmlns:a16="http://schemas.microsoft.com/office/drawing/2014/main" id="{07F6856A-F1D6-41D9-AC99-B28400213EF0}"/>
+                <a16:creationId xmlns:a16="http://schemas.microsoft.com/office/drawing/2014/main" id="{4A4F6482-C89D-4BE5-8A85-B49ECC54EB9F}"/>
               </a:ext>
             </a:extLst>
           </p:cNvPr>
@@ -10346,7 +10356,7 @@
           <p:cNvPr id="2" name="">
             <a:extLst xmlns:a="http://schemas.openxmlformats.org/drawingml/2006/main">
               <a:ext uri="{FF2B5EF4-FFF2-40B4-BE49-F238E27FC236}">
-                <a16:creationId xmlns:a16="http://schemas.microsoft.com/office/drawing/2014/main" id="{8DF35672-90FE-48D2-9794-4B15B22C4576}"/>
+                <a16:creationId xmlns:a16="http://schemas.microsoft.com/office/drawing/2014/main" id="{FEB8BBCD-D251-48DD-AE88-54B38AA993D8}"/>
               </a:ext>
             </a:extLst>
           </p:cNvPr>
@@ -10745,7 +10755,7 @@
           <p:cNvPr id="3" name="text-1">
             <a:extLst xmlns:a="http://schemas.openxmlformats.org/drawingml/2006/main">
               <a:ext uri="{FF2B5EF4-FFF2-40B4-BE49-F238E27FC236}">
-                <a16:creationId xmlns:a16="http://schemas.microsoft.com/office/drawing/2014/main" id="{0647CF54-6D53-49C2-9C08-8D01EBD4F90F}"/>
+                <a16:creationId xmlns:a16="http://schemas.microsoft.com/office/drawing/2014/main" id="{D9983ACF-B78A-4082-8FE4-8E10203AD6E2}"/>
               </a:ext>
             </a:extLst>
           </p:cNvPr>
@@ -10809,7 +10819,7 @@
     </p:spTree>
     <p:extLst>
       <p:ext uri="{BB962C8B-B14F-4D97-AF65-F5344CB8AC3E}">
-        <p14:creationId xmlns:p14="http://schemas.microsoft.com/office/powerpoint/2010/main" val="1986517333"/>
+        <p14:creationId xmlns:p14="http://schemas.microsoft.com/office/powerpoint/2010/main" val="17097258"/>
       </p:ext>
     </p:extLst>
   </p:cSld>
@@ -10840,7 +10850,7 @@
           <p:cNvPr id="10" name="text-0">
             <a:extLst xmlns:a="http://schemas.openxmlformats.org/drawingml/2006/main">
               <a:ext uri="{FF2B5EF4-FFF2-40B4-BE49-F238E27FC236}">
-                <a16:creationId xmlns:a16="http://schemas.microsoft.com/office/drawing/2014/main" id="{6A1A2F65-E0A5-4550-8128-F4431134BE3F}"/>
+                <a16:creationId xmlns:a16="http://schemas.microsoft.com/office/drawing/2014/main" id="{6A97CFD8-A112-4A30-8301-77A60FFC462D}"/>
               </a:ext>
             </a:extLst>
           </p:cNvPr>
@@ -10906,7 +10916,7 @@
           <p:cNvPr id="2" name="text-1">
             <a:extLst xmlns:a="http://schemas.openxmlformats.org/drawingml/2006/main">
               <a:ext uri="{FF2B5EF4-FFF2-40B4-BE49-F238E27FC236}">
-                <a16:creationId xmlns:a16="http://schemas.microsoft.com/office/drawing/2014/main" id="{40F2A0EF-BFA5-45A9-BEEE-B6DB275545CE}"/>
+                <a16:creationId xmlns:a16="http://schemas.microsoft.com/office/drawing/2014/main" id="{77C1AFB8-23EC-4DE0-864E-018F4F1552D3}"/>
               </a:ext>
             </a:extLst>
           </p:cNvPr>
@@ -10972,7 +10982,7 @@
           <p:cNvPr id="3" name="text-2">
             <a:extLst xmlns:a="http://schemas.openxmlformats.org/drawingml/2006/main">
               <a:ext uri="{FF2B5EF4-FFF2-40B4-BE49-F238E27FC236}">
-                <a16:creationId xmlns:a16="http://schemas.microsoft.com/office/drawing/2014/main" id="{03000C99-BA31-4F45-B3D8-78EF13E2EACB}"/>
+                <a16:creationId xmlns:a16="http://schemas.microsoft.com/office/drawing/2014/main" id="{7599479C-7597-478F-B02C-106980B3CC9E}"/>
               </a:ext>
             </a:extLst>
           </p:cNvPr>
@@ -11038,7 +11048,7 @@
           <p:cNvPr id="4" name="text-3">
             <a:extLst xmlns:a="http://schemas.openxmlformats.org/drawingml/2006/main">
               <a:ext uri="{FF2B5EF4-FFF2-40B4-BE49-F238E27FC236}">
-                <a16:creationId xmlns:a16="http://schemas.microsoft.com/office/drawing/2014/main" id="{AFFC4F89-B872-4172-A581-197532148034}"/>
+                <a16:creationId xmlns:a16="http://schemas.microsoft.com/office/drawing/2014/main" id="{15D8105A-DFD3-4C77-9FCF-E799CBB2DB4D}"/>
               </a:ext>
             </a:extLst>
           </p:cNvPr>
@@ -11104,7 +11114,7 @@
           <p:cNvPr id="5" name="text-4">
             <a:extLst xmlns:a="http://schemas.openxmlformats.org/drawingml/2006/main">
               <a:ext uri="{FF2B5EF4-FFF2-40B4-BE49-F238E27FC236}">
-                <a16:creationId xmlns:a16="http://schemas.microsoft.com/office/drawing/2014/main" id="{846C0093-4A73-4D5E-A126-AF9F51CF5E14}"/>
+                <a16:creationId xmlns:a16="http://schemas.microsoft.com/office/drawing/2014/main" id="{087B460F-0D20-4C9D-A1C3-085BF25FCFC2}"/>
               </a:ext>
             </a:extLst>
           </p:cNvPr>
@@ -11170,7 +11180,7 @@
           <p:cNvPr id="6" name="text-5">
             <a:extLst xmlns:a="http://schemas.openxmlformats.org/drawingml/2006/main">
               <a:ext uri="{FF2B5EF4-FFF2-40B4-BE49-F238E27FC236}">
-                <a16:creationId xmlns:a16="http://schemas.microsoft.com/office/drawing/2014/main" id="{C2D9F6D7-465D-44DE-91A1-B192BEFAFF6F}"/>
+                <a16:creationId xmlns:a16="http://schemas.microsoft.com/office/drawing/2014/main" id="{61A62C4E-D5CF-4A0E-94F1-836705236B5A}"/>
               </a:ext>
             </a:extLst>
           </p:cNvPr>
@@ -11236,7 +11246,7 @@
           <p:cNvPr id="7" name="text-6">
             <a:extLst xmlns:a="http://schemas.openxmlformats.org/drawingml/2006/main">
               <a:ext uri="{FF2B5EF4-FFF2-40B4-BE49-F238E27FC236}">
-                <a16:creationId xmlns:a16="http://schemas.microsoft.com/office/drawing/2014/main" id="{7E006780-9E27-4D07-8BB4-EB9DE8E8D620}"/>
+                <a16:creationId xmlns:a16="http://schemas.microsoft.com/office/drawing/2014/main" id="{9C403580-09D1-4629-8AA6-4405BD2677B4}"/>
               </a:ext>
             </a:extLst>
           </p:cNvPr>
@@ -11302,7 +11312,7 @@
           <p:cNvPr id="8" name="text-7">
             <a:extLst xmlns:a="http://schemas.openxmlformats.org/drawingml/2006/main">
               <a:ext uri="{FF2B5EF4-FFF2-40B4-BE49-F238E27FC236}">
-                <a16:creationId xmlns:a16="http://schemas.microsoft.com/office/drawing/2014/main" id="{FC15DA98-294F-403E-A668-13BEE6387535}"/>
+                <a16:creationId xmlns:a16="http://schemas.microsoft.com/office/drawing/2014/main" id="{92A626CC-AED2-4925-9120-06F219B4CC39}"/>
               </a:ext>
             </a:extLst>
           </p:cNvPr>
@@ -11368,7 +11378,7 @@
           <p:cNvPr id="9" name="text-8">
             <a:extLst xmlns:a="http://schemas.openxmlformats.org/drawingml/2006/main">
               <a:ext uri="{FF2B5EF4-FFF2-40B4-BE49-F238E27FC236}">
-                <a16:creationId xmlns:a16="http://schemas.microsoft.com/office/drawing/2014/main" id="{657C3E7C-98A3-4521-A927-663C0EBA130B}"/>
+                <a16:creationId xmlns:a16="http://schemas.microsoft.com/office/drawing/2014/main" id="{6A69033D-E3CC-40B8-9B6D-958D9E68DBBE}"/>
               </a:ext>
             </a:extLst>
           </p:cNvPr>
@@ -11432,7 +11442,7 @@
     </p:spTree>
     <p:extLst>
       <p:ext uri="{BB962C8B-B14F-4D97-AF65-F5344CB8AC3E}">
-        <p14:creationId xmlns:p14="http://schemas.microsoft.com/office/powerpoint/2010/main" val="2020675917"/>
+        <p14:creationId xmlns:p14="http://schemas.microsoft.com/office/powerpoint/2010/main" val="864185761"/>
       </p:ext>
     </p:extLst>
   </p:cSld>
@@ -11463,7 +11473,7 @@
           <p:cNvPr id="10" name="text-0">
             <a:extLst xmlns:a="http://schemas.openxmlformats.org/drawingml/2006/main">
               <a:ext uri="{FF2B5EF4-FFF2-40B4-BE49-F238E27FC236}">
-                <a16:creationId xmlns:a16="http://schemas.microsoft.com/office/drawing/2014/main" id="{D7774940-844E-43A4-9A69-184E9EFDE78A}"/>
+                <a16:creationId xmlns:a16="http://schemas.microsoft.com/office/drawing/2014/main" id="{5EF32895-534E-43CA-B08E-1AC92BD8CF82}"/>
               </a:ext>
             </a:extLst>
           </p:cNvPr>
@@ -11529,7 +11539,7 @@
           <p:cNvPr id="2" name="text-1">
             <a:extLst xmlns:a="http://schemas.openxmlformats.org/drawingml/2006/main">
               <a:ext uri="{FF2B5EF4-FFF2-40B4-BE49-F238E27FC236}">
-                <a16:creationId xmlns:a16="http://schemas.microsoft.com/office/drawing/2014/main" id="{9A3CC739-B549-4696-8A11-71464F5B52A3}"/>
+                <a16:creationId xmlns:a16="http://schemas.microsoft.com/office/drawing/2014/main" id="{A2AC9DB0-10CC-4157-8C08-B0D06AE81966}"/>
               </a:ext>
             </a:extLst>
           </p:cNvPr>
@@ -11595,7 +11605,7 @@
           <p:cNvPr id="3" name="text-2">
             <a:extLst xmlns:a="http://schemas.openxmlformats.org/drawingml/2006/main">
               <a:ext uri="{FF2B5EF4-FFF2-40B4-BE49-F238E27FC236}">
-                <a16:creationId xmlns:a16="http://schemas.microsoft.com/office/drawing/2014/main" id="{94FB18E8-385B-4963-9C0B-CF581AD35AE8}"/>
+                <a16:creationId xmlns:a16="http://schemas.microsoft.com/office/drawing/2014/main" id="{8E2E5F33-D165-4A04-AEDD-5A8A2606C83A}"/>
               </a:ext>
             </a:extLst>
           </p:cNvPr>
@@ -11661,7 +11671,7 @@
           <p:cNvPr id="4" name="text-3">
             <a:extLst xmlns:a="http://schemas.openxmlformats.org/drawingml/2006/main">
               <a:ext uri="{FF2B5EF4-FFF2-40B4-BE49-F238E27FC236}">
-                <a16:creationId xmlns:a16="http://schemas.microsoft.com/office/drawing/2014/main" id="{0117F31D-7629-4084-BC9C-A9B59102707E}"/>
+                <a16:creationId xmlns:a16="http://schemas.microsoft.com/office/drawing/2014/main" id="{734C0A8B-A59E-4524-AB9B-5281FB75F54D}"/>
               </a:ext>
             </a:extLst>
           </p:cNvPr>
@@ -11727,7 +11737,7 @@
           <p:cNvPr id="5" name="text-4">
             <a:extLst xmlns:a="http://schemas.openxmlformats.org/drawingml/2006/main">
               <a:ext uri="{FF2B5EF4-FFF2-40B4-BE49-F238E27FC236}">
-                <a16:creationId xmlns:a16="http://schemas.microsoft.com/office/drawing/2014/main" id="{3F93B17F-EA98-4135-8C74-5E8027D4D690}"/>
+                <a16:creationId xmlns:a16="http://schemas.microsoft.com/office/drawing/2014/main" id="{AA08A3A9-C385-4A28-A1A6-7EE0FF08CDD4}"/>
               </a:ext>
             </a:extLst>
           </p:cNvPr>
@@ -11793,7 +11803,7 @@
           <p:cNvPr id="6" name="text-5">
             <a:extLst xmlns:a="http://schemas.openxmlformats.org/drawingml/2006/main">
               <a:ext uri="{FF2B5EF4-FFF2-40B4-BE49-F238E27FC236}">
-                <a16:creationId xmlns:a16="http://schemas.microsoft.com/office/drawing/2014/main" id="{0EA6F4B6-5D77-46C1-9C4D-827A70D34D3F}"/>
+                <a16:creationId xmlns:a16="http://schemas.microsoft.com/office/drawing/2014/main" id="{1BDAEDE5-3F24-45E1-B56B-E3C17CA78289}"/>
               </a:ext>
             </a:extLst>
           </p:cNvPr>
@@ -11859,7 +11869,7 @@
           <p:cNvPr id="7" name="text-6">
             <a:extLst xmlns:a="http://schemas.openxmlformats.org/drawingml/2006/main">
               <a:ext uri="{FF2B5EF4-FFF2-40B4-BE49-F238E27FC236}">
-                <a16:creationId xmlns:a16="http://schemas.microsoft.com/office/drawing/2014/main" id="{A60F0BD6-F5D0-4FD8-A0F5-71F31CAD8FC2}"/>
+                <a16:creationId xmlns:a16="http://schemas.microsoft.com/office/drawing/2014/main" id="{0458DC46-6BDC-4B91-9528-97770390964E}"/>
               </a:ext>
             </a:extLst>
           </p:cNvPr>
@@ -11925,7 +11935,7 @@
           <p:cNvPr id="8" name="text-7">
             <a:extLst xmlns:a="http://schemas.openxmlformats.org/drawingml/2006/main">
               <a:ext uri="{FF2B5EF4-FFF2-40B4-BE49-F238E27FC236}">
-                <a16:creationId xmlns:a16="http://schemas.microsoft.com/office/drawing/2014/main" id="{124F9783-9AC5-4A90-B812-D3BA2224DEA2}"/>
+                <a16:creationId xmlns:a16="http://schemas.microsoft.com/office/drawing/2014/main" id="{CEC1C636-3383-4C02-B152-9719E287732F}"/>
               </a:ext>
             </a:extLst>
           </p:cNvPr>
@@ -11991,7 +12001,7 @@
           <p:cNvPr id="9" name="text-8">
             <a:extLst xmlns:a="http://schemas.openxmlformats.org/drawingml/2006/main">
               <a:ext uri="{FF2B5EF4-FFF2-40B4-BE49-F238E27FC236}">
-                <a16:creationId xmlns:a16="http://schemas.microsoft.com/office/drawing/2014/main" id="{28948EB0-3018-4F36-9A00-A0BDDD6EE687}"/>
+                <a16:creationId xmlns:a16="http://schemas.microsoft.com/office/drawing/2014/main" id="{1DF9A14E-0E9F-4F37-86E0-37AE3A3BB74A}"/>
               </a:ext>
             </a:extLst>
           </p:cNvPr>
@@ -12055,7 +12065,7 @@
     </p:spTree>
     <p:extLst>
       <p:ext uri="{BB962C8B-B14F-4D97-AF65-F5344CB8AC3E}">
-        <p14:creationId xmlns:p14="http://schemas.microsoft.com/office/powerpoint/2010/main" val="1169296534"/>
+        <p14:creationId xmlns:p14="http://schemas.microsoft.com/office/powerpoint/2010/main" val="952684564"/>
       </p:ext>
     </p:extLst>
   </p:cSld>
@@ -12086,7 +12096,7 @@
           <p:cNvPr id="4" name="text-0">
             <a:extLst xmlns:a="http://schemas.openxmlformats.org/drawingml/2006/main">
               <a:ext uri="{FF2B5EF4-FFF2-40B4-BE49-F238E27FC236}">
-                <a16:creationId xmlns:a16="http://schemas.microsoft.com/office/drawing/2014/main" id="{156722DD-2999-483D-BF90-1C5E650FF11F}"/>
+                <a16:creationId xmlns:a16="http://schemas.microsoft.com/office/drawing/2014/main" id="{C5979DF8-879C-4B84-AE6A-4E3AC9D691FD}"/>
               </a:ext>
             </a:extLst>
           </p:cNvPr>
@@ -12152,7 +12162,7 @@
           <p:cNvPr id="2" name="">
             <a:extLst xmlns:a="http://schemas.openxmlformats.org/drawingml/2006/main">
               <a:ext uri="{FF2B5EF4-FFF2-40B4-BE49-F238E27FC236}">
-                <a16:creationId xmlns:a16="http://schemas.microsoft.com/office/drawing/2014/main" id="{51ECB012-F3B2-43DA-8787-1B141651FF28}"/>
+                <a16:creationId xmlns:a16="http://schemas.microsoft.com/office/drawing/2014/main" id="{2C81B8C5-B995-4DEB-9D80-A99C3F2C7602}"/>
               </a:ext>
             </a:extLst>
           </p:cNvPr>
@@ -12551,7 +12561,7 @@
           <p:cNvPr id="3" name="text-1">
             <a:extLst xmlns:a="http://schemas.openxmlformats.org/drawingml/2006/main">
               <a:ext uri="{FF2B5EF4-FFF2-40B4-BE49-F238E27FC236}">
-                <a16:creationId xmlns:a16="http://schemas.microsoft.com/office/drawing/2014/main" id="{9CE12F8D-F359-4290-8217-078640AAA4DE}"/>
+                <a16:creationId xmlns:a16="http://schemas.microsoft.com/office/drawing/2014/main" id="{A8F3280E-180B-481A-B33C-028007B656D9}"/>
               </a:ext>
             </a:extLst>
           </p:cNvPr>
@@ -12615,7 +12625,7 @@
     </p:spTree>
     <p:extLst>
       <p:ext uri="{BB962C8B-B14F-4D97-AF65-F5344CB8AC3E}">
-        <p14:creationId xmlns:p14="http://schemas.microsoft.com/office/powerpoint/2010/main" val="203304046"/>
+        <p14:creationId xmlns:p14="http://schemas.microsoft.com/office/powerpoint/2010/main" val="137259523"/>
       </p:ext>
     </p:extLst>
   </p:cSld>
@@ -12646,7 +12656,7 @@
           <p:cNvPr id="10" name="text-0">
             <a:extLst xmlns:a="http://schemas.openxmlformats.org/drawingml/2006/main">
               <a:ext uri="{FF2B5EF4-FFF2-40B4-BE49-F238E27FC236}">
-                <a16:creationId xmlns:a16="http://schemas.microsoft.com/office/drawing/2014/main" id="{5E7D4DBD-EF4C-4C49-AE4E-D962DD2F5EC7}"/>
+                <a16:creationId xmlns:a16="http://schemas.microsoft.com/office/drawing/2014/main" id="{25DF9C81-6307-4771-9E08-D6D4D7CBE5D3}"/>
               </a:ext>
             </a:extLst>
           </p:cNvPr>
@@ -12712,7 +12722,7 @@
           <p:cNvPr id="2" name="text-1">
             <a:extLst xmlns:a="http://schemas.openxmlformats.org/drawingml/2006/main">
               <a:ext uri="{FF2B5EF4-FFF2-40B4-BE49-F238E27FC236}">
-                <a16:creationId xmlns:a16="http://schemas.microsoft.com/office/drawing/2014/main" id="{74D9A244-F149-4180-8FE2-E124C094882F}"/>
+                <a16:creationId xmlns:a16="http://schemas.microsoft.com/office/drawing/2014/main" id="{1CBF1A5D-CE9E-40BD-B52F-1B2BE12792AC}"/>
               </a:ext>
             </a:extLst>
           </p:cNvPr>
@@ -12778,7 +12788,7 @@
           <p:cNvPr id="3" name="text-2">
             <a:extLst xmlns:a="http://schemas.openxmlformats.org/drawingml/2006/main">
               <a:ext uri="{FF2B5EF4-FFF2-40B4-BE49-F238E27FC236}">
-                <a16:creationId xmlns:a16="http://schemas.microsoft.com/office/drawing/2014/main" id="{62EC091D-6AB6-48D5-89C7-4A9AC4B13DB4}"/>
+                <a16:creationId xmlns:a16="http://schemas.microsoft.com/office/drawing/2014/main" id="{51978BF4-5A89-4DE8-A017-87F8E6148FC3}"/>
               </a:ext>
             </a:extLst>
           </p:cNvPr>
@@ -12844,7 +12854,7 @@
           <p:cNvPr id="4" name="text-3">
             <a:extLst xmlns:a="http://schemas.openxmlformats.org/drawingml/2006/main">
               <a:ext uri="{FF2B5EF4-FFF2-40B4-BE49-F238E27FC236}">
-                <a16:creationId xmlns:a16="http://schemas.microsoft.com/office/drawing/2014/main" id="{000D9F28-F909-4E1B-A010-E803966F7A6E}"/>
+                <a16:creationId xmlns:a16="http://schemas.microsoft.com/office/drawing/2014/main" id="{7632BFB6-7E19-4278-891F-6C486801BF9B}"/>
               </a:ext>
             </a:extLst>
           </p:cNvPr>
@@ -12910,7 +12920,7 @@
           <p:cNvPr id="5" name="text-4">
             <a:extLst xmlns:a="http://schemas.openxmlformats.org/drawingml/2006/main">
               <a:ext uri="{FF2B5EF4-FFF2-40B4-BE49-F238E27FC236}">
-                <a16:creationId xmlns:a16="http://schemas.microsoft.com/office/drawing/2014/main" id="{D834CF08-DEC7-46B4-B1A8-8CDE127BF8AD}"/>
+                <a16:creationId xmlns:a16="http://schemas.microsoft.com/office/drawing/2014/main" id="{22628A9E-217D-471F-8A4B-96A56A06BD25}"/>
               </a:ext>
             </a:extLst>
           </p:cNvPr>
@@ -12976,7 +12986,7 @@
           <p:cNvPr id="6" name="text-5">
             <a:extLst xmlns:a="http://schemas.openxmlformats.org/drawingml/2006/main">
               <a:ext uri="{FF2B5EF4-FFF2-40B4-BE49-F238E27FC236}">
-                <a16:creationId xmlns:a16="http://schemas.microsoft.com/office/drawing/2014/main" id="{37571989-3582-4582-ACFD-1C897B51892C}"/>
+                <a16:creationId xmlns:a16="http://schemas.microsoft.com/office/drawing/2014/main" id="{06E9CBF0-EB1D-43EC-A009-A7FC73BD2F1C}"/>
               </a:ext>
             </a:extLst>
           </p:cNvPr>
@@ -13042,7 +13052,7 @@
           <p:cNvPr id="7" name="text-6">
             <a:extLst xmlns:a="http://schemas.openxmlformats.org/drawingml/2006/main">
               <a:ext uri="{FF2B5EF4-FFF2-40B4-BE49-F238E27FC236}">
-                <a16:creationId xmlns:a16="http://schemas.microsoft.com/office/drawing/2014/main" id="{20524453-56FF-4228-A0F8-8499A810D48E}"/>
+                <a16:creationId xmlns:a16="http://schemas.microsoft.com/office/drawing/2014/main" id="{25E29556-EA49-4FEA-BCE1-E9BAFC34592C}"/>
               </a:ext>
             </a:extLst>
           </p:cNvPr>
@@ -13108,7 +13118,7 @@
           <p:cNvPr id="8" name="text-7">
             <a:extLst xmlns:a="http://schemas.openxmlformats.org/drawingml/2006/main">
               <a:ext uri="{FF2B5EF4-FFF2-40B4-BE49-F238E27FC236}">
-                <a16:creationId xmlns:a16="http://schemas.microsoft.com/office/drawing/2014/main" id="{9C535D59-3114-4A4D-9129-65D7F26B9DA9}"/>
+                <a16:creationId xmlns:a16="http://schemas.microsoft.com/office/drawing/2014/main" id="{92806493-9258-4A90-9837-ADDDBBAACFBC}"/>
               </a:ext>
             </a:extLst>
           </p:cNvPr>
@@ -13174,7 +13184,7 @@
           <p:cNvPr id="9" name="text-8">
             <a:extLst xmlns:a="http://schemas.openxmlformats.org/drawingml/2006/main">
               <a:ext uri="{FF2B5EF4-FFF2-40B4-BE49-F238E27FC236}">
-                <a16:creationId xmlns:a16="http://schemas.microsoft.com/office/drawing/2014/main" id="{F55AFD95-C7CF-48B1-8711-C82424718891}"/>
+                <a16:creationId xmlns:a16="http://schemas.microsoft.com/office/drawing/2014/main" id="{D968902B-4058-456F-AC1C-F0AAD41BDB9C}"/>
               </a:ext>
             </a:extLst>
           </p:cNvPr>
@@ -13238,7 +13248,7 @@
     </p:spTree>
     <p:extLst>
       <p:ext uri="{BB962C8B-B14F-4D97-AF65-F5344CB8AC3E}">
-        <p14:creationId xmlns:p14="http://schemas.microsoft.com/office/powerpoint/2010/main" val="282081506"/>
+        <p14:creationId xmlns:p14="http://schemas.microsoft.com/office/powerpoint/2010/main" val="441894286"/>
       </p:ext>
     </p:extLst>
   </p:cSld>
@@ -13269,7 +13279,7 @@
           <p:cNvPr id="10" name="text-0">
             <a:extLst xmlns:a="http://schemas.openxmlformats.org/drawingml/2006/main">
               <a:ext uri="{FF2B5EF4-FFF2-40B4-BE49-F238E27FC236}">
-                <a16:creationId xmlns:a16="http://schemas.microsoft.com/office/drawing/2014/main" id="{50B98806-6B19-4F6D-BB76-F380EB1E7D04}"/>
+                <a16:creationId xmlns:a16="http://schemas.microsoft.com/office/drawing/2014/main" id="{FFF17801-8CEC-422B-93E9-0126B3943AC4}"/>
               </a:ext>
             </a:extLst>
           </p:cNvPr>
@@ -13335,7 +13345,7 @@
           <p:cNvPr id="2" name="text-1">
             <a:extLst xmlns:a="http://schemas.openxmlformats.org/drawingml/2006/main">
               <a:ext uri="{FF2B5EF4-FFF2-40B4-BE49-F238E27FC236}">
-                <a16:creationId xmlns:a16="http://schemas.microsoft.com/office/drawing/2014/main" id="{73AAD098-69B8-45AC-BE32-E026D7BE0D99}"/>
+                <a16:creationId xmlns:a16="http://schemas.microsoft.com/office/drawing/2014/main" id="{BC6138C7-3909-4C4C-B94C-5C60EFD0106B}"/>
               </a:ext>
             </a:extLst>
           </p:cNvPr>
@@ -13401,7 +13411,7 @@
           <p:cNvPr id="3" name="text-2">
             <a:extLst xmlns:a="http://schemas.openxmlformats.org/drawingml/2006/main">
               <a:ext uri="{FF2B5EF4-FFF2-40B4-BE49-F238E27FC236}">
-                <a16:creationId xmlns:a16="http://schemas.microsoft.com/office/drawing/2014/main" id="{701F9A72-A045-4249-8A3A-A297D85FDDDE}"/>
+                <a16:creationId xmlns:a16="http://schemas.microsoft.com/office/drawing/2014/main" id="{1CF81CFB-6143-4B5F-99F6-F78A98FE2D3A}"/>
               </a:ext>
             </a:extLst>
           </p:cNvPr>
@@ -13467,7 +13477,7 @@
           <p:cNvPr id="4" name="text-3">
             <a:extLst xmlns:a="http://schemas.openxmlformats.org/drawingml/2006/main">
               <a:ext uri="{FF2B5EF4-FFF2-40B4-BE49-F238E27FC236}">
-                <a16:creationId xmlns:a16="http://schemas.microsoft.com/office/drawing/2014/main" id="{05C828AF-0B43-411A-931F-D6123B783B8E}"/>
+                <a16:creationId xmlns:a16="http://schemas.microsoft.com/office/drawing/2014/main" id="{9F1D7BC9-7175-4E59-BB87-9452AF439A0D}"/>
               </a:ext>
             </a:extLst>
           </p:cNvPr>
@@ -13533,7 +13543,7 @@
           <p:cNvPr id="5" name="text-4">
             <a:extLst xmlns:a="http://schemas.openxmlformats.org/drawingml/2006/main">
               <a:ext uri="{FF2B5EF4-FFF2-40B4-BE49-F238E27FC236}">
-                <a16:creationId xmlns:a16="http://schemas.microsoft.com/office/drawing/2014/main" id="{2447E733-10CC-49C6-AC2B-F72B6F5E705A}"/>
+                <a16:creationId xmlns:a16="http://schemas.microsoft.com/office/drawing/2014/main" id="{D1517A55-2412-4035-BD40-AF65D8B517E4}"/>
               </a:ext>
             </a:extLst>
           </p:cNvPr>
@@ -13599,7 +13609,7 @@
           <p:cNvPr id="6" name="text-5">
             <a:extLst xmlns:a="http://schemas.openxmlformats.org/drawingml/2006/main">
               <a:ext uri="{FF2B5EF4-FFF2-40B4-BE49-F238E27FC236}">
-                <a16:creationId xmlns:a16="http://schemas.microsoft.com/office/drawing/2014/main" id="{99E341C4-1FD3-47E6-ACA7-57288ADC0CF3}"/>
+                <a16:creationId xmlns:a16="http://schemas.microsoft.com/office/drawing/2014/main" id="{212D4018-3E4F-4E09-996F-B94135AE9A86}"/>
               </a:ext>
             </a:extLst>
           </p:cNvPr>
@@ -13665,7 +13675,7 @@
           <p:cNvPr id="7" name="text-6">
             <a:extLst xmlns:a="http://schemas.openxmlformats.org/drawingml/2006/main">
               <a:ext uri="{FF2B5EF4-FFF2-40B4-BE49-F238E27FC236}">
-                <a16:creationId xmlns:a16="http://schemas.microsoft.com/office/drawing/2014/main" id="{64E898AD-610F-46C5-9A89-E1FDCA3F2E4C}"/>
+                <a16:creationId xmlns:a16="http://schemas.microsoft.com/office/drawing/2014/main" id="{1214A6E1-9707-46C6-95C2-9929CAA13C5C}"/>
               </a:ext>
             </a:extLst>
           </p:cNvPr>
@@ -13731,7 +13741,7 @@
           <p:cNvPr id="8" name="text-7">
             <a:extLst xmlns:a="http://schemas.openxmlformats.org/drawingml/2006/main">
               <a:ext uri="{FF2B5EF4-FFF2-40B4-BE49-F238E27FC236}">
-                <a16:creationId xmlns:a16="http://schemas.microsoft.com/office/drawing/2014/main" id="{D110747F-F018-4C52-8C1D-C17311584A3F}"/>
+                <a16:creationId xmlns:a16="http://schemas.microsoft.com/office/drawing/2014/main" id="{09408E88-510E-4937-8D60-0AA6D102E87A}"/>
               </a:ext>
             </a:extLst>
           </p:cNvPr>
@@ -13797,7 +13807,7 @@
           <p:cNvPr id="9" name="text-8">
             <a:extLst xmlns:a="http://schemas.openxmlformats.org/drawingml/2006/main">
               <a:ext uri="{FF2B5EF4-FFF2-40B4-BE49-F238E27FC236}">
-                <a16:creationId xmlns:a16="http://schemas.microsoft.com/office/drawing/2014/main" id="{C6F540B7-FFC7-4847-A6AB-95F917A342E8}"/>
+                <a16:creationId xmlns:a16="http://schemas.microsoft.com/office/drawing/2014/main" id="{D03CF97D-DFD4-45DA-9629-58A0C37F3980}"/>
               </a:ext>
             </a:extLst>
           </p:cNvPr>
@@ -13861,7 +13871,7 @@
     </p:spTree>
     <p:extLst>
       <p:ext uri="{BB962C8B-B14F-4D97-AF65-F5344CB8AC3E}">
-        <p14:creationId xmlns:p14="http://schemas.microsoft.com/office/powerpoint/2010/main" val="1003340877"/>
+        <p14:creationId xmlns:p14="http://schemas.microsoft.com/office/powerpoint/2010/main" val="1974413006"/>
       </p:ext>
     </p:extLst>
   </p:cSld>
@@ -13892,7 +13902,7 @@
           <p:cNvPr id="5" name="text-0">
             <a:extLst xmlns:a="http://schemas.openxmlformats.org/drawingml/2006/main">
               <a:ext uri="{FF2B5EF4-FFF2-40B4-BE49-F238E27FC236}">
-                <a16:creationId xmlns:a16="http://schemas.microsoft.com/office/drawing/2014/main" id="{7A1946D5-FEF3-4189-869E-09135B4F4470}"/>
+                <a16:creationId xmlns:a16="http://schemas.microsoft.com/office/drawing/2014/main" id="{371CCC2F-3E4B-4F34-9225-D7038A55B1B0}"/>
               </a:ext>
             </a:extLst>
           </p:cNvPr>
@@ -13958,7 +13968,7 @@
           <p:cNvPr id="2" name="">
             <a:extLst xmlns:a="http://schemas.openxmlformats.org/drawingml/2006/main">
               <a:ext uri="{FF2B5EF4-FFF2-40B4-BE49-F238E27FC236}">
-                <a16:creationId xmlns:a16="http://schemas.microsoft.com/office/drawing/2014/main" id="{AE08A238-0E0B-4F82-A9F5-C161E3102460}"/>
+                <a16:creationId xmlns:a16="http://schemas.microsoft.com/office/drawing/2014/main" id="{2D793758-07D4-485B-9CB0-A66C290618EC}"/>
               </a:ext>
             </a:extLst>
           </p:cNvPr>
@@ -14357,7 +14367,7 @@
           <p:cNvPr id="3" name="text-1">
             <a:extLst xmlns:a="http://schemas.openxmlformats.org/drawingml/2006/main">
               <a:ext uri="{FF2B5EF4-FFF2-40B4-BE49-F238E27FC236}">
-                <a16:creationId xmlns:a16="http://schemas.microsoft.com/office/drawing/2014/main" id="{CE1EDD5C-2F07-4D0C-BAD6-7C411202511D}"/>
+                <a16:creationId xmlns:a16="http://schemas.microsoft.com/office/drawing/2014/main" id="{F674B837-D83E-44B3-B9B2-B9012BCCF159}"/>
               </a:ext>
             </a:extLst>
           </p:cNvPr>
@@ -14423,7 +14433,7 @@
           <p:cNvPr id="4" name="text-2">
             <a:extLst xmlns:a="http://schemas.openxmlformats.org/drawingml/2006/main">
               <a:ext uri="{FF2B5EF4-FFF2-40B4-BE49-F238E27FC236}">
-                <a16:creationId xmlns:a16="http://schemas.microsoft.com/office/drawing/2014/main" id="{839CBC64-70A3-420B-A8C3-351C38BDDBAA}"/>
+                <a16:creationId xmlns:a16="http://schemas.microsoft.com/office/drawing/2014/main" id="{FD02AEE1-C5F9-4545-AE98-E240F33A39C0}"/>
               </a:ext>
             </a:extLst>
           </p:cNvPr>
@@ -14487,7 +14497,7 @@
     </p:spTree>
     <p:extLst>
       <p:ext uri="{BB962C8B-B14F-4D97-AF65-F5344CB8AC3E}">
-        <p14:creationId xmlns:p14="http://schemas.microsoft.com/office/powerpoint/2010/main" val="1877349001"/>
+        <p14:creationId xmlns:p14="http://schemas.microsoft.com/office/powerpoint/2010/main" val="682594958"/>
       </p:ext>
     </p:extLst>
   </p:cSld>
@@ -14518,7 +14528,7 @@
           <p:cNvPr id="10" name="text-0">
             <a:extLst xmlns:a="http://schemas.openxmlformats.org/drawingml/2006/main">
               <a:ext uri="{FF2B5EF4-FFF2-40B4-BE49-F238E27FC236}">
-                <a16:creationId xmlns:a16="http://schemas.microsoft.com/office/drawing/2014/main" id="{49D81658-00B7-408E-A83A-EA6AC73BEA71}"/>
+                <a16:creationId xmlns:a16="http://schemas.microsoft.com/office/drawing/2014/main" id="{652CF2D5-AA3E-4519-BEF1-1FCCB10ABF1A}"/>
               </a:ext>
             </a:extLst>
           </p:cNvPr>
@@ -14584,7 +14594,7 @@
           <p:cNvPr id="2" name="text-1">
             <a:extLst xmlns:a="http://schemas.openxmlformats.org/drawingml/2006/main">
               <a:ext uri="{FF2B5EF4-FFF2-40B4-BE49-F238E27FC236}">
-                <a16:creationId xmlns:a16="http://schemas.microsoft.com/office/drawing/2014/main" id="{6A1434FB-C786-4CF5-97CC-D4B6A6582D85}"/>
+                <a16:creationId xmlns:a16="http://schemas.microsoft.com/office/drawing/2014/main" id="{8F062A18-A0D1-4186-A0CF-09AA0BE3B499}"/>
               </a:ext>
             </a:extLst>
           </p:cNvPr>
@@ -14650,7 +14660,7 @@
           <p:cNvPr id="3" name="text-2">
             <a:extLst xmlns:a="http://schemas.openxmlformats.org/drawingml/2006/main">
               <a:ext uri="{FF2B5EF4-FFF2-40B4-BE49-F238E27FC236}">
-                <a16:creationId xmlns:a16="http://schemas.microsoft.com/office/drawing/2014/main" id="{BA0F2F91-FB99-4DB7-868A-6F3AC4BB12CA}"/>
+                <a16:creationId xmlns:a16="http://schemas.microsoft.com/office/drawing/2014/main" id="{D544D961-FE80-482B-A179-02BF00ED23C4}"/>
               </a:ext>
             </a:extLst>
           </p:cNvPr>
@@ -14716,7 +14726,7 @@
           <p:cNvPr id="4" name="text-3">
             <a:extLst xmlns:a="http://schemas.openxmlformats.org/drawingml/2006/main">
               <a:ext uri="{FF2B5EF4-FFF2-40B4-BE49-F238E27FC236}">
-                <a16:creationId xmlns:a16="http://schemas.microsoft.com/office/drawing/2014/main" id="{E968FB11-5325-44D7-B3AB-8F79933FEAE1}"/>
+                <a16:creationId xmlns:a16="http://schemas.microsoft.com/office/drawing/2014/main" id="{EB713DBF-3C20-4DA5-87F3-ADBE672B30B5}"/>
               </a:ext>
             </a:extLst>
           </p:cNvPr>
@@ -14782,7 +14792,7 @@
           <p:cNvPr id="5" name="text-4">
             <a:extLst xmlns:a="http://schemas.openxmlformats.org/drawingml/2006/main">
               <a:ext uri="{FF2B5EF4-FFF2-40B4-BE49-F238E27FC236}">
-                <a16:creationId xmlns:a16="http://schemas.microsoft.com/office/drawing/2014/main" id="{CA282133-3528-4634-8ECA-08A66B7353ED}"/>
+                <a16:creationId xmlns:a16="http://schemas.microsoft.com/office/drawing/2014/main" id="{E858C1AC-BE6B-4F1A-A49B-200BA3A3BB20}"/>
               </a:ext>
             </a:extLst>
           </p:cNvPr>
@@ -14848,7 +14858,7 @@
           <p:cNvPr id="6" name="text-5">
             <a:extLst xmlns:a="http://schemas.openxmlformats.org/drawingml/2006/main">
               <a:ext uri="{FF2B5EF4-FFF2-40B4-BE49-F238E27FC236}">
-                <a16:creationId xmlns:a16="http://schemas.microsoft.com/office/drawing/2014/main" id="{C7340D5C-662C-48D6-82E5-9DC501499C10}"/>
+                <a16:creationId xmlns:a16="http://schemas.microsoft.com/office/drawing/2014/main" id="{9EFF4EE2-D5C5-41D5-99D8-ECB2E2896E90}"/>
               </a:ext>
             </a:extLst>
           </p:cNvPr>
@@ -14914,7 +14924,7 @@
           <p:cNvPr id="7" name="text-6">
             <a:extLst xmlns:a="http://schemas.openxmlformats.org/drawingml/2006/main">
               <a:ext uri="{FF2B5EF4-FFF2-40B4-BE49-F238E27FC236}">
-                <a16:creationId xmlns:a16="http://schemas.microsoft.com/office/drawing/2014/main" id="{22AF01E1-1350-4326-88EC-B41F8A9F8CE3}"/>
+                <a16:creationId xmlns:a16="http://schemas.microsoft.com/office/drawing/2014/main" id="{EAF3DA07-F6AA-4A5A-ABCC-16A9495AC55F}"/>
               </a:ext>
             </a:extLst>
           </p:cNvPr>
@@ -14980,7 +14990,7 @@
           <p:cNvPr id="8" name="text-7">
             <a:extLst xmlns:a="http://schemas.openxmlformats.org/drawingml/2006/main">
               <a:ext uri="{FF2B5EF4-FFF2-40B4-BE49-F238E27FC236}">
-                <a16:creationId xmlns:a16="http://schemas.microsoft.com/office/drawing/2014/main" id="{50745D32-FF04-4331-A483-D57418AEE386}"/>
+                <a16:creationId xmlns:a16="http://schemas.microsoft.com/office/drawing/2014/main" id="{7F94F9D2-B3FE-448B-90E2-356083277137}"/>
               </a:ext>
             </a:extLst>
           </p:cNvPr>
@@ -15046,7 +15056,7 @@
           <p:cNvPr id="9" name="text-8">
             <a:extLst xmlns:a="http://schemas.openxmlformats.org/drawingml/2006/main">
               <a:ext uri="{FF2B5EF4-FFF2-40B4-BE49-F238E27FC236}">
-                <a16:creationId xmlns:a16="http://schemas.microsoft.com/office/drawing/2014/main" id="{61089FBA-BC38-4169-A9BD-ABE09D5DA8BF}"/>
+                <a16:creationId xmlns:a16="http://schemas.microsoft.com/office/drawing/2014/main" id="{FB2AE5C5-92AE-4630-B53F-B1C2C6C19276}"/>
               </a:ext>
             </a:extLst>
           </p:cNvPr>
@@ -15110,7 +15120,7 @@
     </p:spTree>
     <p:extLst>
       <p:ext uri="{BB962C8B-B14F-4D97-AF65-F5344CB8AC3E}">
-        <p14:creationId xmlns:p14="http://schemas.microsoft.com/office/powerpoint/2010/main" val="1672345485"/>
+        <p14:creationId xmlns:p14="http://schemas.microsoft.com/office/powerpoint/2010/main" val="1103108192"/>
       </p:ext>
     </p:extLst>
   </p:cSld>
@@ -15141,7 +15151,7 @@
           <p:cNvPr id="5" name="text-0">
             <a:extLst xmlns:a="http://schemas.openxmlformats.org/drawingml/2006/main">
               <a:ext uri="{FF2B5EF4-FFF2-40B4-BE49-F238E27FC236}">
-                <a16:creationId xmlns:a16="http://schemas.microsoft.com/office/drawing/2014/main" id="{A60BD90D-6CF5-471C-B834-3E9F11CDB49C}"/>
+                <a16:creationId xmlns:a16="http://schemas.microsoft.com/office/drawing/2014/main" id="{5FDA128A-708F-40C8-BC8A-DFDDDE25435B}"/>
               </a:ext>
             </a:extLst>
           </p:cNvPr>
@@ -15207,7 +15217,7 @@
           <p:cNvPr id="2" name="">
             <a:extLst xmlns:a="http://schemas.openxmlformats.org/drawingml/2006/main">
               <a:ext uri="{FF2B5EF4-FFF2-40B4-BE49-F238E27FC236}">
-                <a16:creationId xmlns:a16="http://schemas.microsoft.com/office/drawing/2014/main" id="{2FC65F88-2173-4000-931E-3E97897A8AF6}"/>
+                <a16:creationId xmlns:a16="http://schemas.microsoft.com/office/drawing/2014/main" id="{5E662123-4DBC-491D-AB81-3D44276A8972}"/>
               </a:ext>
             </a:extLst>
           </p:cNvPr>
@@ -15485,7 +15495,7 @@
           <p:cNvPr id="3" name="text-1">
             <a:extLst xmlns:a="http://schemas.openxmlformats.org/drawingml/2006/main">
               <a:ext uri="{FF2B5EF4-FFF2-40B4-BE49-F238E27FC236}">
-                <a16:creationId xmlns:a16="http://schemas.microsoft.com/office/drawing/2014/main" id="{217BB9AF-44AC-445A-90D4-8D080C473207}"/>
+                <a16:creationId xmlns:a16="http://schemas.microsoft.com/office/drawing/2014/main" id="{5D77D794-B46E-4F5D-A3B9-5181BCE59C6B}"/>
               </a:ext>
             </a:extLst>
           </p:cNvPr>
@@ -15551,7 +15561,7 @@
           <p:cNvPr id="4" name="text-2">
             <a:extLst xmlns:a="http://schemas.openxmlformats.org/drawingml/2006/main">
               <a:ext uri="{FF2B5EF4-FFF2-40B4-BE49-F238E27FC236}">
-                <a16:creationId xmlns:a16="http://schemas.microsoft.com/office/drawing/2014/main" id="{7EFFDE04-F082-4814-90D4-AE04EC6A12F2}"/>
+                <a16:creationId xmlns:a16="http://schemas.microsoft.com/office/drawing/2014/main" id="{0B9C532F-60AC-4402-9298-F64E1FD58C1A}"/>
               </a:ext>
             </a:extLst>
           </p:cNvPr>
@@ -15615,7 +15625,7 @@
     </p:spTree>
     <p:extLst>
       <p:ext uri="{BB962C8B-B14F-4D97-AF65-F5344CB8AC3E}">
-        <p14:creationId xmlns:p14="http://schemas.microsoft.com/office/powerpoint/2010/main" val="617376225"/>
+        <p14:creationId xmlns:p14="http://schemas.microsoft.com/office/powerpoint/2010/main" val="1472003092"/>
       </p:ext>
     </p:extLst>
   </p:cSld>
@@ -15646,7 +15656,7 @@
           <p:cNvPr id="10" name="text-0">
             <a:extLst xmlns:a="http://schemas.openxmlformats.org/drawingml/2006/main">
               <a:ext uri="{FF2B5EF4-FFF2-40B4-BE49-F238E27FC236}">
-                <a16:creationId xmlns:a16="http://schemas.microsoft.com/office/drawing/2014/main" id="{CB263E37-23A7-43C1-9F72-5F9B1FC95211}"/>
+                <a16:creationId xmlns:a16="http://schemas.microsoft.com/office/drawing/2014/main" id="{F2B9A711-C4B0-4182-B274-ADE77D99A730}"/>
               </a:ext>
             </a:extLst>
           </p:cNvPr>
@@ -15712,7 +15722,7 @@
           <p:cNvPr id="2" name="text-1">
             <a:extLst xmlns:a="http://schemas.openxmlformats.org/drawingml/2006/main">
               <a:ext uri="{FF2B5EF4-FFF2-40B4-BE49-F238E27FC236}">
-                <a16:creationId xmlns:a16="http://schemas.microsoft.com/office/drawing/2014/main" id="{4EE8603B-28E0-4A62-A642-AD085C056D05}"/>
+                <a16:creationId xmlns:a16="http://schemas.microsoft.com/office/drawing/2014/main" id="{CC66E117-0615-4C87-96C0-D3EAD9BF80DD}"/>
               </a:ext>
             </a:extLst>
           </p:cNvPr>
@@ -15778,7 +15788,7 @@
           <p:cNvPr id="3" name="text-2">
             <a:extLst xmlns:a="http://schemas.openxmlformats.org/drawingml/2006/main">
               <a:ext uri="{FF2B5EF4-FFF2-40B4-BE49-F238E27FC236}">
-                <a16:creationId xmlns:a16="http://schemas.microsoft.com/office/drawing/2014/main" id="{2DE8C919-C62C-42E5-AE3E-34683C64FF16}"/>
+                <a16:creationId xmlns:a16="http://schemas.microsoft.com/office/drawing/2014/main" id="{61A47819-2C54-4E55-AE20-6A9B2C761140}"/>
               </a:ext>
             </a:extLst>
           </p:cNvPr>
@@ -15844,7 +15854,7 @@
           <p:cNvPr id="4" name="text-3">
             <a:extLst xmlns:a="http://schemas.openxmlformats.org/drawingml/2006/main">
               <a:ext uri="{FF2B5EF4-FFF2-40B4-BE49-F238E27FC236}">
-                <a16:creationId xmlns:a16="http://schemas.microsoft.com/office/drawing/2014/main" id="{E5FA6237-4937-4E5F-96F8-EB6EAA5997A4}"/>
+                <a16:creationId xmlns:a16="http://schemas.microsoft.com/office/drawing/2014/main" id="{D05E3DA1-7570-4141-AAB8-CC139B9B141D}"/>
               </a:ext>
             </a:extLst>
           </p:cNvPr>
@@ -15910,7 +15920,7 @@
           <p:cNvPr id="5" name="text-4">
             <a:extLst xmlns:a="http://schemas.openxmlformats.org/drawingml/2006/main">
               <a:ext uri="{FF2B5EF4-FFF2-40B4-BE49-F238E27FC236}">
-                <a16:creationId xmlns:a16="http://schemas.microsoft.com/office/drawing/2014/main" id="{7E85D4B4-7A79-4585-8F30-4528CBB00FDC}"/>
+                <a16:creationId xmlns:a16="http://schemas.microsoft.com/office/drawing/2014/main" id="{07B4937E-F817-413F-99BB-7D16BC0E7692}"/>
               </a:ext>
             </a:extLst>
           </p:cNvPr>
@@ -15976,7 +15986,7 @@
           <p:cNvPr id="6" name="text-5">
             <a:extLst xmlns:a="http://schemas.openxmlformats.org/drawingml/2006/main">
               <a:ext uri="{FF2B5EF4-FFF2-40B4-BE49-F238E27FC236}">
-                <a16:creationId xmlns:a16="http://schemas.microsoft.com/office/drawing/2014/main" id="{A597CE3A-2EF4-4D4A-AFD6-711DA8D7A598}"/>
+                <a16:creationId xmlns:a16="http://schemas.microsoft.com/office/drawing/2014/main" id="{54051D85-2C8B-4732-9D00-A8644651B5AE}"/>
               </a:ext>
             </a:extLst>
           </p:cNvPr>
@@ -16042,7 +16052,7 @@
           <p:cNvPr id="7" name="text-6">
             <a:extLst xmlns:a="http://schemas.openxmlformats.org/drawingml/2006/main">
               <a:ext uri="{FF2B5EF4-FFF2-40B4-BE49-F238E27FC236}">
-                <a16:creationId xmlns:a16="http://schemas.microsoft.com/office/drawing/2014/main" id="{706A177F-A664-487D-B8C8-004A64ED4F87}"/>
+                <a16:creationId xmlns:a16="http://schemas.microsoft.com/office/drawing/2014/main" id="{F1FA8EE4-E9F3-4031-9322-86F76C07BF6A}"/>
               </a:ext>
             </a:extLst>
           </p:cNvPr>
@@ -16108,7 +16118,7 @@
           <p:cNvPr id="8" name="text-7">
             <a:extLst xmlns:a="http://schemas.openxmlformats.org/drawingml/2006/main">
               <a:ext uri="{FF2B5EF4-FFF2-40B4-BE49-F238E27FC236}">
-                <a16:creationId xmlns:a16="http://schemas.microsoft.com/office/drawing/2014/main" id="{4F5B98F5-F6BF-4DB8-9DDD-470D897B2EDE}"/>
+                <a16:creationId xmlns:a16="http://schemas.microsoft.com/office/drawing/2014/main" id="{3778E351-4025-48E8-8FAF-E7E8EDC46C52}"/>
               </a:ext>
             </a:extLst>
           </p:cNvPr>
@@ -16174,7 +16184,7 @@
           <p:cNvPr id="9" name="text-8">
             <a:extLst xmlns:a="http://schemas.openxmlformats.org/drawingml/2006/main">
               <a:ext uri="{FF2B5EF4-FFF2-40B4-BE49-F238E27FC236}">
-                <a16:creationId xmlns:a16="http://schemas.microsoft.com/office/drawing/2014/main" id="{77611124-DB23-4764-AEDE-7E5096D1C775}"/>
+                <a16:creationId xmlns:a16="http://schemas.microsoft.com/office/drawing/2014/main" id="{6C2BE0A6-51CD-4EF2-B0C6-77D5400CC884}"/>
               </a:ext>
             </a:extLst>
           </p:cNvPr>
@@ -16238,7 +16248,7 @@
     </p:spTree>
     <p:extLst>
       <p:ext uri="{BB962C8B-B14F-4D97-AF65-F5344CB8AC3E}">
-        <p14:creationId xmlns:p14="http://schemas.microsoft.com/office/powerpoint/2010/main" val="1836769355"/>
+        <p14:creationId xmlns:p14="http://schemas.microsoft.com/office/powerpoint/2010/main" val="933113744"/>
       </p:ext>
     </p:extLst>
   </p:cSld>
@@ -16269,7 +16279,7 @@
           <p:cNvPr id="10" name="text-0">
             <a:extLst xmlns:a="http://schemas.openxmlformats.org/drawingml/2006/main">
               <a:ext uri="{FF2B5EF4-FFF2-40B4-BE49-F238E27FC236}">
-                <a16:creationId xmlns:a16="http://schemas.microsoft.com/office/drawing/2014/main" id="{6892D18A-BE52-4DA3-92D9-CFCF00BB5054}"/>
+                <a16:creationId xmlns:a16="http://schemas.microsoft.com/office/drawing/2014/main" id="{3D7FD722-9F1B-4ACE-BB9D-CF6B401760E2}"/>
               </a:ext>
             </a:extLst>
           </p:cNvPr>
@@ -16335,7 +16345,7 @@
           <p:cNvPr id="2" name="text-1">
             <a:extLst xmlns:a="http://schemas.openxmlformats.org/drawingml/2006/main">
               <a:ext uri="{FF2B5EF4-FFF2-40B4-BE49-F238E27FC236}">
-                <a16:creationId xmlns:a16="http://schemas.microsoft.com/office/drawing/2014/main" id="{0E9A8315-0E75-47C3-B7A2-F42385C56A73}"/>
+                <a16:creationId xmlns:a16="http://schemas.microsoft.com/office/drawing/2014/main" id="{36C38FFF-48F9-448F-AB36-A88A2CAE1031}"/>
               </a:ext>
             </a:extLst>
           </p:cNvPr>
@@ -16401,7 +16411,7 @@
           <p:cNvPr id="3" name="text-2">
             <a:extLst xmlns:a="http://schemas.openxmlformats.org/drawingml/2006/main">
               <a:ext uri="{FF2B5EF4-FFF2-40B4-BE49-F238E27FC236}">
-                <a16:creationId xmlns:a16="http://schemas.microsoft.com/office/drawing/2014/main" id="{986C6453-EF6D-4E1A-95EE-7C5CC28E4BE4}"/>
+                <a16:creationId xmlns:a16="http://schemas.microsoft.com/office/drawing/2014/main" id="{4E969184-9DC1-4B84-B099-9D9CF1D2544E}"/>
               </a:ext>
             </a:extLst>
           </p:cNvPr>
@@ -16467,7 +16477,7 @@
           <p:cNvPr id="4" name="text-3">
             <a:extLst xmlns:a="http://schemas.openxmlformats.org/drawingml/2006/main">
               <a:ext uri="{FF2B5EF4-FFF2-40B4-BE49-F238E27FC236}">
-                <a16:creationId xmlns:a16="http://schemas.microsoft.com/office/drawing/2014/main" id="{C60A26B9-CD37-4D7D-9CF8-FC502A09D8DD}"/>
+                <a16:creationId xmlns:a16="http://schemas.microsoft.com/office/drawing/2014/main" id="{82415079-62CB-475D-9B4E-B1878CA43CA9}"/>
               </a:ext>
             </a:extLst>
           </p:cNvPr>
@@ -16533,7 +16543,7 @@
           <p:cNvPr id="5" name="text-4">
             <a:extLst xmlns:a="http://schemas.openxmlformats.org/drawingml/2006/main">
               <a:ext uri="{FF2B5EF4-FFF2-40B4-BE49-F238E27FC236}">
-                <a16:creationId xmlns:a16="http://schemas.microsoft.com/office/drawing/2014/main" id="{B282CB37-626C-4A5D-A6BC-501334D3D4A9}"/>
+                <a16:creationId xmlns:a16="http://schemas.microsoft.com/office/drawing/2014/main" id="{55478EA4-500F-4348-87A5-31EA2109C18C}"/>
               </a:ext>
             </a:extLst>
           </p:cNvPr>
@@ -16599,7 +16609,7 @@
           <p:cNvPr id="6" name="text-5">
             <a:extLst xmlns:a="http://schemas.openxmlformats.org/drawingml/2006/main">
               <a:ext uri="{FF2B5EF4-FFF2-40B4-BE49-F238E27FC236}">
-                <a16:creationId xmlns:a16="http://schemas.microsoft.com/office/drawing/2014/main" id="{15E0F9A5-1EEF-4D04-89D1-52FDAF1E4DF6}"/>
+                <a16:creationId xmlns:a16="http://schemas.microsoft.com/office/drawing/2014/main" id="{A91A7BD1-F43E-4A85-ABA8-8E387CF49ECA}"/>
               </a:ext>
             </a:extLst>
           </p:cNvPr>
@@ -16665,7 +16675,7 @@
           <p:cNvPr id="7" name="text-6">
             <a:extLst xmlns:a="http://schemas.openxmlformats.org/drawingml/2006/main">
               <a:ext uri="{FF2B5EF4-FFF2-40B4-BE49-F238E27FC236}">
-                <a16:creationId xmlns:a16="http://schemas.microsoft.com/office/drawing/2014/main" id="{9A66ABF6-D6D4-431B-AE20-617DC7B1521E}"/>
+                <a16:creationId xmlns:a16="http://schemas.microsoft.com/office/drawing/2014/main" id="{2AB9AE7E-1135-4C08-A780-CB87E7535DF0}"/>
               </a:ext>
             </a:extLst>
           </p:cNvPr>
@@ -16731,7 +16741,7 @@
           <p:cNvPr id="8" name="text-7">
             <a:extLst xmlns:a="http://schemas.openxmlformats.org/drawingml/2006/main">
               <a:ext uri="{FF2B5EF4-FFF2-40B4-BE49-F238E27FC236}">
-                <a16:creationId xmlns:a16="http://schemas.microsoft.com/office/drawing/2014/main" id="{8A931D9D-A5BC-437F-97E6-3588AA7266F7}"/>
+                <a16:creationId xmlns:a16="http://schemas.microsoft.com/office/drawing/2014/main" id="{6CEC21B3-167B-48AA-AA20-41C75B90F35C}"/>
               </a:ext>
             </a:extLst>
           </p:cNvPr>
@@ -16797,7 +16807,7 @@
           <p:cNvPr id="9" name="text-8">
             <a:extLst xmlns:a="http://schemas.openxmlformats.org/drawingml/2006/main">
               <a:ext uri="{FF2B5EF4-FFF2-40B4-BE49-F238E27FC236}">
-                <a16:creationId xmlns:a16="http://schemas.microsoft.com/office/drawing/2014/main" id="{9CB00E8D-44FB-440E-A361-AD14A0B74A7C}"/>
+                <a16:creationId xmlns:a16="http://schemas.microsoft.com/office/drawing/2014/main" id="{A2042471-FC14-4CE3-8A64-1F7866B6D50E}"/>
               </a:ext>
             </a:extLst>
           </p:cNvPr>
@@ -16861,7 +16871,7 @@
     </p:spTree>
     <p:extLst>
       <p:ext uri="{BB962C8B-B14F-4D97-AF65-F5344CB8AC3E}">
-        <p14:creationId xmlns:p14="http://schemas.microsoft.com/office/powerpoint/2010/main" val="525992365"/>
+        <p14:creationId xmlns:p14="http://schemas.microsoft.com/office/powerpoint/2010/main" val="1871575070"/>
       </p:ext>
     </p:extLst>
   </p:cSld>
@@ -16892,7 +16902,7 @@
           <p:cNvPr id="10" name="text-0">
             <a:extLst xmlns:a="http://schemas.openxmlformats.org/drawingml/2006/main">
               <a:ext uri="{FF2B5EF4-FFF2-40B4-BE49-F238E27FC236}">
-                <a16:creationId xmlns:a16="http://schemas.microsoft.com/office/drawing/2014/main" id="{6CA70D50-050D-494F-A1A7-63B907A43D3E}"/>
+                <a16:creationId xmlns:a16="http://schemas.microsoft.com/office/drawing/2014/main" id="{1CCD70E4-93C8-4A1B-B07F-C98BA02A2827}"/>
               </a:ext>
             </a:extLst>
           </p:cNvPr>
@@ -16958,7 +16968,7 @@
           <p:cNvPr id="2" name="text-1">
             <a:extLst xmlns:a="http://schemas.openxmlformats.org/drawingml/2006/main">
               <a:ext uri="{FF2B5EF4-FFF2-40B4-BE49-F238E27FC236}">
-                <a16:creationId xmlns:a16="http://schemas.microsoft.com/office/drawing/2014/main" id="{BECD3EFC-925A-4CE4-B608-B0170508F299}"/>
+                <a16:creationId xmlns:a16="http://schemas.microsoft.com/office/drawing/2014/main" id="{7AA46667-2CD3-4A51-890E-B4BE6DABC346}"/>
               </a:ext>
             </a:extLst>
           </p:cNvPr>
@@ -17024,7 +17034,7 @@
           <p:cNvPr id="3" name="text-2">
             <a:extLst xmlns:a="http://schemas.openxmlformats.org/drawingml/2006/main">
               <a:ext uri="{FF2B5EF4-FFF2-40B4-BE49-F238E27FC236}">
-                <a16:creationId xmlns:a16="http://schemas.microsoft.com/office/drawing/2014/main" id="{94719CE0-B977-43BC-8F56-679E2686BCF7}"/>
+                <a16:creationId xmlns:a16="http://schemas.microsoft.com/office/drawing/2014/main" id="{49AEEF01-B748-4E9D-83C8-B03A646F44C7}"/>
               </a:ext>
             </a:extLst>
           </p:cNvPr>
@@ -17090,7 +17100,7 @@
           <p:cNvPr id="4" name="text-3">
             <a:extLst xmlns:a="http://schemas.openxmlformats.org/drawingml/2006/main">
               <a:ext uri="{FF2B5EF4-FFF2-40B4-BE49-F238E27FC236}">
-                <a16:creationId xmlns:a16="http://schemas.microsoft.com/office/drawing/2014/main" id="{DC93A86B-EDB4-4007-8554-E54532896646}"/>
+                <a16:creationId xmlns:a16="http://schemas.microsoft.com/office/drawing/2014/main" id="{89432979-E0B9-4DFA-9B78-99B1641B28A1}"/>
               </a:ext>
             </a:extLst>
           </p:cNvPr>
@@ -17156,7 +17166,7 @@
           <p:cNvPr id="5" name="text-4">
             <a:extLst xmlns:a="http://schemas.openxmlformats.org/drawingml/2006/main">
               <a:ext uri="{FF2B5EF4-FFF2-40B4-BE49-F238E27FC236}">
-                <a16:creationId xmlns:a16="http://schemas.microsoft.com/office/drawing/2014/main" id="{DBB9F375-2AE1-4068-8430-98FBA552E5DD}"/>
+                <a16:creationId xmlns:a16="http://schemas.microsoft.com/office/drawing/2014/main" id="{34994C9A-BBAC-4D22-8AB1-DA07CA05534C}"/>
               </a:ext>
             </a:extLst>
           </p:cNvPr>
@@ -17222,7 +17232,7 @@
           <p:cNvPr id="6" name="text-5">
             <a:extLst xmlns:a="http://schemas.openxmlformats.org/drawingml/2006/main">
               <a:ext uri="{FF2B5EF4-FFF2-40B4-BE49-F238E27FC236}">
-                <a16:creationId xmlns:a16="http://schemas.microsoft.com/office/drawing/2014/main" id="{8CC2B0D6-3EE7-4054-B8F0-11536D1BB676}"/>
+                <a16:creationId xmlns:a16="http://schemas.microsoft.com/office/drawing/2014/main" id="{3E5A202F-3329-4036-9902-31371BEAE41B}"/>
               </a:ext>
             </a:extLst>
           </p:cNvPr>
@@ -17288,7 +17298,7 @@
           <p:cNvPr id="7" name="text-6">
             <a:extLst xmlns:a="http://schemas.openxmlformats.org/drawingml/2006/main">
               <a:ext uri="{FF2B5EF4-FFF2-40B4-BE49-F238E27FC236}">
-                <a16:creationId xmlns:a16="http://schemas.microsoft.com/office/drawing/2014/main" id="{E32A463F-1E1C-40CE-803A-891E9F30156A}"/>
+                <a16:creationId xmlns:a16="http://schemas.microsoft.com/office/drawing/2014/main" id="{C988403F-8269-482E-AAE8-2931E1889721}"/>
               </a:ext>
             </a:extLst>
           </p:cNvPr>
@@ -17354,7 +17364,7 @@
           <p:cNvPr id="8" name="text-7">
             <a:extLst xmlns:a="http://schemas.openxmlformats.org/drawingml/2006/main">
               <a:ext uri="{FF2B5EF4-FFF2-40B4-BE49-F238E27FC236}">
-                <a16:creationId xmlns:a16="http://schemas.microsoft.com/office/drawing/2014/main" id="{660E4DDC-B546-44CB-A5A0-0B1F02C14D78}"/>
+                <a16:creationId xmlns:a16="http://schemas.microsoft.com/office/drawing/2014/main" id="{CBE70954-9082-4431-BBB4-CBD86F5FDDCD}"/>
               </a:ext>
             </a:extLst>
           </p:cNvPr>
@@ -17420,7 +17430,7 @@
           <p:cNvPr id="9" name="text-8">
             <a:extLst xmlns:a="http://schemas.openxmlformats.org/drawingml/2006/main">
               <a:ext uri="{FF2B5EF4-FFF2-40B4-BE49-F238E27FC236}">
-                <a16:creationId xmlns:a16="http://schemas.microsoft.com/office/drawing/2014/main" id="{F3A44F25-CF81-4869-8FD3-63BBF00D0928}"/>
+                <a16:creationId xmlns:a16="http://schemas.microsoft.com/office/drawing/2014/main" id="{37F9DAB3-7460-4CD6-8727-8C9AC141212D}"/>
               </a:ext>
             </a:extLst>
           </p:cNvPr>
@@ -17484,7 +17494,7 @@
     </p:spTree>
     <p:extLst>
       <p:ext uri="{BB962C8B-B14F-4D97-AF65-F5344CB8AC3E}">
-        <p14:creationId xmlns:p14="http://schemas.microsoft.com/office/powerpoint/2010/main" val="2010822411"/>
+        <p14:creationId xmlns:p14="http://schemas.microsoft.com/office/powerpoint/2010/main" val="336971415"/>
       </p:ext>
     </p:extLst>
   </p:cSld>
@@ -17515,7 +17525,7 @@
           <p:cNvPr id="5" name="text-0">
             <a:extLst xmlns:a="http://schemas.openxmlformats.org/drawingml/2006/main">
               <a:ext uri="{FF2B5EF4-FFF2-40B4-BE49-F238E27FC236}">
-                <a16:creationId xmlns:a16="http://schemas.microsoft.com/office/drawing/2014/main" id="{C73677A4-34E1-4DB2-B204-883C45315557}"/>
+                <a16:creationId xmlns:a16="http://schemas.microsoft.com/office/drawing/2014/main" id="{DE9318D0-F7C8-428B-A06D-75A37753B5A4}"/>
               </a:ext>
             </a:extLst>
           </p:cNvPr>
@@ -17581,7 +17591,7 @@
           <p:cNvPr id="2" name="">
             <a:extLst xmlns:a="http://schemas.openxmlformats.org/drawingml/2006/main">
               <a:ext uri="{FF2B5EF4-FFF2-40B4-BE49-F238E27FC236}">
-                <a16:creationId xmlns:a16="http://schemas.microsoft.com/office/drawing/2014/main" id="{4FC664D7-0FC4-4EAC-8906-E3E3F521DF70}"/>
+                <a16:creationId xmlns:a16="http://schemas.microsoft.com/office/drawing/2014/main" id="{986418F9-7C6E-4967-AA84-A4A9803A1C97}"/>
               </a:ext>
             </a:extLst>
           </p:cNvPr>
@@ -17980,7 +17990,7 @@
           <p:cNvPr id="3" name="text-1">
             <a:extLst xmlns:a="http://schemas.openxmlformats.org/drawingml/2006/main">
               <a:ext uri="{FF2B5EF4-FFF2-40B4-BE49-F238E27FC236}">
-                <a16:creationId xmlns:a16="http://schemas.microsoft.com/office/drawing/2014/main" id="{820CD9D2-58EA-4715-BCD3-B7238CCB5ABD}"/>
+                <a16:creationId xmlns:a16="http://schemas.microsoft.com/office/drawing/2014/main" id="{42D14F19-F7D1-415F-A740-A53CB151CCB7}"/>
               </a:ext>
             </a:extLst>
           </p:cNvPr>
@@ -18046,7 +18056,7 @@
           <p:cNvPr id="4" name="text-2">
             <a:extLst xmlns:a="http://schemas.openxmlformats.org/drawingml/2006/main">
               <a:ext uri="{FF2B5EF4-FFF2-40B4-BE49-F238E27FC236}">
-                <a16:creationId xmlns:a16="http://schemas.microsoft.com/office/drawing/2014/main" id="{A1F447DD-B27A-4938-A2E9-6AADC348A549}"/>
+                <a16:creationId xmlns:a16="http://schemas.microsoft.com/office/drawing/2014/main" id="{5FF71648-E358-407E-A7BD-FEB69DB5048F}"/>
               </a:ext>
             </a:extLst>
           </p:cNvPr>
@@ -18110,7 +18120,7 @@
     </p:spTree>
     <p:extLst>
       <p:ext uri="{BB962C8B-B14F-4D97-AF65-F5344CB8AC3E}">
-        <p14:creationId xmlns:p14="http://schemas.microsoft.com/office/powerpoint/2010/main" val="142387649"/>
+        <p14:creationId xmlns:p14="http://schemas.microsoft.com/office/powerpoint/2010/main" val="1042206346"/>
       </p:ext>
     </p:extLst>
   </p:cSld>
@@ -18141,7 +18151,7 @@
           <p:cNvPr id="10" name="text-0">
             <a:extLst xmlns:a="http://schemas.openxmlformats.org/drawingml/2006/main">
               <a:ext uri="{FF2B5EF4-FFF2-40B4-BE49-F238E27FC236}">
-                <a16:creationId xmlns:a16="http://schemas.microsoft.com/office/drawing/2014/main" id="{9C480894-3A52-4ECF-9696-0A39A6AB3B2B}"/>
+                <a16:creationId xmlns:a16="http://schemas.microsoft.com/office/drawing/2014/main" id="{7D8F0586-B21F-4CEF-8970-02F41831A38C}"/>
               </a:ext>
             </a:extLst>
           </p:cNvPr>
@@ -18207,7 +18217,7 @@
           <p:cNvPr id="2" name="text-1">
             <a:extLst xmlns:a="http://schemas.openxmlformats.org/drawingml/2006/main">
               <a:ext uri="{FF2B5EF4-FFF2-40B4-BE49-F238E27FC236}">
-                <a16:creationId xmlns:a16="http://schemas.microsoft.com/office/drawing/2014/main" id="{490AD7D0-614B-4DB4-B15B-3CEBAE7B88A1}"/>
+                <a16:creationId xmlns:a16="http://schemas.microsoft.com/office/drawing/2014/main" id="{8717572A-2C53-48DA-AF1C-A81D88FE7C69}"/>
               </a:ext>
             </a:extLst>
           </p:cNvPr>
@@ -18273,7 +18283,7 @@
           <p:cNvPr id="3" name="text-2">
             <a:extLst xmlns:a="http://schemas.openxmlformats.org/drawingml/2006/main">
               <a:ext uri="{FF2B5EF4-FFF2-40B4-BE49-F238E27FC236}">
-                <a16:creationId xmlns:a16="http://schemas.microsoft.com/office/drawing/2014/main" id="{D2B192DD-384C-4199-8976-C75761922C33}"/>
+                <a16:creationId xmlns:a16="http://schemas.microsoft.com/office/drawing/2014/main" id="{94BFC576-2449-42B0-AEA6-8A06993662FD}"/>
               </a:ext>
             </a:extLst>
           </p:cNvPr>
@@ -18339,7 +18349,7 @@
           <p:cNvPr id="4" name="text-3">
             <a:extLst xmlns:a="http://schemas.openxmlformats.org/drawingml/2006/main">
               <a:ext uri="{FF2B5EF4-FFF2-40B4-BE49-F238E27FC236}">
-                <a16:creationId xmlns:a16="http://schemas.microsoft.com/office/drawing/2014/main" id="{B108FD8B-1F0E-4F98-A06A-EE348EBED55C}"/>
+                <a16:creationId xmlns:a16="http://schemas.microsoft.com/office/drawing/2014/main" id="{594223ED-BE82-456C-912A-88689EFBC39C}"/>
               </a:ext>
             </a:extLst>
           </p:cNvPr>
@@ -18405,7 +18415,7 @@
           <p:cNvPr id="5" name="text-4">
             <a:extLst xmlns:a="http://schemas.openxmlformats.org/drawingml/2006/main">
               <a:ext uri="{FF2B5EF4-FFF2-40B4-BE49-F238E27FC236}">
-                <a16:creationId xmlns:a16="http://schemas.microsoft.com/office/drawing/2014/main" id="{28D4DEB0-F6C1-4B3A-830F-718401558B89}"/>
+                <a16:creationId xmlns:a16="http://schemas.microsoft.com/office/drawing/2014/main" id="{A80659A5-7BF6-4B0C-B7DD-7E0F07B423BF}"/>
               </a:ext>
             </a:extLst>
           </p:cNvPr>
@@ -18471,7 +18481,7 @@
           <p:cNvPr id="6" name="text-5">
             <a:extLst xmlns:a="http://schemas.openxmlformats.org/drawingml/2006/main">
               <a:ext uri="{FF2B5EF4-FFF2-40B4-BE49-F238E27FC236}">
-                <a16:creationId xmlns:a16="http://schemas.microsoft.com/office/drawing/2014/main" id="{4576C2A8-AFC3-4B65-8B29-8A35CDB4CD74}"/>
+                <a16:creationId xmlns:a16="http://schemas.microsoft.com/office/drawing/2014/main" id="{0E492A75-E414-4B52-AEF3-F2D9F952164D}"/>
               </a:ext>
             </a:extLst>
           </p:cNvPr>
@@ -18537,7 +18547,7 @@
           <p:cNvPr id="7" name="text-6">
             <a:extLst xmlns:a="http://schemas.openxmlformats.org/drawingml/2006/main">
               <a:ext uri="{FF2B5EF4-FFF2-40B4-BE49-F238E27FC236}">
-                <a16:creationId xmlns:a16="http://schemas.microsoft.com/office/drawing/2014/main" id="{884F2E88-B348-4896-8434-A6F91EE70B4E}"/>
+                <a16:creationId xmlns:a16="http://schemas.microsoft.com/office/drawing/2014/main" id="{223312D5-D592-419E-97E5-E3514813C464}"/>
               </a:ext>
             </a:extLst>
           </p:cNvPr>
@@ -18603,7 +18613,7 @@
           <p:cNvPr id="8" name="text-7">
             <a:extLst xmlns:a="http://schemas.openxmlformats.org/drawingml/2006/main">
               <a:ext uri="{FF2B5EF4-FFF2-40B4-BE49-F238E27FC236}">
-                <a16:creationId xmlns:a16="http://schemas.microsoft.com/office/drawing/2014/main" id="{AEE5704C-5751-488A-B1E2-07B0332E3268}"/>
+                <a16:creationId xmlns:a16="http://schemas.microsoft.com/office/drawing/2014/main" id="{095FE194-A4D2-4314-BD55-33C0DAA48661}"/>
               </a:ext>
             </a:extLst>
           </p:cNvPr>
@@ -18669,7 +18679,7 @@
           <p:cNvPr id="9" name="text-8">
             <a:extLst xmlns:a="http://schemas.openxmlformats.org/drawingml/2006/main">
               <a:ext uri="{FF2B5EF4-FFF2-40B4-BE49-F238E27FC236}">
-                <a16:creationId xmlns:a16="http://schemas.microsoft.com/office/drawing/2014/main" id="{06C14008-A6CC-422E-9CE5-C2B722658703}"/>
+                <a16:creationId xmlns:a16="http://schemas.microsoft.com/office/drawing/2014/main" id="{E9167113-83C1-40B5-A08E-2CBFD6E02F85}"/>
               </a:ext>
             </a:extLst>
           </p:cNvPr>
@@ -18733,7 +18743,7 @@
     </p:spTree>
     <p:extLst>
       <p:ext uri="{BB962C8B-B14F-4D97-AF65-F5344CB8AC3E}">
-        <p14:creationId xmlns:p14="http://schemas.microsoft.com/office/powerpoint/2010/main" val="1844966947"/>
+        <p14:creationId xmlns:p14="http://schemas.microsoft.com/office/powerpoint/2010/main" val="262337099"/>
       </p:ext>
     </p:extLst>
   </p:cSld>
@@ -18764,7 +18774,7 @@
           <p:cNvPr id="10" name="text-0">
             <a:extLst xmlns:a="http://schemas.openxmlformats.org/drawingml/2006/main">
               <a:ext uri="{FF2B5EF4-FFF2-40B4-BE49-F238E27FC236}">
-                <a16:creationId xmlns:a16="http://schemas.microsoft.com/office/drawing/2014/main" id="{D540D55F-502A-472E-BD0F-B6CFABEFC33A}"/>
+                <a16:creationId xmlns:a16="http://schemas.microsoft.com/office/drawing/2014/main" id="{289B8CB2-AB9E-4EF4-ADDE-F614FE6B33B1}"/>
               </a:ext>
             </a:extLst>
           </p:cNvPr>
@@ -18830,7 +18840,7 @@
           <p:cNvPr id="2" name="text-1">
             <a:extLst xmlns:a="http://schemas.openxmlformats.org/drawingml/2006/main">
               <a:ext uri="{FF2B5EF4-FFF2-40B4-BE49-F238E27FC236}">
-                <a16:creationId xmlns:a16="http://schemas.microsoft.com/office/drawing/2014/main" id="{3EFB7C41-05B7-425D-BF5B-AED559397E03}"/>
+                <a16:creationId xmlns:a16="http://schemas.microsoft.com/office/drawing/2014/main" id="{97DFA019-FB12-4B7F-AEE1-43896B0693A0}"/>
               </a:ext>
             </a:extLst>
           </p:cNvPr>
@@ -18896,7 +18906,7 @@
           <p:cNvPr id="3" name="text-2">
             <a:extLst xmlns:a="http://schemas.openxmlformats.org/drawingml/2006/main">
               <a:ext uri="{FF2B5EF4-FFF2-40B4-BE49-F238E27FC236}">
-                <a16:creationId xmlns:a16="http://schemas.microsoft.com/office/drawing/2014/main" id="{73A91CA1-0EDD-4615-A1E9-A491A85E499E}"/>
+                <a16:creationId xmlns:a16="http://schemas.microsoft.com/office/drawing/2014/main" id="{D51D42EC-51CE-41C4-8D04-D68DBE186012}"/>
               </a:ext>
             </a:extLst>
           </p:cNvPr>
@@ -18962,7 +18972,7 @@
           <p:cNvPr id="4" name="text-3">
             <a:extLst xmlns:a="http://schemas.openxmlformats.org/drawingml/2006/main">
               <a:ext uri="{FF2B5EF4-FFF2-40B4-BE49-F238E27FC236}">
-                <a16:creationId xmlns:a16="http://schemas.microsoft.com/office/drawing/2014/main" id="{E4768D1B-34BC-4D7B-909F-6F8871743E77}"/>
+                <a16:creationId xmlns:a16="http://schemas.microsoft.com/office/drawing/2014/main" id="{9644AED1-36A7-40CA-91DF-C5B5BAF0A288}"/>
               </a:ext>
             </a:extLst>
           </p:cNvPr>
@@ -19028,7 +19038,7 @@
           <p:cNvPr id="5" name="text-4">
             <a:extLst xmlns:a="http://schemas.openxmlformats.org/drawingml/2006/main">
               <a:ext uri="{FF2B5EF4-FFF2-40B4-BE49-F238E27FC236}">
-                <a16:creationId xmlns:a16="http://schemas.microsoft.com/office/drawing/2014/main" id="{AA003FBD-1370-4344-AA81-ABE82BD4E749}"/>
+                <a16:creationId xmlns:a16="http://schemas.microsoft.com/office/drawing/2014/main" id="{80055BF1-91E8-42C7-933A-63FE3104F2EF}"/>
               </a:ext>
             </a:extLst>
           </p:cNvPr>
@@ -19094,7 +19104,7 @@
           <p:cNvPr id="6" name="text-5">
             <a:extLst xmlns:a="http://schemas.openxmlformats.org/drawingml/2006/main">
               <a:ext uri="{FF2B5EF4-FFF2-40B4-BE49-F238E27FC236}">
-                <a16:creationId xmlns:a16="http://schemas.microsoft.com/office/drawing/2014/main" id="{CB0519C5-3915-4FFB-A9EB-76BB32D216D9}"/>
+                <a16:creationId xmlns:a16="http://schemas.microsoft.com/office/drawing/2014/main" id="{729B986F-EAA4-4FB6-81BE-F85CC3BE866F}"/>
               </a:ext>
             </a:extLst>
           </p:cNvPr>
@@ -19160,7 +19170,7 @@
           <p:cNvPr id="7" name="text-6">
             <a:extLst xmlns:a="http://schemas.openxmlformats.org/drawingml/2006/main">
               <a:ext uri="{FF2B5EF4-FFF2-40B4-BE49-F238E27FC236}">
-                <a16:creationId xmlns:a16="http://schemas.microsoft.com/office/drawing/2014/main" id="{0F19A793-8AF4-4939-A2D5-56B4A534B9B8}"/>
+                <a16:creationId xmlns:a16="http://schemas.microsoft.com/office/drawing/2014/main" id="{12FCD058-B83E-4909-BEAA-4ED4A18FFCCA}"/>
               </a:ext>
             </a:extLst>
           </p:cNvPr>
@@ -19226,7 +19236,7 @@
           <p:cNvPr id="8" name="text-7">
             <a:extLst xmlns:a="http://schemas.openxmlformats.org/drawingml/2006/main">
               <a:ext uri="{FF2B5EF4-FFF2-40B4-BE49-F238E27FC236}">
-                <a16:creationId xmlns:a16="http://schemas.microsoft.com/office/drawing/2014/main" id="{20D88693-9DC7-4EF2-BC47-D204A5298F4B}"/>
+                <a16:creationId xmlns:a16="http://schemas.microsoft.com/office/drawing/2014/main" id="{D1D5B556-0F15-4ED5-A066-1214C2D6C201}"/>
               </a:ext>
             </a:extLst>
           </p:cNvPr>
@@ -19292,7 +19302,7 @@
           <p:cNvPr id="9" name="text-8">
             <a:extLst xmlns:a="http://schemas.openxmlformats.org/drawingml/2006/main">
               <a:ext uri="{FF2B5EF4-FFF2-40B4-BE49-F238E27FC236}">
-                <a16:creationId xmlns:a16="http://schemas.microsoft.com/office/drawing/2014/main" id="{6BF15C61-E36F-4BD8-9B53-8E72055F62FB}"/>
+                <a16:creationId xmlns:a16="http://schemas.microsoft.com/office/drawing/2014/main" id="{AAF7DAAF-482C-41D6-8E5C-64BEA18D1D9E}"/>
               </a:ext>
             </a:extLst>
           </p:cNvPr>
@@ -19356,7 +19366,7 @@
     </p:spTree>
     <p:extLst>
       <p:ext uri="{BB962C8B-B14F-4D97-AF65-F5344CB8AC3E}">
-        <p14:creationId xmlns:p14="http://schemas.microsoft.com/office/powerpoint/2010/main" val="1794851102"/>
+        <p14:creationId xmlns:p14="http://schemas.microsoft.com/office/powerpoint/2010/main" val="1690673066"/>
       </p:ext>
     </p:extLst>
   </p:cSld>
@@ -19387,7 +19397,7 @@
           <p:cNvPr id="5" name="text-0">
             <a:extLst xmlns:a="http://schemas.openxmlformats.org/drawingml/2006/main">
               <a:ext uri="{FF2B5EF4-FFF2-40B4-BE49-F238E27FC236}">
-                <a16:creationId xmlns:a16="http://schemas.microsoft.com/office/drawing/2014/main" id="{A1985E18-FC8E-443B-98B8-A7642E77D6D1}"/>
+                <a16:creationId xmlns:a16="http://schemas.microsoft.com/office/drawing/2014/main" id="{9BDD7960-C2FF-47FA-BCE2-ACFCA6EDC854}"/>
               </a:ext>
             </a:extLst>
           </p:cNvPr>
@@ -19453,7 +19463,7 @@
           <p:cNvPr id="2" name="">
             <a:extLst xmlns:a="http://schemas.openxmlformats.org/drawingml/2006/main">
               <a:ext uri="{FF2B5EF4-FFF2-40B4-BE49-F238E27FC236}">
-                <a16:creationId xmlns:a16="http://schemas.microsoft.com/office/drawing/2014/main" id="{EECB5150-81C2-4C21-8881-1451B665C00A}"/>
+                <a16:creationId xmlns:a16="http://schemas.microsoft.com/office/drawing/2014/main" id="{773DDAEC-3D49-4E3D-9111-1202FC35F4B1}"/>
               </a:ext>
             </a:extLst>
           </p:cNvPr>
@@ -19852,7 +19862,7 @@
           <p:cNvPr id="3" name="text-1">
             <a:extLst xmlns:a="http://schemas.openxmlformats.org/drawingml/2006/main">
               <a:ext uri="{FF2B5EF4-FFF2-40B4-BE49-F238E27FC236}">
-                <a16:creationId xmlns:a16="http://schemas.microsoft.com/office/drawing/2014/main" id="{541CD02A-B14E-4410-A862-E72DD4B4F814}"/>
+                <a16:creationId xmlns:a16="http://schemas.microsoft.com/office/drawing/2014/main" id="{26883B16-F5D8-4DDF-9900-3844BAC2B17A}"/>
               </a:ext>
             </a:extLst>
           </p:cNvPr>
@@ -19918,7 +19928,7 @@
           <p:cNvPr id="4" name="text-2">
             <a:extLst xmlns:a="http://schemas.openxmlformats.org/drawingml/2006/main">
               <a:ext uri="{FF2B5EF4-FFF2-40B4-BE49-F238E27FC236}">
-                <a16:creationId xmlns:a16="http://schemas.microsoft.com/office/drawing/2014/main" id="{A0CEFA1F-05EF-42B5-8F2F-A34A7FC8EACC}"/>
+                <a16:creationId xmlns:a16="http://schemas.microsoft.com/office/drawing/2014/main" id="{91B749CC-3184-4641-9F70-93C627B8ED48}"/>
               </a:ext>
             </a:extLst>
           </p:cNvPr>
@@ -19982,7 +19992,7 @@
     </p:spTree>
     <p:extLst>
       <p:ext uri="{BB962C8B-B14F-4D97-AF65-F5344CB8AC3E}">
-        <p14:creationId xmlns:p14="http://schemas.microsoft.com/office/powerpoint/2010/main" val="473402934"/>
+        <p14:creationId xmlns:p14="http://schemas.microsoft.com/office/powerpoint/2010/main" val="560835987"/>
       </p:ext>
     </p:extLst>
   </p:cSld>
@@ -20013,7 +20023,7 @@
           <p:cNvPr id="5" name="text-0">
             <a:extLst xmlns:a="http://schemas.openxmlformats.org/drawingml/2006/main">
               <a:ext uri="{FF2B5EF4-FFF2-40B4-BE49-F238E27FC236}">
-                <a16:creationId xmlns:a16="http://schemas.microsoft.com/office/drawing/2014/main" id="{99C874FF-3EE9-4465-9406-CB9CC76E1DA0}"/>
+                <a16:creationId xmlns:a16="http://schemas.microsoft.com/office/drawing/2014/main" id="{04864A4A-704C-4358-827A-067DDF620F46}"/>
               </a:ext>
             </a:extLst>
           </p:cNvPr>
@@ -20079,7 +20089,7 @@
           <p:cNvPr id="2" name="">
             <a:extLst xmlns:a="http://schemas.openxmlformats.org/drawingml/2006/main">
               <a:ext uri="{FF2B5EF4-FFF2-40B4-BE49-F238E27FC236}">
-                <a16:creationId xmlns:a16="http://schemas.microsoft.com/office/drawing/2014/main" id="{B811D039-5DB6-468A-9FE5-484341C938E8}"/>
+                <a16:creationId xmlns:a16="http://schemas.microsoft.com/office/drawing/2014/main" id="{8EDCB302-1E43-46F9-8DE7-3CA47280945C}"/>
               </a:ext>
             </a:extLst>
           </p:cNvPr>
@@ -20501,7 +20511,7 @@
           <p:cNvPr id="3" name="text-1">
             <a:extLst xmlns:a="http://schemas.openxmlformats.org/drawingml/2006/main">
               <a:ext uri="{FF2B5EF4-FFF2-40B4-BE49-F238E27FC236}">
-                <a16:creationId xmlns:a16="http://schemas.microsoft.com/office/drawing/2014/main" id="{801F734A-4BE2-4308-B919-185714DD65AE}"/>
+                <a16:creationId xmlns:a16="http://schemas.microsoft.com/office/drawing/2014/main" id="{98062F03-FD61-4CE9-BD66-3CD67B32279E}"/>
               </a:ext>
             </a:extLst>
           </p:cNvPr>
@@ -20567,7 +20577,7 @@
           <p:cNvPr id="4" name="text-2">
             <a:extLst xmlns:a="http://schemas.openxmlformats.org/drawingml/2006/main">
               <a:ext uri="{FF2B5EF4-FFF2-40B4-BE49-F238E27FC236}">
-                <a16:creationId xmlns:a16="http://schemas.microsoft.com/office/drawing/2014/main" id="{85A5BA74-4340-4AC8-90EE-8B816B4055E6}"/>
+                <a16:creationId xmlns:a16="http://schemas.microsoft.com/office/drawing/2014/main" id="{11E1F804-6FBB-4ACC-9FBE-FF57D3E0EE8F}"/>
               </a:ext>
             </a:extLst>
           </p:cNvPr>
@@ -20631,7 +20641,7 @@
     </p:spTree>
     <p:extLst>
       <p:ext uri="{BB962C8B-B14F-4D97-AF65-F5344CB8AC3E}">
-        <p14:creationId xmlns:p14="http://schemas.microsoft.com/office/powerpoint/2010/main" val="1471594818"/>
+        <p14:creationId xmlns:p14="http://schemas.microsoft.com/office/powerpoint/2010/main" val="255628181"/>
       </p:ext>
     </p:extLst>
   </p:cSld>
@@ -20662,7 +20672,7 @@
           <p:cNvPr id="10" name="text-0">
             <a:extLst xmlns:a="http://schemas.openxmlformats.org/drawingml/2006/main">
               <a:ext uri="{FF2B5EF4-FFF2-40B4-BE49-F238E27FC236}">
-                <a16:creationId xmlns:a16="http://schemas.microsoft.com/office/drawing/2014/main" id="{83C85C65-2075-44FB-98DB-A6E4F4CB3CC4}"/>
+                <a16:creationId xmlns:a16="http://schemas.microsoft.com/office/drawing/2014/main" id="{E76215E9-6F81-4F3E-9768-1A64C96ED488}"/>
               </a:ext>
             </a:extLst>
           </p:cNvPr>
@@ -20728,7 +20738,7 @@
           <p:cNvPr id="2" name="text-1">
             <a:extLst xmlns:a="http://schemas.openxmlformats.org/drawingml/2006/main">
               <a:ext uri="{FF2B5EF4-FFF2-40B4-BE49-F238E27FC236}">
-                <a16:creationId xmlns:a16="http://schemas.microsoft.com/office/drawing/2014/main" id="{DBBB3F93-E4D7-4D07-B5DE-472D2F31687B}"/>
+                <a16:creationId xmlns:a16="http://schemas.microsoft.com/office/drawing/2014/main" id="{F63D2A9D-C982-4E16-9B7C-813DB237FC98}"/>
               </a:ext>
             </a:extLst>
           </p:cNvPr>
@@ -20794,7 +20804,7 @@
           <p:cNvPr id="3" name="text-2">
             <a:extLst xmlns:a="http://schemas.openxmlformats.org/drawingml/2006/main">
               <a:ext uri="{FF2B5EF4-FFF2-40B4-BE49-F238E27FC236}">
-                <a16:creationId xmlns:a16="http://schemas.microsoft.com/office/drawing/2014/main" id="{257D0CB0-576C-4AB1-943C-6A762C0E6FDC}"/>
+                <a16:creationId xmlns:a16="http://schemas.microsoft.com/office/drawing/2014/main" id="{5BFEB604-4090-4DC5-A497-8099725DBA97}"/>
               </a:ext>
             </a:extLst>
           </p:cNvPr>
@@ -20860,7 +20870,7 @@
           <p:cNvPr id="4" name="text-3">
             <a:extLst xmlns:a="http://schemas.openxmlformats.org/drawingml/2006/main">
               <a:ext uri="{FF2B5EF4-FFF2-40B4-BE49-F238E27FC236}">
-                <a16:creationId xmlns:a16="http://schemas.microsoft.com/office/drawing/2014/main" id="{60FD6E99-8A52-4566-BFE8-ABDA1ABE4E79}"/>
+                <a16:creationId xmlns:a16="http://schemas.microsoft.com/office/drawing/2014/main" id="{71D03968-FDEF-41F2-93BA-77C872013E5D}"/>
               </a:ext>
             </a:extLst>
           </p:cNvPr>
@@ -20926,7 +20936,7 @@
           <p:cNvPr id="5" name="text-4">
             <a:extLst xmlns:a="http://schemas.openxmlformats.org/drawingml/2006/main">
               <a:ext uri="{FF2B5EF4-FFF2-40B4-BE49-F238E27FC236}">
-                <a16:creationId xmlns:a16="http://schemas.microsoft.com/office/drawing/2014/main" id="{E77B48C3-E760-4C79-99F0-8A73ED0D2D1D}"/>
+                <a16:creationId xmlns:a16="http://schemas.microsoft.com/office/drawing/2014/main" id="{40E4EAC6-8C8D-475A-8CCD-98CD440EC1D3}"/>
               </a:ext>
             </a:extLst>
           </p:cNvPr>
@@ -20992,7 +21002,7 @@
           <p:cNvPr id="6" name="text-5">
             <a:extLst xmlns:a="http://schemas.openxmlformats.org/drawingml/2006/main">
               <a:ext uri="{FF2B5EF4-FFF2-40B4-BE49-F238E27FC236}">
-                <a16:creationId xmlns:a16="http://schemas.microsoft.com/office/drawing/2014/main" id="{ED1C46E2-06C3-407A-945D-940CA1A4649A}"/>
+                <a16:creationId xmlns:a16="http://schemas.microsoft.com/office/drawing/2014/main" id="{5ED90F2F-A2EC-4008-BD0D-03BA2311C5D0}"/>
               </a:ext>
             </a:extLst>
           </p:cNvPr>
@@ -21058,7 +21068,7 @@
           <p:cNvPr id="7" name="text-6">
             <a:extLst xmlns:a="http://schemas.openxmlformats.org/drawingml/2006/main">
               <a:ext uri="{FF2B5EF4-FFF2-40B4-BE49-F238E27FC236}">
-                <a16:creationId xmlns:a16="http://schemas.microsoft.com/office/drawing/2014/main" id="{0B52DD3B-1487-469B-8459-3F4B8671CD64}"/>
+                <a16:creationId xmlns:a16="http://schemas.microsoft.com/office/drawing/2014/main" id="{9DA64EAC-9181-498E-98D3-963E6AB3ED40}"/>
               </a:ext>
             </a:extLst>
           </p:cNvPr>
@@ -21124,7 +21134,7 @@
           <p:cNvPr id="8" name="text-7">
             <a:extLst xmlns:a="http://schemas.openxmlformats.org/drawingml/2006/main">
               <a:ext uri="{FF2B5EF4-FFF2-40B4-BE49-F238E27FC236}">
-                <a16:creationId xmlns:a16="http://schemas.microsoft.com/office/drawing/2014/main" id="{58686BEE-58D0-42CB-876A-BDCC5A6BE1A0}"/>
+                <a16:creationId xmlns:a16="http://schemas.microsoft.com/office/drawing/2014/main" id="{705E4057-E6D7-4618-B817-2EA486846887}"/>
               </a:ext>
             </a:extLst>
           </p:cNvPr>
@@ -21190,7 +21200,7 @@
           <p:cNvPr id="9" name="text-8">
             <a:extLst xmlns:a="http://schemas.openxmlformats.org/drawingml/2006/main">
               <a:ext uri="{FF2B5EF4-FFF2-40B4-BE49-F238E27FC236}">
-                <a16:creationId xmlns:a16="http://schemas.microsoft.com/office/drawing/2014/main" id="{C50B4C2B-7EE6-48D1-81BD-6119D2E86C07}"/>
+                <a16:creationId xmlns:a16="http://schemas.microsoft.com/office/drawing/2014/main" id="{EF13F8A2-B609-4BF4-8096-C7A12BC8423A}"/>
               </a:ext>
             </a:extLst>
           </p:cNvPr>
@@ -21254,7 +21264,7 @@
     </p:spTree>
     <p:extLst>
       <p:ext uri="{BB962C8B-B14F-4D97-AF65-F5344CB8AC3E}">
-        <p14:creationId xmlns:p14="http://schemas.microsoft.com/office/powerpoint/2010/main" val="2046752100"/>
+        <p14:creationId xmlns:p14="http://schemas.microsoft.com/office/powerpoint/2010/main" val="444712809"/>
       </p:ext>
     </p:extLst>
   </p:cSld>
@@ -21285,7 +21295,7 @@
           <p:cNvPr id="5" name="text-0">
             <a:extLst xmlns:a="http://schemas.openxmlformats.org/drawingml/2006/main">
               <a:ext uri="{FF2B5EF4-FFF2-40B4-BE49-F238E27FC236}">
-                <a16:creationId xmlns:a16="http://schemas.microsoft.com/office/drawing/2014/main" id="{A4824F1A-9AAC-43F3-9A64-F71F31E064CF}"/>
+                <a16:creationId xmlns:a16="http://schemas.microsoft.com/office/drawing/2014/main" id="{CB5F50EC-EB62-4B4A-A0EF-4B2D9CA8CC7D}"/>
               </a:ext>
             </a:extLst>
           </p:cNvPr>
@@ -21351,7 +21361,7 @@
           <p:cNvPr id="2" name="">
             <a:extLst xmlns:a="http://schemas.openxmlformats.org/drawingml/2006/main">
               <a:ext uri="{FF2B5EF4-FFF2-40B4-BE49-F238E27FC236}">
-                <a16:creationId xmlns:a16="http://schemas.microsoft.com/office/drawing/2014/main" id="{13588B66-CB17-4BE7-9CBB-3C4C29342504}"/>
+                <a16:creationId xmlns:a16="http://schemas.microsoft.com/office/drawing/2014/main" id="{87AB576D-128D-444E-9749-E49CFE8D787E}"/>
               </a:ext>
             </a:extLst>
           </p:cNvPr>
@@ -21676,7 +21686,7 @@
           <p:cNvPr id="3" name="text-1">
             <a:extLst xmlns:a="http://schemas.openxmlformats.org/drawingml/2006/main">
               <a:ext uri="{FF2B5EF4-FFF2-40B4-BE49-F238E27FC236}">
-                <a16:creationId xmlns:a16="http://schemas.microsoft.com/office/drawing/2014/main" id="{B2773391-D08E-4008-A865-60DCE398ACE7}"/>
+                <a16:creationId xmlns:a16="http://schemas.microsoft.com/office/drawing/2014/main" id="{5FD5BDE9-D5DB-4081-A40B-F091DF4D9E5A}"/>
               </a:ext>
             </a:extLst>
           </p:cNvPr>
@@ -21742,7 +21752,7 @@
           <p:cNvPr id="4" name="text-2">
             <a:extLst xmlns:a="http://schemas.openxmlformats.org/drawingml/2006/main">
               <a:ext uri="{FF2B5EF4-FFF2-40B4-BE49-F238E27FC236}">
-                <a16:creationId xmlns:a16="http://schemas.microsoft.com/office/drawing/2014/main" id="{A1F8C08F-410D-4931-9FB3-C2FAF777E264}"/>
+                <a16:creationId xmlns:a16="http://schemas.microsoft.com/office/drawing/2014/main" id="{F1455C13-1737-40A7-AECF-0E36C1AE7722}"/>
               </a:ext>
             </a:extLst>
           </p:cNvPr>
@@ -21806,7 +21816,7 @@
     </p:spTree>
     <p:extLst>
       <p:ext uri="{BB962C8B-B14F-4D97-AF65-F5344CB8AC3E}">
-        <p14:creationId xmlns:p14="http://schemas.microsoft.com/office/powerpoint/2010/main" val="779534122"/>
+        <p14:creationId xmlns:p14="http://schemas.microsoft.com/office/powerpoint/2010/main" val="802536252"/>
       </p:ext>
     </p:extLst>
   </p:cSld>
@@ -21837,7 +21847,7 @@
           <p:cNvPr id="10" name="text-0">
             <a:extLst xmlns:a="http://schemas.openxmlformats.org/drawingml/2006/main">
               <a:ext uri="{FF2B5EF4-FFF2-40B4-BE49-F238E27FC236}">
-                <a16:creationId xmlns:a16="http://schemas.microsoft.com/office/drawing/2014/main" id="{9D2D6A0D-F5D4-4A3C-8394-E93F6050A2A3}"/>
+                <a16:creationId xmlns:a16="http://schemas.microsoft.com/office/drawing/2014/main" id="{1A76944D-117B-4B48-968E-C9041AA56DF7}"/>
               </a:ext>
             </a:extLst>
           </p:cNvPr>
@@ -21903,7 +21913,7 @@
           <p:cNvPr id="2" name="text-1">
             <a:extLst xmlns:a="http://schemas.openxmlformats.org/drawingml/2006/main">
               <a:ext uri="{FF2B5EF4-FFF2-40B4-BE49-F238E27FC236}">
-                <a16:creationId xmlns:a16="http://schemas.microsoft.com/office/drawing/2014/main" id="{7C5EECF1-161F-4CB9-AED4-B25574C85D13}"/>
+                <a16:creationId xmlns:a16="http://schemas.microsoft.com/office/drawing/2014/main" id="{60B476F3-4AD7-4670-B8B5-D0A35ADBF5DA}"/>
               </a:ext>
             </a:extLst>
           </p:cNvPr>
@@ -21969,7 +21979,7 @@
           <p:cNvPr id="3" name="text-2">
             <a:extLst xmlns:a="http://schemas.openxmlformats.org/drawingml/2006/main">
               <a:ext uri="{FF2B5EF4-FFF2-40B4-BE49-F238E27FC236}">
-                <a16:creationId xmlns:a16="http://schemas.microsoft.com/office/drawing/2014/main" id="{BD91BF7C-09E2-4923-8D17-98AA7315EE9E}"/>
+                <a16:creationId xmlns:a16="http://schemas.microsoft.com/office/drawing/2014/main" id="{90B65B95-1963-468D-B0EC-A30DB7C9FE9D}"/>
               </a:ext>
             </a:extLst>
           </p:cNvPr>
@@ -22035,7 +22045,7 @@
           <p:cNvPr id="4" name="text-3">
             <a:extLst xmlns:a="http://schemas.openxmlformats.org/drawingml/2006/main">
               <a:ext uri="{FF2B5EF4-FFF2-40B4-BE49-F238E27FC236}">
-                <a16:creationId xmlns:a16="http://schemas.microsoft.com/office/drawing/2014/main" id="{082024EC-0BDB-4431-AC61-876FC5A6C5CE}"/>
+                <a16:creationId xmlns:a16="http://schemas.microsoft.com/office/drawing/2014/main" id="{27CE1DA9-8170-4F3D-BC0B-1BCA4F047F12}"/>
               </a:ext>
             </a:extLst>
           </p:cNvPr>
@@ -22101,7 +22111,7 @@
           <p:cNvPr id="5" name="text-4">
             <a:extLst xmlns:a="http://schemas.openxmlformats.org/drawingml/2006/main">
               <a:ext uri="{FF2B5EF4-FFF2-40B4-BE49-F238E27FC236}">
-                <a16:creationId xmlns:a16="http://schemas.microsoft.com/office/drawing/2014/main" id="{B956AF5A-AB0A-4429-80AE-7B44C04DE1E1}"/>
+                <a16:creationId xmlns:a16="http://schemas.microsoft.com/office/drawing/2014/main" id="{9A6FB34A-2D60-4C61-8F84-6E3DAA4C7C21}"/>
               </a:ext>
             </a:extLst>
           </p:cNvPr>
@@ -22167,7 +22177,7 @@
           <p:cNvPr id="6" name="text-5">
             <a:extLst xmlns:a="http://schemas.openxmlformats.org/drawingml/2006/main">
               <a:ext uri="{FF2B5EF4-FFF2-40B4-BE49-F238E27FC236}">
-                <a16:creationId xmlns:a16="http://schemas.microsoft.com/office/drawing/2014/main" id="{C79681D9-C732-4B36-A563-D95200472C9D}"/>
+                <a16:creationId xmlns:a16="http://schemas.microsoft.com/office/drawing/2014/main" id="{518F4AB8-B0A6-4B19-904B-86B914019D61}"/>
               </a:ext>
             </a:extLst>
           </p:cNvPr>
@@ -22233,7 +22243,7 @@
           <p:cNvPr id="7" name="text-6">
             <a:extLst xmlns:a="http://schemas.openxmlformats.org/drawingml/2006/main">
               <a:ext uri="{FF2B5EF4-FFF2-40B4-BE49-F238E27FC236}">
-                <a16:creationId xmlns:a16="http://schemas.microsoft.com/office/drawing/2014/main" id="{950841A9-15F7-4BF2-B819-0A9436F19744}"/>
+                <a16:creationId xmlns:a16="http://schemas.microsoft.com/office/drawing/2014/main" id="{0A56B857-EB0C-406E-9425-4FF114CB1B70}"/>
               </a:ext>
             </a:extLst>
           </p:cNvPr>
@@ -22299,7 +22309,7 @@
           <p:cNvPr id="8" name="text-7">
             <a:extLst xmlns:a="http://schemas.openxmlformats.org/drawingml/2006/main">
               <a:ext uri="{FF2B5EF4-FFF2-40B4-BE49-F238E27FC236}">
-                <a16:creationId xmlns:a16="http://schemas.microsoft.com/office/drawing/2014/main" id="{AD6A64BE-630E-4E1D-B467-BD97D9D5E913}"/>
+                <a16:creationId xmlns:a16="http://schemas.microsoft.com/office/drawing/2014/main" id="{CF3C6E09-F4EF-4DFF-BBF8-4867C5013756}"/>
               </a:ext>
             </a:extLst>
           </p:cNvPr>
@@ -22365,7 +22375,7 @@
           <p:cNvPr id="9" name="text-8">
             <a:extLst xmlns:a="http://schemas.openxmlformats.org/drawingml/2006/main">
               <a:ext uri="{FF2B5EF4-FFF2-40B4-BE49-F238E27FC236}">
-                <a16:creationId xmlns:a16="http://schemas.microsoft.com/office/drawing/2014/main" id="{7B1238CB-98CD-4750-9DCB-F48F5EADCFB7}"/>
+                <a16:creationId xmlns:a16="http://schemas.microsoft.com/office/drawing/2014/main" id="{E61CDB94-9DD8-4AD7-ABF0-46C428A3EEB7}"/>
               </a:ext>
             </a:extLst>
           </p:cNvPr>
@@ -22429,7 +22439,7 @@
     </p:spTree>
     <p:extLst>
       <p:ext uri="{BB962C8B-B14F-4D97-AF65-F5344CB8AC3E}">
-        <p14:creationId xmlns:p14="http://schemas.microsoft.com/office/powerpoint/2010/main" val="495030375"/>
+        <p14:creationId xmlns:p14="http://schemas.microsoft.com/office/powerpoint/2010/main" val="2076091099"/>
       </p:ext>
     </p:extLst>
   </p:cSld>
@@ -22460,7 +22470,7 @@
           <p:cNvPr id="10" name="text-0">
             <a:extLst xmlns:a="http://schemas.openxmlformats.org/drawingml/2006/main">
               <a:ext uri="{FF2B5EF4-FFF2-40B4-BE49-F238E27FC236}">
-                <a16:creationId xmlns:a16="http://schemas.microsoft.com/office/drawing/2014/main" id="{89239E4C-A55D-42C1-BDFD-8CF2BE07FB39}"/>
+                <a16:creationId xmlns:a16="http://schemas.microsoft.com/office/drawing/2014/main" id="{F218B855-D124-4350-A404-91CBFBE93CEA}"/>
               </a:ext>
             </a:extLst>
           </p:cNvPr>
@@ -22526,7 +22536,7 @@
           <p:cNvPr id="2" name="text-1">
             <a:extLst xmlns:a="http://schemas.openxmlformats.org/drawingml/2006/main">
               <a:ext uri="{FF2B5EF4-FFF2-40B4-BE49-F238E27FC236}">
-                <a16:creationId xmlns:a16="http://schemas.microsoft.com/office/drawing/2014/main" id="{2774BC9C-5010-4760-860D-F63D1918C1EF}"/>
+                <a16:creationId xmlns:a16="http://schemas.microsoft.com/office/drawing/2014/main" id="{8784B626-D387-4AB5-9D7C-AEBB5CB9CA27}"/>
               </a:ext>
             </a:extLst>
           </p:cNvPr>
@@ -22592,7 +22602,7 @@
           <p:cNvPr id="3" name="text-2">
             <a:extLst xmlns:a="http://schemas.openxmlformats.org/drawingml/2006/main">
               <a:ext uri="{FF2B5EF4-FFF2-40B4-BE49-F238E27FC236}">
-                <a16:creationId xmlns:a16="http://schemas.microsoft.com/office/drawing/2014/main" id="{5F32299B-3254-4344-9160-FFECC7BDAB37}"/>
+                <a16:creationId xmlns:a16="http://schemas.microsoft.com/office/drawing/2014/main" id="{E065988F-0CF0-49E8-84D5-9EEF3F3B97D9}"/>
               </a:ext>
             </a:extLst>
           </p:cNvPr>
@@ -22658,7 +22668,7 @@
           <p:cNvPr id="4" name="text-3">
             <a:extLst xmlns:a="http://schemas.openxmlformats.org/drawingml/2006/main">
               <a:ext uri="{FF2B5EF4-FFF2-40B4-BE49-F238E27FC236}">
-                <a16:creationId xmlns:a16="http://schemas.microsoft.com/office/drawing/2014/main" id="{76B3176F-FFF2-4E03-A6DF-1DF84FAB99F3}"/>
+                <a16:creationId xmlns:a16="http://schemas.microsoft.com/office/drawing/2014/main" id="{7552AC01-69A2-4C52-85DD-7893F38D10C7}"/>
               </a:ext>
             </a:extLst>
           </p:cNvPr>
@@ -22724,7 +22734,7 @@
           <p:cNvPr id="5" name="text-4">
             <a:extLst xmlns:a="http://schemas.openxmlformats.org/drawingml/2006/main">
               <a:ext uri="{FF2B5EF4-FFF2-40B4-BE49-F238E27FC236}">
-                <a16:creationId xmlns:a16="http://schemas.microsoft.com/office/drawing/2014/main" id="{7F8D2EC0-37BB-448D-8A74-1229AB8A9728}"/>
+                <a16:creationId xmlns:a16="http://schemas.microsoft.com/office/drawing/2014/main" id="{D4607AE0-3B81-4996-839F-CDCF6EF6ACE1}"/>
               </a:ext>
             </a:extLst>
           </p:cNvPr>
@@ -22780,7 +22790,7 @@
                 <a:ea typeface="Arial"/>
                 <a:cs typeface="Arial"/>
               </a:rPr>
-              <a:t>Gleiche Results, gebundene Owner-/Readerbeobachtungen, einzelne Reader-Indexnutzung und Owner-INSERT/Rollback.</a:t>
+              <a:t>Gleiche Results, zwei private Original-Readerplanprofile, einzelne Reader-Indexnutzung und Owner-INSERT/Rollback.</a:t>
             </a:r>
           </a:p>
         </p:txBody>
@@ -22790,7 +22800,7 @@
           <p:cNvPr id="6" name="text-5">
             <a:extLst xmlns:a="http://schemas.openxmlformats.org/drawingml/2006/main">
               <a:ext uri="{FF2B5EF4-FFF2-40B4-BE49-F238E27FC236}">
-                <a16:creationId xmlns:a16="http://schemas.microsoft.com/office/drawing/2014/main" id="{53DB3A58-7531-4031-9EBD-B65AB069241F}"/>
+                <a16:creationId xmlns:a16="http://schemas.microsoft.com/office/drawing/2014/main" id="{5A094665-B929-480C-93E0-9DEC2ABB94EC}"/>
               </a:ext>
             </a:extLst>
           </p:cNvPr>
@@ -22856,7 +22866,7 @@
           <p:cNvPr id="7" name="text-6">
             <a:extLst xmlns:a="http://schemas.openxmlformats.org/drawingml/2006/main">
               <a:ext uri="{FF2B5EF4-FFF2-40B4-BE49-F238E27FC236}">
-                <a16:creationId xmlns:a16="http://schemas.microsoft.com/office/drawing/2014/main" id="{64D6C82C-984F-4149-A751-454EBF6CD4B9}"/>
+                <a16:creationId xmlns:a16="http://schemas.microsoft.com/office/drawing/2014/main" id="{C6887287-B5B6-48A3-AB47-2FE43857BFA6}"/>
               </a:ext>
             </a:extLst>
           </p:cNvPr>
@@ -22912,7 +22922,7 @@
                 <a:ea typeface="Arial"/>
                 <a:cs typeface="Arial"/>
               </a:rPr>
-              <a:t>Tatsächliche Readerpläne und vollständiger Indexnettonutzen bleiben NOT_ESTABLISHED.</a:t>
+              <a:t>Vollständige Runtime-/TP-PERF-Abnahme und Indexnettonutzen bleiben NOT_ESTABLISHED.</a:t>
             </a:r>
           </a:p>
         </p:txBody>
@@ -22922,7 +22932,7 @@
           <p:cNvPr id="8" name="text-7">
             <a:extLst xmlns:a="http://schemas.openxmlformats.org/drawingml/2006/main">
               <a:ext uri="{FF2B5EF4-FFF2-40B4-BE49-F238E27FC236}">
-                <a16:creationId xmlns:a16="http://schemas.microsoft.com/office/drawing/2014/main" id="{CEE8CF0B-0E9D-4C97-BCA0-3E8493408BA3}"/>
+                <a16:creationId xmlns:a16="http://schemas.microsoft.com/office/drawing/2014/main" id="{E39FC43B-F810-4300-A16E-4AE8DBF65DEA}"/>
               </a:ext>
             </a:extLst>
           </p:cNvPr>
@@ -22988,7 +22998,7 @@
           <p:cNvPr id="9" name="text-8">
             <a:extLst xmlns:a="http://schemas.openxmlformats.org/drawingml/2006/main">
               <a:ext uri="{FF2B5EF4-FFF2-40B4-BE49-F238E27FC236}">
-                <a16:creationId xmlns:a16="http://schemas.microsoft.com/office/drawing/2014/main" id="{B2E19B3A-A4D1-481E-84DD-4E2C1CD29D1F}"/>
+                <a16:creationId xmlns:a16="http://schemas.microsoft.com/office/drawing/2014/main" id="{574B4814-42D2-41C9-823C-882E8D0FCD21}"/>
               </a:ext>
             </a:extLst>
           </p:cNvPr>
@@ -23052,7 +23062,7 @@
     </p:spTree>
     <p:extLst>
       <p:ext uri="{BB962C8B-B14F-4D97-AF65-F5344CB8AC3E}">
-        <p14:creationId xmlns:p14="http://schemas.microsoft.com/office/powerpoint/2010/main" val="1414023007"/>
+        <p14:creationId xmlns:p14="http://schemas.microsoft.com/office/powerpoint/2010/main" val="391069420"/>
       </p:ext>
     </p:extLst>
   </p:cSld>
@@ -23083,7 +23093,7 @@
           <p:cNvPr id="10" name="text-0">
             <a:extLst xmlns:a="http://schemas.openxmlformats.org/drawingml/2006/main">
               <a:ext uri="{FF2B5EF4-FFF2-40B4-BE49-F238E27FC236}">
-                <a16:creationId xmlns:a16="http://schemas.microsoft.com/office/drawing/2014/main" id="{3F409805-CE6F-4BC9-AA9A-2EAB83380BF8}"/>
+                <a16:creationId xmlns:a16="http://schemas.microsoft.com/office/drawing/2014/main" id="{AA140B6C-1126-4973-8284-7E100418D9EC}"/>
               </a:ext>
             </a:extLst>
           </p:cNvPr>
@@ -23149,7 +23159,7 @@
           <p:cNvPr id="2" name="text-1">
             <a:extLst xmlns:a="http://schemas.openxmlformats.org/drawingml/2006/main">
               <a:ext uri="{FF2B5EF4-FFF2-40B4-BE49-F238E27FC236}">
-                <a16:creationId xmlns:a16="http://schemas.microsoft.com/office/drawing/2014/main" id="{86B24E5A-7C2A-4463-A4F7-984E4E0852EE}"/>
+                <a16:creationId xmlns:a16="http://schemas.microsoft.com/office/drawing/2014/main" id="{3EF9011D-CF1A-4F1E-AF8A-199B77712BA6}"/>
               </a:ext>
             </a:extLst>
           </p:cNvPr>
@@ -23215,7 +23225,7 @@
           <p:cNvPr id="3" name="text-2">
             <a:extLst xmlns:a="http://schemas.openxmlformats.org/drawingml/2006/main">
               <a:ext uri="{FF2B5EF4-FFF2-40B4-BE49-F238E27FC236}">
-                <a16:creationId xmlns:a16="http://schemas.microsoft.com/office/drawing/2014/main" id="{4D3A6748-02D8-4214-8BA5-CD1A3CDEC88F}"/>
+                <a16:creationId xmlns:a16="http://schemas.microsoft.com/office/drawing/2014/main" id="{C629B52C-C0F1-4443-8529-14B70DBD6D92}"/>
               </a:ext>
             </a:extLst>
           </p:cNvPr>
@@ -23281,7 +23291,7 @@
           <p:cNvPr id="4" name="text-3">
             <a:extLst xmlns:a="http://schemas.openxmlformats.org/drawingml/2006/main">
               <a:ext uri="{FF2B5EF4-FFF2-40B4-BE49-F238E27FC236}">
-                <a16:creationId xmlns:a16="http://schemas.microsoft.com/office/drawing/2014/main" id="{EECFAF35-F31A-479B-BACF-DAFB85FC38D1}"/>
+                <a16:creationId xmlns:a16="http://schemas.microsoft.com/office/drawing/2014/main" id="{64F3CD5B-2196-48C5-A34A-95905E7CBC59}"/>
               </a:ext>
             </a:extLst>
           </p:cNvPr>
@@ -23347,7 +23357,7 @@
           <p:cNvPr id="5" name="text-4">
             <a:extLst xmlns:a="http://schemas.openxmlformats.org/drawingml/2006/main">
               <a:ext uri="{FF2B5EF4-FFF2-40B4-BE49-F238E27FC236}">
-                <a16:creationId xmlns:a16="http://schemas.microsoft.com/office/drawing/2014/main" id="{0B75C3F1-49C1-43A2-B0A3-CF33E33C8D9E}"/>
+                <a16:creationId xmlns:a16="http://schemas.microsoft.com/office/drawing/2014/main" id="{71C1454C-4BF3-45E2-A835-8ED540CAE5AB}"/>
               </a:ext>
             </a:extLst>
           </p:cNvPr>
@@ -23413,7 +23423,7 @@
           <p:cNvPr id="6" name="text-5">
             <a:extLst xmlns:a="http://schemas.openxmlformats.org/drawingml/2006/main">
               <a:ext uri="{FF2B5EF4-FFF2-40B4-BE49-F238E27FC236}">
-                <a16:creationId xmlns:a16="http://schemas.microsoft.com/office/drawing/2014/main" id="{826B92B4-E686-4A4C-941E-E1D56B6D1662}"/>
+                <a16:creationId xmlns:a16="http://schemas.microsoft.com/office/drawing/2014/main" id="{7B18EFE0-BFAE-4CFE-B157-86F027707134}"/>
               </a:ext>
             </a:extLst>
           </p:cNvPr>
@@ -23479,7 +23489,7 @@
           <p:cNvPr id="7" name="text-6">
             <a:extLst xmlns:a="http://schemas.openxmlformats.org/drawingml/2006/main">
               <a:ext uri="{FF2B5EF4-FFF2-40B4-BE49-F238E27FC236}">
-                <a16:creationId xmlns:a16="http://schemas.microsoft.com/office/drawing/2014/main" id="{4CB01936-9D3C-4870-A120-91CBEEA246A3}"/>
+                <a16:creationId xmlns:a16="http://schemas.microsoft.com/office/drawing/2014/main" id="{5BC7C4A3-4A95-46E9-A465-19F797ECA106}"/>
               </a:ext>
             </a:extLst>
           </p:cNvPr>
@@ -23545,7 +23555,7 @@
           <p:cNvPr id="8" name="text-7">
             <a:extLst xmlns:a="http://schemas.openxmlformats.org/drawingml/2006/main">
               <a:ext uri="{FF2B5EF4-FFF2-40B4-BE49-F238E27FC236}">
-                <a16:creationId xmlns:a16="http://schemas.microsoft.com/office/drawing/2014/main" id="{3C06AB45-E619-4703-B095-758A089D0967}"/>
+                <a16:creationId xmlns:a16="http://schemas.microsoft.com/office/drawing/2014/main" id="{16F2F211-64A9-4993-A2D2-1355CD2533A4}"/>
               </a:ext>
             </a:extLst>
           </p:cNvPr>
@@ -23611,7 +23621,7 @@
           <p:cNvPr id="9" name="text-8">
             <a:extLst xmlns:a="http://schemas.openxmlformats.org/drawingml/2006/main">
               <a:ext uri="{FF2B5EF4-FFF2-40B4-BE49-F238E27FC236}">
-                <a16:creationId xmlns:a16="http://schemas.microsoft.com/office/drawing/2014/main" id="{90CFA491-7D31-441C-B7FF-B600AF679568}"/>
+                <a16:creationId xmlns:a16="http://schemas.microsoft.com/office/drawing/2014/main" id="{A8F49513-F3DD-41C8-9AC2-647B4C71E307}"/>
               </a:ext>
             </a:extLst>
           </p:cNvPr>
@@ -23675,7 +23685,7 @@
     </p:spTree>
     <p:extLst>
       <p:ext uri="{BB962C8B-B14F-4D97-AF65-F5344CB8AC3E}">
-        <p14:creationId xmlns:p14="http://schemas.microsoft.com/office/powerpoint/2010/main" val="370017727"/>
+        <p14:creationId xmlns:p14="http://schemas.microsoft.com/office/powerpoint/2010/main" val="146172360"/>
       </p:ext>
     </p:extLst>
   </p:cSld>
@@ -23706,7 +23716,7 @@
           <p:cNvPr id="5" name="text-0">
             <a:extLst xmlns:a="http://schemas.openxmlformats.org/drawingml/2006/main">
               <a:ext uri="{FF2B5EF4-FFF2-40B4-BE49-F238E27FC236}">
-                <a16:creationId xmlns:a16="http://schemas.microsoft.com/office/drawing/2014/main" id="{DEF667A0-8D7D-4108-B005-E46FE13818CB}"/>
+                <a16:creationId xmlns:a16="http://schemas.microsoft.com/office/drawing/2014/main" id="{EFA8648D-D4DD-4235-A954-E04ABC27BEB7}"/>
               </a:ext>
             </a:extLst>
           </p:cNvPr>
@@ -23772,7 +23782,7 @@
           <p:cNvPr id="2" name="">
             <a:extLst xmlns:a="http://schemas.openxmlformats.org/drawingml/2006/main">
               <a:ext uri="{FF2B5EF4-FFF2-40B4-BE49-F238E27FC236}">
-                <a16:creationId xmlns:a16="http://schemas.microsoft.com/office/drawing/2014/main" id="{3CE4DB4B-AF57-4E48-AC28-8C4BFB11BC4D}"/>
+                <a16:creationId xmlns:a16="http://schemas.microsoft.com/office/drawing/2014/main" id="{E2F94ABE-BBE1-40E2-B7D2-ED4C7828E2CA}"/>
               </a:ext>
             </a:extLst>
           </p:cNvPr>
@@ -24050,7 +24060,7 @@
           <p:cNvPr id="3" name="text-1">
             <a:extLst xmlns:a="http://schemas.openxmlformats.org/drawingml/2006/main">
               <a:ext uri="{FF2B5EF4-FFF2-40B4-BE49-F238E27FC236}">
-                <a16:creationId xmlns:a16="http://schemas.microsoft.com/office/drawing/2014/main" id="{0402F818-0348-4380-B64C-701C1465BE32}"/>
+                <a16:creationId xmlns:a16="http://schemas.microsoft.com/office/drawing/2014/main" id="{805D9EE5-105E-45C8-A330-BF54C90BAEA3}"/>
               </a:ext>
             </a:extLst>
           </p:cNvPr>
@@ -24116,7 +24126,7 @@
           <p:cNvPr id="4" name="text-2">
             <a:extLst xmlns:a="http://schemas.openxmlformats.org/drawingml/2006/main">
               <a:ext uri="{FF2B5EF4-FFF2-40B4-BE49-F238E27FC236}">
-                <a16:creationId xmlns:a16="http://schemas.microsoft.com/office/drawing/2014/main" id="{67DAFCEE-E4E9-49F7-931D-5830242F8F8D}"/>
+                <a16:creationId xmlns:a16="http://schemas.microsoft.com/office/drawing/2014/main" id="{79A3F840-1DE8-48DB-B62D-75FA4E60A805}"/>
               </a:ext>
             </a:extLst>
           </p:cNvPr>
@@ -24180,7 +24190,7 @@
     </p:spTree>
     <p:extLst>
       <p:ext uri="{BB962C8B-B14F-4D97-AF65-F5344CB8AC3E}">
-        <p14:creationId xmlns:p14="http://schemas.microsoft.com/office/powerpoint/2010/main" val="1179196167"/>
+        <p14:creationId xmlns:p14="http://schemas.microsoft.com/office/powerpoint/2010/main" val="493144837"/>
       </p:ext>
     </p:extLst>
   </p:cSld>
@@ -24211,7 +24221,7 @@
           <p:cNvPr id="10" name="text-0">
             <a:extLst xmlns:a="http://schemas.openxmlformats.org/drawingml/2006/main">
               <a:ext uri="{FF2B5EF4-FFF2-40B4-BE49-F238E27FC236}">
-                <a16:creationId xmlns:a16="http://schemas.microsoft.com/office/drawing/2014/main" id="{CFA5A5B4-450A-4815-B931-DB2398503E8B}"/>
+                <a16:creationId xmlns:a16="http://schemas.microsoft.com/office/drawing/2014/main" id="{178D8876-61A4-4A62-89F4-95FC0A951BC8}"/>
               </a:ext>
             </a:extLst>
           </p:cNvPr>
@@ -24277,7 +24287,7 @@
           <p:cNvPr id="2" name="text-1">
             <a:extLst xmlns:a="http://schemas.openxmlformats.org/drawingml/2006/main">
               <a:ext uri="{FF2B5EF4-FFF2-40B4-BE49-F238E27FC236}">
-                <a16:creationId xmlns:a16="http://schemas.microsoft.com/office/drawing/2014/main" id="{5457940A-A2DE-419D-8D8C-D0D34F1FAA89}"/>
+                <a16:creationId xmlns:a16="http://schemas.microsoft.com/office/drawing/2014/main" id="{9FEA8D3F-5072-4A72-8549-4F74418EDAFE}"/>
               </a:ext>
             </a:extLst>
           </p:cNvPr>
@@ -24343,7 +24353,7 @@
           <p:cNvPr id="3" name="text-2">
             <a:extLst xmlns:a="http://schemas.openxmlformats.org/drawingml/2006/main">
               <a:ext uri="{FF2B5EF4-FFF2-40B4-BE49-F238E27FC236}">
-                <a16:creationId xmlns:a16="http://schemas.microsoft.com/office/drawing/2014/main" id="{E2D37B83-937D-4348-B6C8-24FDFB1B5B2F}"/>
+                <a16:creationId xmlns:a16="http://schemas.microsoft.com/office/drawing/2014/main" id="{807A8CAA-2A91-442F-B20C-A05C7A308219}"/>
               </a:ext>
             </a:extLst>
           </p:cNvPr>
@@ -24409,7 +24419,7 @@
           <p:cNvPr id="4" name="text-3">
             <a:extLst xmlns:a="http://schemas.openxmlformats.org/drawingml/2006/main">
               <a:ext uri="{FF2B5EF4-FFF2-40B4-BE49-F238E27FC236}">
-                <a16:creationId xmlns:a16="http://schemas.microsoft.com/office/drawing/2014/main" id="{1DF851B3-E032-4353-9FCE-28CF2F9A5D8F}"/>
+                <a16:creationId xmlns:a16="http://schemas.microsoft.com/office/drawing/2014/main" id="{B76448E9-19D4-4CC3-AF1E-BB27175398A1}"/>
               </a:ext>
             </a:extLst>
           </p:cNvPr>
@@ -24475,7 +24485,7 @@
           <p:cNvPr id="5" name="text-4">
             <a:extLst xmlns:a="http://schemas.openxmlformats.org/drawingml/2006/main">
               <a:ext uri="{FF2B5EF4-FFF2-40B4-BE49-F238E27FC236}">
-                <a16:creationId xmlns:a16="http://schemas.microsoft.com/office/drawing/2014/main" id="{136AAAA6-33D3-451E-8AA5-9C792C80692B}"/>
+                <a16:creationId xmlns:a16="http://schemas.microsoft.com/office/drawing/2014/main" id="{39894CDD-2CFD-45E2-B4E9-01418DD3F5E9}"/>
               </a:ext>
             </a:extLst>
           </p:cNvPr>
@@ -24541,7 +24551,7 @@
           <p:cNvPr id="6" name="text-5">
             <a:extLst xmlns:a="http://schemas.openxmlformats.org/drawingml/2006/main">
               <a:ext uri="{FF2B5EF4-FFF2-40B4-BE49-F238E27FC236}">
-                <a16:creationId xmlns:a16="http://schemas.microsoft.com/office/drawing/2014/main" id="{26EFC14F-751F-4C49-8DEA-B09F0914EFF9}"/>
+                <a16:creationId xmlns:a16="http://schemas.microsoft.com/office/drawing/2014/main" id="{97A49485-C954-4571-853F-F86FC58CF510}"/>
               </a:ext>
             </a:extLst>
           </p:cNvPr>
@@ -24607,7 +24617,7 @@
           <p:cNvPr id="7" name="text-6">
             <a:extLst xmlns:a="http://schemas.openxmlformats.org/drawingml/2006/main">
               <a:ext uri="{FF2B5EF4-FFF2-40B4-BE49-F238E27FC236}">
-                <a16:creationId xmlns:a16="http://schemas.microsoft.com/office/drawing/2014/main" id="{CB33116E-6B14-4DEC-9F04-F73E27CB8C94}"/>
+                <a16:creationId xmlns:a16="http://schemas.microsoft.com/office/drawing/2014/main" id="{5FF6C361-2D3F-4E80-87CF-49F456154063}"/>
               </a:ext>
             </a:extLst>
           </p:cNvPr>
@@ -24673,7 +24683,7 @@
           <p:cNvPr id="8" name="text-7">
             <a:extLst xmlns:a="http://schemas.openxmlformats.org/drawingml/2006/main">
               <a:ext uri="{FF2B5EF4-FFF2-40B4-BE49-F238E27FC236}">
-                <a16:creationId xmlns:a16="http://schemas.microsoft.com/office/drawing/2014/main" id="{AEBDF6F9-D31B-4C89-AA94-FADAA411581C}"/>
+                <a16:creationId xmlns:a16="http://schemas.microsoft.com/office/drawing/2014/main" id="{D9B98003-E41A-43BE-8855-10B6B22E7D61}"/>
               </a:ext>
             </a:extLst>
           </p:cNvPr>
@@ -24739,7 +24749,7 @@
           <p:cNvPr id="9" name="text-8">
             <a:extLst xmlns:a="http://schemas.openxmlformats.org/drawingml/2006/main">
               <a:ext uri="{FF2B5EF4-FFF2-40B4-BE49-F238E27FC236}">
-                <a16:creationId xmlns:a16="http://schemas.microsoft.com/office/drawing/2014/main" id="{F02B388D-1177-4380-931B-0EBF74A69D81}"/>
+                <a16:creationId xmlns:a16="http://schemas.microsoft.com/office/drawing/2014/main" id="{68D94286-FF86-4925-B3BA-7EAED2F33B12}"/>
               </a:ext>
             </a:extLst>
           </p:cNvPr>
@@ -24803,7 +24813,7 @@
     </p:spTree>
     <p:extLst>
       <p:ext uri="{BB962C8B-B14F-4D97-AF65-F5344CB8AC3E}">
-        <p14:creationId xmlns:p14="http://schemas.microsoft.com/office/powerpoint/2010/main" val="1298397753"/>
+        <p14:creationId xmlns:p14="http://schemas.microsoft.com/office/powerpoint/2010/main" val="1848658422"/>
       </p:ext>
     </p:extLst>
   </p:cSld>
@@ -24834,7 +24844,7 @@
           <p:cNvPr id="4" name="text-0">
             <a:extLst xmlns:a="http://schemas.openxmlformats.org/drawingml/2006/main">
               <a:ext uri="{FF2B5EF4-FFF2-40B4-BE49-F238E27FC236}">
-                <a16:creationId xmlns:a16="http://schemas.microsoft.com/office/drawing/2014/main" id="{6368F4AA-C089-4551-AFFE-78F71340998C}"/>
+                <a16:creationId xmlns:a16="http://schemas.microsoft.com/office/drawing/2014/main" id="{581F5DDC-003E-43B4-9D92-5ED4988ABCEC}"/>
               </a:ext>
             </a:extLst>
           </p:cNvPr>
@@ -24900,7 +24910,7 @@
           <p:cNvPr id="2" name="">
             <a:extLst xmlns:a="http://schemas.openxmlformats.org/drawingml/2006/main">
               <a:ext uri="{FF2B5EF4-FFF2-40B4-BE49-F238E27FC236}">
-                <a16:creationId xmlns:a16="http://schemas.microsoft.com/office/drawing/2014/main" id="{1CB46F02-6CA0-4DCE-819C-C7B1B39CBAA6}"/>
+                <a16:creationId xmlns:a16="http://schemas.microsoft.com/office/drawing/2014/main" id="{AF2E4E21-B370-4456-A467-3190D43A81EF}"/>
               </a:ext>
             </a:extLst>
           </p:cNvPr>
@@ -25299,7 +25309,7 @@
           <p:cNvPr id="3" name="text-1">
             <a:extLst xmlns:a="http://schemas.openxmlformats.org/drawingml/2006/main">
               <a:ext uri="{FF2B5EF4-FFF2-40B4-BE49-F238E27FC236}">
-                <a16:creationId xmlns:a16="http://schemas.microsoft.com/office/drawing/2014/main" id="{CEC7AE74-07C9-47D8-8BDE-25CB7102C83A}"/>
+                <a16:creationId xmlns:a16="http://schemas.microsoft.com/office/drawing/2014/main" id="{5685853C-7E28-47D7-A272-01334B26A429}"/>
               </a:ext>
             </a:extLst>
           </p:cNvPr>
@@ -25363,7 +25373,7 @@
     </p:spTree>
     <p:extLst>
       <p:ext uri="{BB962C8B-B14F-4D97-AF65-F5344CB8AC3E}">
-        <p14:creationId xmlns:p14="http://schemas.microsoft.com/office/powerpoint/2010/main" val="939299571"/>
+        <p14:creationId xmlns:p14="http://schemas.microsoft.com/office/powerpoint/2010/main" val="1858375424"/>
       </p:ext>
     </p:extLst>
   </p:cSld>
@@ -25394,7 +25404,7 @@
           <p:cNvPr id="5" name="text-0">
             <a:extLst xmlns:a="http://schemas.openxmlformats.org/drawingml/2006/main">
               <a:ext uri="{FF2B5EF4-FFF2-40B4-BE49-F238E27FC236}">
-                <a16:creationId xmlns:a16="http://schemas.microsoft.com/office/drawing/2014/main" id="{3D6D0083-66EC-4A96-822D-3D5B192E6511}"/>
+                <a16:creationId xmlns:a16="http://schemas.microsoft.com/office/drawing/2014/main" id="{DCDA7120-266A-45FA-966F-FF5F59169229}"/>
               </a:ext>
             </a:extLst>
           </p:cNvPr>
@@ -25460,7 +25470,7 @@
           <p:cNvPr id="2" name="">
             <a:extLst xmlns:a="http://schemas.openxmlformats.org/drawingml/2006/main">
               <a:ext uri="{FF2B5EF4-FFF2-40B4-BE49-F238E27FC236}">
-                <a16:creationId xmlns:a16="http://schemas.microsoft.com/office/drawing/2014/main" id="{856007C4-E400-439D-A56D-FCAB40538ECE}"/>
+                <a16:creationId xmlns:a16="http://schemas.microsoft.com/office/drawing/2014/main" id="{A1A4499A-7C1B-4983-8076-03A54A3CAFAB}"/>
               </a:ext>
             </a:extLst>
           </p:cNvPr>
@@ -25933,7 +25943,7 @@
           <p:cNvPr id="3" name="text-1">
             <a:extLst xmlns:a="http://schemas.openxmlformats.org/drawingml/2006/main">
               <a:ext uri="{FF2B5EF4-FFF2-40B4-BE49-F238E27FC236}">
-                <a16:creationId xmlns:a16="http://schemas.microsoft.com/office/drawing/2014/main" id="{F8620FA9-2E33-4368-9834-9AC75FDC35AD}"/>
+                <a16:creationId xmlns:a16="http://schemas.microsoft.com/office/drawing/2014/main" id="{AC1A8580-D59E-4E6F-BA65-A74E05E86C9F}"/>
               </a:ext>
             </a:extLst>
           </p:cNvPr>
@@ -25999,7 +26009,7 @@
           <p:cNvPr id="4" name="text-2">
             <a:extLst xmlns:a="http://schemas.openxmlformats.org/drawingml/2006/main">
               <a:ext uri="{FF2B5EF4-FFF2-40B4-BE49-F238E27FC236}">
-                <a16:creationId xmlns:a16="http://schemas.microsoft.com/office/drawing/2014/main" id="{A2F3D8CA-10F6-4D83-BDAA-57633BDC5071}"/>
+                <a16:creationId xmlns:a16="http://schemas.microsoft.com/office/drawing/2014/main" id="{086CBAB8-17F5-482F-AA34-D99A318D4F10}"/>
               </a:ext>
             </a:extLst>
           </p:cNvPr>
@@ -26063,7 +26073,7 @@
     </p:spTree>
     <p:extLst>
       <p:ext uri="{BB962C8B-B14F-4D97-AF65-F5344CB8AC3E}">
-        <p14:creationId xmlns:p14="http://schemas.microsoft.com/office/powerpoint/2010/main" val="905620312"/>
+        <p14:creationId xmlns:p14="http://schemas.microsoft.com/office/powerpoint/2010/main" val="2019302001"/>
       </p:ext>
     </p:extLst>
   </p:cSld>
@@ -26094,7 +26104,7 @@
           <p:cNvPr id="5" name="text-0">
             <a:extLst xmlns:a="http://schemas.openxmlformats.org/drawingml/2006/main">
               <a:ext uri="{FF2B5EF4-FFF2-40B4-BE49-F238E27FC236}">
-                <a16:creationId xmlns:a16="http://schemas.microsoft.com/office/drawing/2014/main" id="{D0309612-3F04-47BB-AF0F-A377070EBA74}"/>
+                <a16:creationId xmlns:a16="http://schemas.microsoft.com/office/drawing/2014/main" id="{ACC024C6-A202-4B1A-99D9-AE7404440E7E}"/>
               </a:ext>
             </a:extLst>
           </p:cNvPr>
@@ -26160,7 +26170,7 @@
           <p:cNvPr id="2" name="">
             <a:extLst xmlns:a="http://schemas.openxmlformats.org/drawingml/2006/main">
               <a:ext uri="{FF2B5EF4-FFF2-40B4-BE49-F238E27FC236}">
-                <a16:creationId xmlns:a16="http://schemas.microsoft.com/office/drawing/2014/main" id="{D5F02087-8409-489B-8D99-228AB8F77BF3}"/>
+                <a16:creationId xmlns:a16="http://schemas.microsoft.com/office/drawing/2014/main" id="{D1EEFB7C-59B2-45AA-A47F-28C6B74EF883}"/>
               </a:ext>
             </a:extLst>
           </p:cNvPr>
@@ -26388,7 +26398,7 @@
           <p:cNvPr id="3" name="text-1">
             <a:extLst xmlns:a="http://schemas.openxmlformats.org/drawingml/2006/main">
               <a:ext uri="{FF2B5EF4-FFF2-40B4-BE49-F238E27FC236}">
-                <a16:creationId xmlns:a16="http://schemas.microsoft.com/office/drawing/2014/main" id="{D18CC8B0-D0A3-4C22-9BB8-50B9767373B3}"/>
+                <a16:creationId xmlns:a16="http://schemas.microsoft.com/office/drawing/2014/main" id="{BB0AE333-FAC8-4A9D-BC9B-0582EA135F4D}"/>
               </a:ext>
             </a:extLst>
           </p:cNvPr>
@@ -26454,7 +26464,7 @@
           <p:cNvPr id="4" name="text-2">
             <a:extLst xmlns:a="http://schemas.openxmlformats.org/drawingml/2006/main">
               <a:ext uri="{FF2B5EF4-FFF2-40B4-BE49-F238E27FC236}">
-                <a16:creationId xmlns:a16="http://schemas.microsoft.com/office/drawing/2014/main" id="{B2AF2A7C-DA52-4BD2-9D5F-7BAB62D6EC59}"/>
+                <a16:creationId xmlns:a16="http://schemas.microsoft.com/office/drawing/2014/main" id="{8ECE8BCF-086F-4B87-986D-9DDAEC0D6695}"/>
               </a:ext>
             </a:extLst>
           </p:cNvPr>
@@ -26518,7 +26528,7 @@
     </p:spTree>
     <p:extLst>
       <p:ext uri="{BB962C8B-B14F-4D97-AF65-F5344CB8AC3E}">
-        <p14:creationId xmlns:p14="http://schemas.microsoft.com/office/powerpoint/2010/main" val="1126798209"/>
+        <p14:creationId xmlns:p14="http://schemas.microsoft.com/office/powerpoint/2010/main" val="1292837046"/>
       </p:ext>
     </p:extLst>
   </p:cSld>
@@ -26549,7 +26559,7 @@
           <p:cNvPr id="9" name="text-0">
             <a:extLst xmlns:a="http://schemas.openxmlformats.org/drawingml/2006/main">
               <a:ext uri="{FF2B5EF4-FFF2-40B4-BE49-F238E27FC236}">
-                <a16:creationId xmlns:a16="http://schemas.microsoft.com/office/drawing/2014/main" id="{34DB4D8A-A3CE-490E-BDD4-2550D46A1121}"/>
+                <a16:creationId xmlns:a16="http://schemas.microsoft.com/office/drawing/2014/main" id="{65BCEB84-2584-4EAC-BBB2-6F1D80327038}"/>
               </a:ext>
             </a:extLst>
           </p:cNvPr>
@@ -26615,7 +26625,7 @@
           <p:cNvPr id="2" name="text-1">
             <a:extLst xmlns:a="http://schemas.openxmlformats.org/drawingml/2006/main">
               <a:ext uri="{FF2B5EF4-FFF2-40B4-BE49-F238E27FC236}">
-                <a16:creationId xmlns:a16="http://schemas.microsoft.com/office/drawing/2014/main" id="{FC59FFF5-3DCF-44D6-9AF9-208ACCB0321D}"/>
+                <a16:creationId xmlns:a16="http://schemas.microsoft.com/office/drawing/2014/main" id="{4E0DD925-3CEE-4A14-8060-2B6EAB8205F8}"/>
               </a:ext>
             </a:extLst>
           </p:cNvPr>
@@ -26681,7 +26691,7 @@
           <p:cNvPr id="3" name="text-2">
             <a:extLst xmlns:a="http://schemas.openxmlformats.org/drawingml/2006/main">
               <a:ext uri="{FF2B5EF4-FFF2-40B4-BE49-F238E27FC236}">
-                <a16:creationId xmlns:a16="http://schemas.microsoft.com/office/drawing/2014/main" id="{1F71B7A8-4EC0-49B2-9B46-C24A1D283A10}"/>
+                <a16:creationId xmlns:a16="http://schemas.microsoft.com/office/drawing/2014/main" id="{5D3611B6-3A03-4758-9772-7B4235F786BE}"/>
               </a:ext>
             </a:extLst>
           </p:cNvPr>
@@ -26747,7 +26757,7 @@
           <p:cNvPr id="4" name="text-3">
             <a:extLst xmlns:a="http://schemas.openxmlformats.org/drawingml/2006/main">
               <a:ext uri="{FF2B5EF4-FFF2-40B4-BE49-F238E27FC236}">
-                <a16:creationId xmlns:a16="http://schemas.microsoft.com/office/drawing/2014/main" id="{EF275EBA-ED92-47FA-BD65-6E10D165D6E8}"/>
+                <a16:creationId xmlns:a16="http://schemas.microsoft.com/office/drawing/2014/main" id="{B55D3615-4870-45A4-9B9B-B18BC330512F}"/>
               </a:ext>
             </a:extLst>
           </p:cNvPr>
@@ -26813,7 +26823,7 @@
           <p:cNvPr id="5" name="text-4">
             <a:extLst xmlns:a="http://schemas.openxmlformats.org/drawingml/2006/main">
               <a:ext uri="{FF2B5EF4-FFF2-40B4-BE49-F238E27FC236}">
-                <a16:creationId xmlns:a16="http://schemas.microsoft.com/office/drawing/2014/main" id="{B1317994-131D-48FE-9DF2-09A270173435}"/>
+                <a16:creationId xmlns:a16="http://schemas.microsoft.com/office/drawing/2014/main" id="{022C10EF-8A62-4CCD-A842-019FA580FD94}"/>
               </a:ext>
             </a:extLst>
           </p:cNvPr>
@@ -26879,7 +26889,7 @@
           <p:cNvPr id="6" name="text-5">
             <a:extLst xmlns:a="http://schemas.openxmlformats.org/drawingml/2006/main">
               <a:ext uri="{FF2B5EF4-FFF2-40B4-BE49-F238E27FC236}">
-                <a16:creationId xmlns:a16="http://schemas.microsoft.com/office/drawing/2014/main" id="{BD41C59A-CAE8-44E0-ADFF-AAB639C35DC8}"/>
+                <a16:creationId xmlns:a16="http://schemas.microsoft.com/office/drawing/2014/main" id="{75C6D396-D762-4D02-95B3-5AC71B61E052}"/>
               </a:ext>
             </a:extLst>
           </p:cNvPr>
@@ -26945,7 +26955,7 @@
           <p:cNvPr id="7" name="text-6">
             <a:extLst xmlns:a="http://schemas.openxmlformats.org/drawingml/2006/main">
               <a:ext uri="{FF2B5EF4-FFF2-40B4-BE49-F238E27FC236}">
-                <a16:creationId xmlns:a16="http://schemas.microsoft.com/office/drawing/2014/main" id="{DEC584DF-2CF4-4137-9E56-A809DDD4CDFA}"/>
+                <a16:creationId xmlns:a16="http://schemas.microsoft.com/office/drawing/2014/main" id="{5F5FF5A5-C4B5-4FAC-82CD-8C61100CDADA}"/>
               </a:ext>
             </a:extLst>
           </p:cNvPr>
@@ -27011,7 +27021,7 @@
           <p:cNvPr id="8" name="text-7">
             <a:extLst xmlns:a="http://schemas.openxmlformats.org/drawingml/2006/main">
               <a:ext uri="{FF2B5EF4-FFF2-40B4-BE49-F238E27FC236}">
-                <a16:creationId xmlns:a16="http://schemas.microsoft.com/office/drawing/2014/main" id="{F9D1DFD4-C262-4E24-8373-8BA97C82D67D}"/>
+                <a16:creationId xmlns:a16="http://schemas.microsoft.com/office/drawing/2014/main" id="{8ED0E3A2-CE38-4623-8911-ADCAE584839A}"/>
               </a:ext>
             </a:extLst>
           </p:cNvPr>
@@ -27075,7 +27085,7 @@
     </p:spTree>
     <p:extLst>
       <p:ext uri="{BB962C8B-B14F-4D97-AF65-F5344CB8AC3E}">
-        <p14:creationId xmlns:p14="http://schemas.microsoft.com/office/powerpoint/2010/main" val="1458239551"/>
+        <p14:creationId xmlns:p14="http://schemas.microsoft.com/office/powerpoint/2010/main" val="1210731514"/>
       </p:ext>
     </p:extLst>
   </p:cSld>
@@ -27106,7 +27116,7 @@
           <p:cNvPr id="10" name="text-0">
             <a:extLst xmlns:a="http://schemas.openxmlformats.org/drawingml/2006/main">
               <a:ext uri="{FF2B5EF4-FFF2-40B4-BE49-F238E27FC236}">
-                <a16:creationId xmlns:a16="http://schemas.microsoft.com/office/drawing/2014/main" id="{FB1BE807-5E14-41A9-A182-A953ABBA8C52}"/>
+                <a16:creationId xmlns:a16="http://schemas.microsoft.com/office/drawing/2014/main" id="{A1F9B474-6B69-4246-89BC-254EBAB622C9}"/>
               </a:ext>
             </a:extLst>
           </p:cNvPr>
@@ -27172,7 +27182,7 @@
           <p:cNvPr id="2" name="text-1">
             <a:extLst xmlns:a="http://schemas.openxmlformats.org/drawingml/2006/main">
               <a:ext uri="{FF2B5EF4-FFF2-40B4-BE49-F238E27FC236}">
-                <a16:creationId xmlns:a16="http://schemas.microsoft.com/office/drawing/2014/main" id="{13EFDB59-F8C8-43F5-A882-F9A166149167}"/>
+                <a16:creationId xmlns:a16="http://schemas.microsoft.com/office/drawing/2014/main" id="{09BC30C9-A1C8-4154-B750-BD85168D6E62}"/>
               </a:ext>
             </a:extLst>
           </p:cNvPr>
@@ -27238,7 +27248,7 @@
           <p:cNvPr id="3" name="text-2">
             <a:extLst xmlns:a="http://schemas.openxmlformats.org/drawingml/2006/main">
               <a:ext uri="{FF2B5EF4-FFF2-40B4-BE49-F238E27FC236}">
-                <a16:creationId xmlns:a16="http://schemas.microsoft.com/office/drawing/2014/main" id="{8AE0F0E7-31EC-48BD-B980-D49D8728754A}"/>
+                <a16:creationId xmlns:a16="http://schemas.microsoft.com/office/drawing/2014/main" id="{413134C4-9D45-40DE-AA4E-53BE199AB278}"/>
               </a:ext>
             </a:extLst>
           </p:cNvPr>
@@ -27304,7 +27314,7 @@
           <p:cNvPr id="4" name="text-3">
             <a:extLst xmlns:a="http://schemas.openxmlformats.org/drawingml/2006/main">
               <a:ext uri="{FF2B5EF4-FFF2-40B4-BE49-F238E27FC236}">
-                <a16:creationId xmlns:a16="http://schemas.microsoft.com/office/drawing/2014/main" id="{18E7512C-3B15-43C0-83DC-096D4E72E2E7}"/>
+                <a16:creationId xmlns:a16="http://schemas.microsoft.com/office/drawing/2014/main" id="{9888EC40-AF03-436A-8E18-6F75F4E320F8}"/>
               </a:ext>
             </a:extLst>
           </p:cNvPr>
@@ -27370,7 +27380,7 @@
           <p:cNvPr id="5" name="text-4">
             <a:extLst xmlns:a="http://schemas.openxmlformats.org/drawingml/2006/main">
               <a:ext uri="{FF2B5EF4-FFF2-40B4-BE49-F238E27FC236}">
-                <a16:creationId xmlns:a16="http://schemas.microsoft.com/office/drawing/2014/main" id="{EDD57AF8-E9FA-4653-8DF5-F78F04522F26}"/>
+                <a16:creationId xmlns:a16="http://schemas.microsoft.com/office/drawing/2014/main" id="{0C92E70C-67DD-4D0D-B521-E9121DCDB90B}"/>
               </a:ext>
             </a:extLst>
           </p:cNvPr>
@@ -27436,7 +27446,7 @@
           <p:cNvPr id="6" name="text-5">
             <a:extLst xmlns:a="http://schemas.openxmlformats.org/drawingml/2006/main">
               <a:ext uri="{FF2B5EF4-FFF2-40B4-BE49-F238E27FC236}">
-                <a16:creationId xmlns:a16="http://schemas.microsoft.com/office/drawing/2014/main" id="{7690F567-6F6D-4275-B036-471A45B5B900}"/>
+                <a16:creationId xmlns:a16="http://schemas.microsoft.com/office/drawing/2014/main" id="{9D45F2E3-AE92-42EA-918F-B455673CB1AA}"/>
               </a:ext>
             </a:extLst>
           </p:cNvPr>
@@ -27502,7 +27512,7 @@
           <p:cNvPr id="7" name="text-6">
             <a:extLst xmlns:a="http://schemas.openxmlformats.org/drawingml/2006/main">
               <a:ext uri="{FF2B5EF4-FFF2-40B4-BE49-F238E27FC236}">
-                <a16:creationId xmlns:a16="http://schemas.microsoft.com/office/drawing/2014/main" id="{0C7A89DA-5FFD-4E96-8669-1B316619C5D6}"/>
+                <a16:creationId xmlns:a16="http://schemas.microsoft.com/office/drawing/2014/main" id="{5152E283-3C37-4EFF-84E4-91B0E2912699}"/>
               </a:ext>
             </a:extLst>
           </p:cNvPr>
@@ -27568,7 +27578,7 @@
           <p:cNvPr id="8" name="text-7">
             <a:extLst xmlns:a="http://schemas.openxmlformats.org/drawingml/2006/main">
               <a:ext uri="{FF2B5EF4-FFF2-40B4-BE49-F238E27FC236}">
-                <a16:creationId xmlns:a16="http://schemas.microsoft.com/office/drawing/2014/main" id="{FCFD819A-FE40-4654-9FC1-3692E2BB6CF9}"/>
+                <a16:creationId xmlns:a16="http://schemas.microsoft.com/office/drawing/2014/main" id="{3C3ECCCF-C337-40A8-B756-A1C50D336443}"/>
               </a:ext>
             </a:extLst>
           </p:cNvPr>
@@ -27634,7 +27644,7 @@
           <p:cNvPr id="9" name="text-8">
             <a:extLst xmlns:a="http://schemas.openxmlformats.org/drawingml/2006/main">
               <a:ext uri="{FF2B5EF4-FFF2-40B4-BE49-F238E27FC236}">
-                <a16:creationId xmlns:a16="http://schemas.microsoft.com/office/drawing/2014/main" id="{884C25ED-829E-44BE-A541-8DAE4885B9E6}"/>
+                <a16:creationId xmlns:a16="http://schemas.microsoft.com/office/drawing/2014/main" id="{DB2ADDB5-CE9C-4310-951D-CF9ABE917B27}"/>
               </a:ext>
             </a:extLst>
           </p:cNvPr>
@@ -27698,7 +27708,7 @@
     </p:spTree>
     <p:extLst>
       <p:ext uri="{BB962C8B-B14F-4D97-AF65-F5344CB8AC3E}">
-        <p14:creationId xmlns:p14="http://schemas.microsoft.com/office/powerpoint/2010/main" val="797778804"/>
+        <p14:creationId xmlns:p14="http://schemas.microsoft.com/office/powerpoint/2010/main" val="2041439992"/>
       </p:ext>
     </p:extLst>
   </p:cSld>
@@ -27729,7 +27739,7 @@
           <p:cNvPr id="5" name="text-0">
             <a:extLst xmlns:a="http://schemas.openxmlformats.org/drawingml/2006/main">
               <a:ext uri="{FF2B5EF4-FFF2-40B4-BE49-F238E27FC236}">
-                <a16:creationId xmlns:a16="http://schemas.microsoft.com/office/drawing/2014/main" id="{3793CEBB-7131-42CA-A6C8-84FE69F43311}"/>
+                <a16:creationId xmlns:a16="http://schemas.microsoft.com/office/drawing/2014/main" id="{B6C31A3F-199F-4F44-B90F-A915B4C9F962}"/>
               </a:ext>
             </a:extLst>
           </p:cNvPr>
@@ -27795,7 +27805,7 @@
           <p:cNvPr id="2" name="">
             <a:extLst xmlns:a="http://schemas.openxmlformats.org/drawingml/2006/main">
               <a:ext uri="{FF2B5EF4-FFF2-40B4-BE49-F238E27FC236}">
-                <a16:creationId xmlns:a16="http://schemas.microsoft.com/office/drawing/2014/main" id="{98B14887-0B19-4674-8E36-BD6EB563D1DA}"/>
+                <a16:creationId xmlns:a16="http://schemas.microsoft.com/office/drawing/2014/main" id="{7769ECB3-ABB9-46DF-AA71-F4E0770DD193}"/>
               </a:ext>
             </a:extLst>
           </p:cNvPr>
@@ -28194,7 +28204,7 @@
           <p:cNvPr id="3" name="text-1">
             <a:extLst xmlns:a="http://schemas.openxmlformats.org/drawingml/2006/main">
               <a:ext uri="{FF2B5EF4-FFF2-40B4-BE49-F238E27FC236}">
-                <a16:creationId xmlns:a16="http://schemas.microsoft.com/office/drawing/2014/main" id="{0EE02B75-6D44-427D-9D15-BF5F8DCB22F8}"/>
+                <a16:creationId xmlns:a16="http://schemas.microsoft.com/office/drawing/2014/main" id="{87793C01-40F3-4321-A9A2-C677267154D7}"/>
               </a:ext>
             </a:extLst>
           </p:cNvPr>
@@ -28260,7 +28270,7 @@
           <p:cNvPr id="4" name="text-2">
             <a:extLst xmlns:a="http://schemas.openxmlformats.org/drawingml/2006/main">
               <a:ext uri="{FF2B5EF4-FFF2-40B4-BE49-F238E27FC236}">
-                <a16:creationId xmlns:a16="http://schemas.microsoft.com/office/drawing/2014/main" id="{867398E1-0AE2-45D6-8002-F87456CF7047}"/>
+                <a16:creationId xmlns:a16="http://schemas.microsoft.com/office/drawing/2014/main" id="{EFEB66D8-AA4A-4647-8982-1D86FD17A3BD}"/>
               </a:ext>
             </a:extLst>
           </p:cNvPr>
@@ -28324,7 +28334,7 @@
     </p:spTree>
     <p:extLst>
       <p:ext uri="{BB962C8B-B14F-4D97-AF65-F5344CB8AC3E}">
-        <p14:creationId xmlns:p14="http://schemas.microsoft.com/office/powerpoint/2010/main" val="1194359164"/>
+        <p14:creationId xmlns:p14="http://schemas.microsoft.com/office/powerpoint/2010/main" val="596064803"/>
       </p:ext>
     </p:extLst>
   </p:cSld>

</xml_diff>